<commit_message>
Added Yahboom board details
</commit_message>
<xml_diff>
--- a/embedded/RobotOperatingSystem/Yahboom_ROS2_board.pptx
+++ b/embedded/RobotOperatingSystem/Yahboom_ROS2_board.pptx
@@ -109,6 +109,11 @@
       </a:defRPr>
     </a:lvl9pPr>
   </p:defaultTextStyle>
+  <p:extLst>
+    <p:ext uri="{EFAFB233-063F-42B5-8137-9DF3F51BA10A}">
+      <p15:sldGuideLst xmlns:p15="http://schemas.microsoft.com/office/powerpoint/2012/main"/>
+    </p:ext>
+  </p:extLst>
 </p:presentation>
 </file>
 
@@ -243,7 +248,7 @@
           <a:p>
             <a:fld id="{44754554-1BE5-4E82-B131-2EEEA354167B}" type="datetimeFigureOut">
               <a:rPr lang="en-US" smtClean="0"/>
-              <a:t>3/11/2026</a:t>
+              <a:t>3/13/2026</a:t>
             </a:fld>
             <a:endParaRPr lang="en-US"/>
           </a:p>
@@ -413,7 +418,7 @@
           <a:p>
             <a:fld id="{44754554-1BE5-4E82-B131-2EEEA354167B}" type="datetimeFigureOut">
               <a:rPr lang="en-US" smtClean="0"/>
-              <a:t>3/11/2026</a:t>
+              <a:t>3/13/2026</a:t>
             </a:fld>
             <a:endParaRPr lang="en-US"/>
           </a:p>
@@ -593,7 +598,7 @@
           <a:p>
             <a:fld id="{44754554-1BE5-4E82-B131-2EEEA354167B}" type="datetimeFigureOut">
               <a:rPr lang="en-US" smtClean="0"/>
-              <a:t>3/11/2026</a:t>
+              <a:t>3/13/2026</a:t>
             </a:fld>
             <a:endParaRPr lang="en-US"/>
           </a:p>
@@ -763,7 +768,7 @@
           <a:p>
             <a:fld id="{44754554-1BE5-4E82-B131-2EEEA354167B}" type="datetimeFigureOut">
               <a:rPr lang="en-US" smtClean="0"/>
-              <a:t>3/11/2026</a:t>
+              <a:t>3/13/2026</a:t>
             </a:fld>
             <a:endParaRPr lang="en-US"/>
           </a:p>
@@ -1009,7 +1014,7 @@
           <a:p>
             <a:fld id="{44754554-1BE5-4E82-B131-2EEEA354167B}" type="datetimeFigureOut">
               <a:rPr lang="en-US" smtClean="0"/>
-              <a:t>3/11/2026</a:t>
+              <a:t>3/13/2026</a:t>
             </a:fld>
             <a:endParaRPr lang="en-US"/>
           </a:p>
@@ -1241,7 +1246,7 @@
           <a:p>
             <a:fld id="{44754554-1BE5-4E82-B131-2EEEA354167B}" type="datetimeFigureOut">
               <a:rPr lang="en-US" smtClean="0"/>
-              <a:t>3/11/2026</a:t>
+              <a:t>3/13/2026</a:t>
             </a:fld>
             <a:endParaRPr lang="en-US"/>
           </a:p>
@@ -1608,7 +1613,7 @@
           <a:p>
             <a:fld id="{44754554-1BE5-4E82-B131-2EEEA354167B}" type="datetimeFigureOut">
               <a:rPr lang="en-US" smtClean="0"/>
-              <a:t>3/11/2026</a:t>
+              <a:t>3/13/2026</a:t>
             </a:fld>
             <a:endParaRPr lang="en-US"/>
           </a:p>
@@ -1726,7 +1731,7 @@
           <a:p>
             <a:fld id="{44754554-1BE5-4E82-B131-2EEEA354167B}" type="datetimeFigureOut">
               <a:rPr lang="en-US" smtClean="0"/>
-              <a:t>3/11/2026</a:t>
+              <a:t>3/13/2026</a:t>
             </a:fld>
             <a:endParaRPr lang="en-US"/>
           </a:p>
@@ -1821,7 +1826,7 @@
           <a:p>
             <a:fld id="{44754554-1BE5-4E82-B131-2EEEA354167B}" type="datetimeFigureOut">
               <a:rPr lang="en-US" smtClean="0"/>
-              <a:t>3/11/2026</a:t>
+              <a:t>3/13/2026</a:t>
             </a:fld>
             <a:endParaRPr lang="en-US"/>
           </a:p>
@@ -2098,7 +2103,7 @@
           <a:p>
             <a:fld id="{44754554-1BE5-4E82-B131-2EEEA354167B}" type="datetimeFigureOut">
               <a:rPr lang="en-US" smtClean="0"/>
-              <a:t>3/11/2026</a:t>
+              <a:t>3/13/2026</a:t>
             </a:fld>
             <a:endParaRPr lang="en-US"/>
           </a:p>
@@ -2351,7 +2356,7 @@
           <a:p>
             <a:fld id="{44754554-1BE5-4E82-B131-2EEEA354167B}" type="datetimeFigureOut">
               <a:rPr lang="en-US" smtClean="0"/>
-              <a:t>3/11/2026</a:t>
+              <a:t>3/13/2026</a:t>
             </a:fld>
             <a:endParaRPr lang="en-US"/>
           </a:p>
@@ -2564,7 +2569,7 @@
           <a:p>
             <a:fld id="{44754554-1BE5-4E82-B131-2EEEA354167B}" type="datetimeFigureOut">
               <a:rPr lang="en-US" smtClean="0"/>
-              <a:t>3/11/2026</a:t>
+              <a:t>3/13/2026</a:t>
             </a:fld>
             <a:endParaRPr lang="en-US"/>
           </a:p>
@@ -3352,7 +3357,11 @@
           <a:bodyPr/>
           <a:lstStyle/>
           <a:p>
-            <a:endParaRPr lang="en-US"/>
+            <a:r>
+              <a:rPr lang="en-US" dirty="0" smtClean="0"/>
+              <a:t>Connecting from Linux / Pi</a:t>
+            </a:r>
+            <a:endParaRPr lang="en-US" dirty="0"/>
           </a:p>
         </p:txBody>
       </p:sp>
@@ -3368,10 +3377,383 @@
         </p:nvSpPr>
         <p:spPr/>
         <p:txBody>
-          <a:bodyPr/>
-          <a:lstStyle/>
-          <a:p>
-            <a:endParaRPr lang="en-US"/>
+          <a:bodyPr>
+            <a:normAutofit fontScale="55000" lnSpcReduction="20000"/>
+          </a:bodyPr>
+          <a:lstStyle/>
+          <a:p>
+            <a:r>
+              <a:rPr lang="en-US" dirty="0" err="1" smtClean="0"/>
+              <a:t>lsusb</a:t>
+            </a:r>
+            <a:r>
+              <a:rPr lang="en-US" dirty="0" smtClean="0"/>
+              <a:t> to verify it sees the ‘</a:t>
+            </a:r>
+            <a:r>
+              <a:rPr lang="en-US" dirty="0" err="1" smtClean="0"/>
+              <a:t>QinHeng</a:t>
+            </a:r>
+            <a:r>
+              <a:rPr lang="en-US" dirty="0" smtClean="0"/>
+              <a:t>’ device</a:t>
+            </a:r>
+          </a:p>
+          <a:p>
+            <a:r>
+              <a:rPr lang="en-US" dirty="0" smtClean="0"/>
+              <a:t>Make /</a:t>
+            </a:r>
+            <a:r>
+              <a:rPr lang="en-US" dirty="0" err="1" smtClean="0"/>
+              <a:t>etc</a:t>
+            </a:r>
+            <a:r>
+              <a:rPr lang="en-US" dirty="0" smtClean="0"/>
+              <a:t>/</a:t>
+            </a:r>
+            <a:r>
+              <a:rPr lang="en-US" dirty="0" err="1" smtClean="0"/>
+              <a:t>udev</a:t>
+            </a:r>
+            <a:r>
+              <a:rPr lang="en-US" dirty="0" smtClean="0"/>
+              <a:t>/</a:t>
+            </a:r>
+            <a:r>
+              <a:rPr lang="en-US" dirty="0" err="1" smtClean="0"/>
+              <a:t>rules.d</a:t>
+            </a:r>
+            <a:r>
+              <a:rPr lang="en-US" dirty="0" smtClean="0"/>
+              <a:t>/</a:t>
+            </a:r>
+            <a:r>
+              <a:rPr lang="en-US" dirty="0" err="1" smtClean="0"/>
+              <a:t>myserial.rules</a:t>
+            </a:r>
+            <a:r>
+              <a:rPr lang="en-US" dirty="0" smtClean="0"/>
+              <a:t> file with:</a:t>
+            </a:r>
+          </a:p>
+          <a:p>
+            <a:pPr lvl="1"/>
+            <a:r>
+              <a:rPr lang="en-US" sz="1400" dirty="0"/>
+              <a:t>KERNEL=="</a:t>
+            </a:r>
+            <a:r>
+              <a:rPr lang="en-US" sz="1400" dirty="0" err="1"/>
+              <a:t>ttyUSB</a:t>
+            </a:r>
+            <a:r>
+              <a:rPr lang="en-US" sz="1400" dirty="0"/>
+              <a:t>*", ATTRS{</a:t>
+            </a:r>
+            <a:r>
+              <a:rPr lang="en-US" sz="1400" dirty="0" err="1"/>
+              <a:t>idVendor</a:t>
+            </a:r>
+            <a:r>
+              <a:rPr lang="en-US" sz="1400" dirty="0"/>
+              <a:t>}=="1a86", ATTRS{</a:t>
+            </a:r>
+            <a:r>
+              <a:rPr lang="en-US" sz="1400" dirty="0" err="1"/>
+              <a:t>idProduct</a:t>
+            </a:r>
+            <a:r>
+              <a:rPr lang="en-US" sz="1400" dirty="0"/>
+              <a:t>}=="7523", MODE:="0777", SYMLINK+="</a:t>
+            </a:r>
+            <a:r>
+              <a:rPr lang="en-US" sz="1400" dirty="0" err="1" smtClean="0"/>
+              <a:t>myserial</a:t>
+            </a:r>
+            <a:r>
+              <a:rPr lang="en-US" sz="1400" dirty="0" smtClean="0"/>
+              <a:t>“</a:t>
+            </a:r>
+          </a:p>
+          <a:p>
+            <a:pPr lvl="1"/>
+            <a:r>
+              <a:rPr lang="en-US" dirty="0" smtClean="0"/>
+              <a:t>'/dev/</a:t>
+            </a:r>
+            <a:r>
+              <a:rPr lang="en-US" dirty="0" err="1" smtClean="0"/>
+              <a:t>myserial</a:t>
+            </a:r>
+            <a:r>
+              <a:rPr lang="en-US" dirty="0" smtClean="0"/>
+              <a:t>' is what the </a:t>
+            </a:r>
+            <a:r>
+              <a:rPr lang="en-US" dirty="0" err="1" smtClean="0"/>
+              <a:t>Rosmaster</a:t>
+            </a:r>
+            <a:r>
+              <a:rPr lang="en-US" dirty="0" smtClean="0"/>
+              <a:t> bot constructer uses to connect</a:t>
+            </a:r>
+          </a:p>
+          <a:p>
+            <a:r>
+              <a:rPr lang="en-US" dirty="0" smtClean="0"/>
+              <a:t>It should have these permissions: -</a:t>
+            </a:r>
+            <a:r>
+              <a:rPr lang="en-US" dirty="0" err="1" smtClean="0"/>
+              <a:t>rwxr</a:t>
+            </a:r>
+            <a:r>
+              <a:rPr lang="en-US" dirty="0" smtClean="0"/>
+              <a:t>-</a:t>
+            </a:r>
+            <a:r>
+              <a:rPr lang="en-US" dirty="0" err="1" smtClean="0"/>
+              <a:t>xr</a:t>
+            </a:r>
+            <a:r>
+              <a:rPr lang="en-US" dirty="0" smtClean="0"/>
+              <a:t>-x</a:t>
+            </a:r>
+          </a:p>
+          <a:p>
+            <a:r>
+              <a:rPr lang="en-US" dirty="0" smtClean="0"/>
+              <a:t>ls -l /dev/</a:t>
+            </a:r>
+            <a:r>
+              <a:rPr lang="en-US" dirty="0" err="1" smtClean="0"/>
+              <a:t>myserial</a:t>
+            </a:r>
+            <a:r>
+              <a:rPr lang="en-US" dirty="0" smtClean="0"/>
+              <a:t> should show the link: /dev/</a:t>
+            </a:r>
+            <a:r>
+              <a:rPr lang="en-US" dirty="0" err="1" smtClean="0"/>
+              <a:t>myserial</a:t>
+            </a:r>
+            <a:r>
+              <a:rPr lang="en-US" dirty="0" smtClean="0"/>
+              <a:t> </a:t>
+            </a:r>
+            <a:r>
+              <a:rPr lang="en-US" dirty="0" smtClean="0">
+                <a:sym typeface="Wingdings" panose="05000000000000000000" pitchFamily="2" charset="2"/>
+              </a:rPr>
+              <a:t> ttyUSB0</a:t>
+            </a:r>
+          </a:p>
+          <a:p>
+            <a:r>
+              <a:rPr lang="en-US" dirty="0" smtClean="0">
+                <a:sym typeface="Wingdings" panose="05000000000000000000" pitchFamily="2" charset="2"/>
+              </a:rPr>
+              <a:t>Install </a:t>
+            </a:r>
+            <a:r>
+              <a:rPr lang="en-US" dirty="0" err="1" smtClean="0">
+                <a:sym typeface="Wingdings" panose="05000000000000000000" pitchFamily="2" charset="2"/>
+              </a:rPr>
+              <a:t>Rosmaster</a:t>
+            </a:r>
+            <a:r>
+              <a:rPr lang="en-US" dirty="0" smtClean="0">
+                <a:sym typeface="Wingdings" panose="05000000000000000000" pitchFamily="2" charset="2"/>
+              </a:rPr>
+              <a:t> library from code from downloaded py_install.zip:</a:t>
+            </a:r>
+          </a:p>
+          <a:p>
+            <a:pPr lvl="1"/>
+            <a:r>
+              <a:rPr lang="en-US" dirty="0" smtClean="0">
+                <a:sym typeface="Wingdings" panose="05000000000000000000" pitchFamily="2" charset="2"/>
+              </a:rPr>
+              <a:t>cd </a:t>
+            </a:r>
+            <a:r>
+              <a:rPr lang="en-US" dirty="0" err="1" smtClean="0">
+                <a:sym typeface="Wingdings" panose="05000000000000000000" pitchFamily="2" charset="2"/>
+              </a:rPr>
+              <a:t>py_install</a:t>
+            </a:r>
+            <a:endParaRPr lang="en-US" dirty="0" smtClean="0">
+              <a:sym typeface="Wingdings" panose="05000000000000000000" pitchFamily="2" charset="2"/>
+            </a:endParaRPr>
+          </a:p>
+          <a:p>
+            <a:pPr lvl="1"/>
+            <a:r>
+              <a:rPr lang="en-US" dirty="0" err="1" smtClean="0">
+                <a:sym typeface="Wingdings" panose="05000000000000000000" pitchFamily="2" charset="2"/>
+              </a:rPr>
+              <a:t>sudo</a:t>
+            </a:r>
+            <a:r>
+              <a:rPr lang="en-US" dirty="0" smtClean="0">
+                <a:sym typeface="Wingdings" panose="05000000000000000000" pitchFamily="2" charset="2"/>
+              </a:rPr>
+              <a:t> python3 setup.py install</a:t>
+            </a:r>
+          </a:p>
+          <a:p>
+            <a:pPr lvl="1"/>
+            <a:r>
+              <a:rPr lang="en-US" dirty="0" smtClean="0">
+                <a:sym typeface="Wingdings" panose="05000000000000000000" pitchFamily="2" charset="2"/>
+              </a:rPr>
+              <a:t>*Might also have to re-install the serial library</a:t>
+            </a:r>
+          </a:p>
+          <a:p>
+            <a:pPr lvl="2"/>
+            <a:r>
+              <a:rPr lang="en-US" dirty="0" err="1" smtClean="0">
+                <a:sym typeface="Wingdings" panose="05000000000000000000" pitchFamily="2" charset="2"/>
+              </a:rPr>
+              <a:t>sudo</a:t>
+            </a:r>
+            <a:r>
+              <a:rPr lang="en-US" dirty="0" smtClean="0">
+                <a:sym typeface="Wingdings" panose="05000000000000000000" pitchFamily="2" charset="2"/>
+              </a:rPr>
+              <a:t> pip3 uninstall serial</a:t>
+            </a:r>
+          </a:p>
+          <a:p>
+            <a:pPr lvl="2"/>
+            <a:r>
+              <a:rPr lang="en-US" dirty="0" err="1" smtClean="0">
+                <a:sym typeface="Wingdings" panose="05000000000000000000" pitchFamily="2" charset="2"/>
+              </a:rPr>
+              <a:t>sudo</a:t>
+            </a:r>
+            <a:r>
+              <a:rPr lang="en-US" dirty="0" smtClean="0">
+                <a:sym typeface="Wingdings" panose="05000000000000000000" pitchFamily="2" charset="2"/>
+              </a:rPr>
+              <a:t> pip3 install </a:t>
+            </a:r>
+            <a:r>
+              <a:rPr lang="en-US" dirty="0" err="1" smtClean="0">
+                <a:sym typeface="Wingdings" panose="05000000000000000000" pitchFamily="2" charset="2"/>
+              </a:rPr>
+              <a:t>pyserial</a:t>
+            </a:r>
+            <a:endParaRPr lang="en-US" dirty="0" smtClean="0">
+              <a:sym typeface="Wingdings" panose="05000000000000000000" pitchFamily="2" charset="2"/>
+            </a:endParaRPr>
+          </a:p>
+          <a:p>
+            <a:r>
+              <a:rPr lang="en-US" dirty="0" smtClean="0">
+                <a:sym typeface="Wingdings" panose="05000000000000000000" pitchFamily="2" charset="2"/>
+              </a:rPr>
+              <a:t>Then you can execute in python:</a:t>
+            </a:r>
+          </a:p>
+          <a:p>
+            <a:pPr lvl="1"/>
+            <a:r>
+              <a:rPr lang="en-US" dirty="0" smtClean="0">
+                <a:sym typeface="Wingdings" panose="05000000000000000000" pitchFamily="2" charset="2"/>
+              </a:rPr>
+              <a:t>from </a:t>
+            </a:r>
+            <a:r>
+              <a:rPr lang="en-US" dirty="0" err="1" smtClean="0">
+                <a:sym typeface="Wingdings" panose="05000000000000000000" pitchFamily="2" charset="2"/>
+              </a:rPr>
+              <a:t>Rosmaster_Lib</a:t>
+            </a:r>
+            <a:r>
+              <a:rPr lang="en-US" dirty="0" smtClean="0">
+                <a:sym typeface="Wingdings" panose="05000000000000000000" pitchFamily="2" charset="2"/>
+              </a:rPr>
+              <a:t> import </a:t>
+            </a:r>
+            <a:r>
+              <a:rPr lang="en-US" dirty="0" err="1" smtClean="0">
+                <a:sym typeface="Wingdings" panose="05000000000000000000" pitchFamily="2" charset="2"/>
+              </a:rPr>
+              <a:t>Rosmaster</a:t>
+            </a:r>
+            <a:endParaRPr lang="en-US" dirty="0" smtClean="0">
+              <a:sym typeface="Wingdings" panose="05000000000000000000" pitchFamily="2" charset="2"/>
+            </a:endParaRPr>
+          </a:p>
+          <a:p>
+            <a:pPr lvl="1"/>
+            <a:r>
+              <a:rPr lang="en-US" dirty="0" smtClean="0">
+                <a:sym typeface="Wingdings" panose="05000000000000000000" pitchFamily="2" charset="2"/>
+              </a:rPr>
+              <a:t>bot = </a:t>
+            </a:r>
+            <a:r>
+              <a:rPr lang="en-US" dirty="0" err="1" smtClean="0">
+                <a:sym typeface="Wingdings" panose="05000000000000000000" pitchFamily="2" charset="2"/>
+              </a:rPr>
+              <a:t>Rosmaster</a:t>
+            </a:r>
+            <a:r>
+              <a:rPr lang="en-US" dirty="0" smtClean="0">
+                <a:sym typeface="Wingdings" panose="05000000000000000000" pitchFamily="2" charset="2"/>
+              </a:rPr>
+              <a:t>()</a:t>
+            </a:r>
+          </a:p>
+          <a:p>
+            <a:pPr lvl="1"/>
+            <a:r>
+              <a:rPr lang="en-US" dirty="0" err="1" smtClean="0">
+                <a:sym typeface="Wingdings" panose="05000000000000000000" pitchFamily="2" charset="2"/>
+              </a:rPr>
+              <a:t>bot.set_motor</a:t>
+            </a:r>
+            <a:r>
+              <a:rPr lang="en-US" dirty="0" smtClean="0">
+                <a:sym typeface="Wingdings" panose="05000000000000000000" pitchFamily="2" charset="2"/>
+              </a:rPr>
+              <a:t>(50,0,0,0)</a:t>
+            </a:r>
+          </a:p>
+          <a:p>
+            <a:pPr lvl="1"/>
+            <a:r>
+              <a:rPr lang="en-US" dirty="0" err="1">
+                <a:sym typeface="Wingdings" panose="05000000000000000000" pitchFamily="2" charset="2"/>
+              </a:rPr>
+              <a:t>b</a:t>
+            </a:r>
+            <a:r>
+              <a:rPr lang="en-US" dirty="0" err="1" smtClean="0">
+                <a:sym typeface="Wingdings" panose="05000000000000000000" pitchFamily="2" charset="2"/>
+              </a:rPr>
+              <a:t>ot.set_beep</a:t>
+            </a:r>
+            <a:r>
+              <a:rPr lang="en-US" dirty="0" smtClean="0">
+                <a:sym typeface="Wingdings" panose="05000000000000000000" pitchFamily="2" charset="2"/>
+              </a:rPr>
+              <a:t>(100)</a:t>
+            </a:r>
+            <a:endParaRPr lang="en-US" dirty="0" smtClean="0">
+              <a:sym typeface="Wingdings" panose="05000000000000000000" pitchFamily="2" charset="2"/>
+            </a:endParaRPr>
+          </a:p>
+          <a:p>
+            <a:r>
+              <a:rPr lang="en-US" dirty="0" smtClean="0"/>
+              <a:t>*Works on Pi 5, but not on Jetson Orin Nano</a:t>
+            </a:r>
+            <a:endParaRPr lang="en-US" dirty="0"/>
           </a:p>
         </p:txBody>
       </p:sp>

</xml_diff>

<commit_message>
Updated Yahboom board ROS2
</commit_message>
<xml_diff>
--- a/embedded/RobotOperatingSystem/Yahboom_ROS2_board.pptx
+++ b/embedded/RobotOperatingSystem/Yahboom_ROS2_board.pptx
@@ -11,6 +11,12 @@
     <p:sldId id="259" r:id="rId5"/>
     <p:sldId id="260" r:id="rId6"/>
     <p:sldId id="261" r:id="rId7"/>
+    <p:sldId id="262" r:id="rId8"/>
+    <p:sldId id="263" r:id="rId9"/>
+    <p:sldId id="264" r:id="rId10"/>
+    <p:sldId id="266" r:id="rId11"/>
+    <p:sldId id="267" r:id="rId12"/>
+    <p:sldId id="265" r:id="rId13"/>
   </p:sldIdLst>
   <p:sldSz cx="12192000" cy="6858000"/>
   <p:notesSz cx="6858000" cy="9144000"/>
@@ -248,7 +254,7 @@
           <a:p>
             <a:fld id="{44754554-1BE5-4E82-B131-2EEEA354167B}" type="datetimeFigureOut">
               <a:rPr lang="en-US" smtClean="0"/>
-              <a:t>3/13/2026</a:t>
+              <a:t>3/16/2026</a:t>
             </a:fld>
             <a:endParaRPr lang="en-US"/>
           </a:p>
@@ -418,7 +424,7 @@
           <a:p>
             <a:fld id="{44754554-1BE5-4E82-B131-2EEEA354167B}" type="datetimeFigureOut">
               <a:rPr lang="en-US" smtClean="0"/>
-              <a:t>3/13/2026</a:t>
+              <a:t>3/16/2026</a:t>
             </a:fld>
             <a:endParaRPr lang="en-US"/>
           </a:p>
@@ -598,7 +604,7 @@
           <a:p>
             <a:fld id="{44754554-1BE5-4E82-B131-2EEEA354167B}" type="datetimeFigureOut">
               <a:rPr lang="en-US" smtClean="0"/>
-              <a:t>3/13/2026</a:t>
+              <a:t>3/16/2026</a:t>
             </a:fld>
             <a:endParaRPr lang="en-US"/>
           </a:p>
@@ -768,7 +774,7 @@
           <a:p>
             <a:fld id="{44754554-1BE5-4E82-B131-2EEEA354167B}" type="datetimeFigureOut">
               <a:rPr lang="en-US" smtClean="0"/>
-              <a:t>3/13/2026</a:t>
+              <a:t>3/16/2026</a:t>
             </a:fld>
             <a:endParaRPr lang="en-US"/>
           </a:p>
@@ -1014,7 +1020,7 @@
           <a:p>
             <a:fld id="{44754554-1BE5-4E82-B131-2EEEA354167B}" type="datetimeFigureOut">
               <a:rPr lang="en-US" smtClean="0"/>
-              <a:t>3/13/2026</a:t>
+              <a:t>3/16/2026</a:t>
             </a:fld>
             <a:endParaRPr lang="en-US"/>
           </a:p>
@@ -1246,7 +1252,7 @@
           <a:p>
             <a:fld id="{44754554-1BE5-4E82-B131-2EEEA354167B}" type="datetimeFigureOut">
               <a:rPr lang="en-US" smtClean="0"/>
-              <a:t>3/13/2026</a:t>
+              <a:t>3/16/2026</a:t>
             </a:fld>
             <a:endParaRPr lang="en-US"/>
           </a:p>
@@ -1613,7 +1619,7 @@
           <a:p>
             <a:fld id="{44754554-1BE5-4E82-B131-2EEEA354167B}" type="datetimeFigureOut">
               <a:rPr lang="en-US" smtClean="0"/>
-              <a:t>3/13/2026</a:t>
+              <a:t>3/16/2026</a:t>
             </a:fld>
             <a:endParaRPr lang="en-US"/>
           </a:p>
@@ -1731,7 +1737,7 @@
           <a:p>
             <a:fld id="{44754554-1BE5-4E82-B131-2EEEA354167B}" type="datetimeFigureOut">
               <a:rPr lang="en-US" smtClean="0"/>
-              <a:t>3/13/2026</a:t>
+              <a:t>3/16/2026</a:t>
             </a:fld>
             <a:endParaRPr lang="en-US"/>
           </a:p>
@@ -1826,7 +1832,7 @@
           <a:p>
             <a:fld id="{44754554-1BE5-4E82-B131-2EEEA354167B}" type="datetimeFigureOut">
               <a:rPr lang="en-US" smtClean="0"/>
-              <a:t>3/13/2026</a:t>
+              <a:t>3/16/2026</a:t>
             </a:fld>
             <a:endParaRPr lang="en-US"/>
           </a:p>
@@ -2103,7 +2109,7 @@
           <a:p>
             <a:fld id="{44754554-1BE5-4E82-B131-2EEEA354167B}" type="datetimeFigureOut">
               <a:rPr lang="en-US" smtClean="0"/>
-              <a:t>3/13/2026</a:t>
+              <a:t>3/16/2026</a:t>
             </a:fld>
             <a:endParaRPr lang="en-US"/>
           </a:p>
@@ -2356,7 +2362,7 @@
           <a:p>
             <a:fld id="{44754554-1BE5-4E82-B131-2EEEA354167B}" type="datetimeFigureOut">
               <a:rPr lang="en-US" smtClean="0"/>
-              <a:t>3/13/2026</a:t>
+              <a:t>3/16/2026</a:t>
             </a:fld>
             <a:endParaRPr lang="en-US"/>
           </a:p>
@@ -2569,7 +2575,7 @@
           <a:p>
             <a:fld id="{44754554-1BE5-4E82-B131-2EEEA354167B}" type="datetimeFigureOut">
               <a:rPr lang="en-US" smtClean="0"/>
-              <a:t>3/13/2026</a:t>
+              <a:t>3/16/2026</a:t>
             </a:fld>
             <a:endParaRPr lang="en-US"/>
           </a:p>
@@ -3033,6 +3039,904 @@
 </p:sld>
 </file>
 
+<file path=ppt/slides/slide10.xml><?xml version="1.0" encoding="utf-8"?>
+<p:sld xmlns:a="http://schemas.openxmlformats.org/drawingml/2006/main" xmlns:r="http://schemas.openxmlformats.org/officeDocument/2006/relationships" xmlns:p="http://schemas.openxmlformats.org/presentationml/2006/main">
+  <p:cSld>
+    <p:spTree>
+      <p:nvGrpSpPr>
+        <p:cNvPr id="1" name=""/>
+        <p:cNvGrpSpPr/>
+        <p:nvPr/>
+      </p:nvGrpSpPr>
+      <p:grpSpPr>
+        <a:xfrm>
+          <a:off x="0" y="0"/>
+          <a:ext cx="0" cy="0"/>
+          <a:chOff x="0" y="0"/>
+          <a:chExt cx="0" cy="0"/>
+        </a:xfrm>
+      </p:grpSpPr>
+      <p:sp>
+        <p:nvSpPr>
+          <p:cNvPr id="2" name="Title 1"/>
+          <p:cNvSpPr>
+            <a:spLocks noGrp="1"/>
+          </p:cNvSpPr>
+          <p:nvPr>
+            <p:ph type="title"/>
+          </p:nvPr>
+        </p:nvSpPr>
+        <p:spPr/>
+        <p:txBody>
+          <a:bodyPr>
+            <a:normAutofit/>
+          </a:bodyPr>
+          <a:lstStyle/>
+          <a:p>
+            <a:r>
+              <a:rPr lang="en-US" dirty="0" smtClean="0"/>
+              <a:t>Creating new ROS2 </a:t>
+            </a:r>
+            <a:r>
+              <a:rPr lang="en-US" dirty="0"/>
+              <a:t>workspace</a:t>
+            </a:r>
+            <a:br>
+              <a:rPr lang="en-US" dirty="0"/>
+            </a:br>
+            <a:r>
+              <a:rPr lang="en-US" sz="1400" dirty="0"/>
+              <a:t>https://docs.ros.org/en/humble/Tutorials/Beginner-Client-Libraries/Creating-A-Workspace/Creating-A-Workspace.html</a:t>
+            </a:r>
+            <a:endParaRPr lang="en-US" dirty="0"/>
+          </a:p>
+        </p:txBody>
+      </p:sp>
+      <p:sp>
+        <p:nvSpPr>
+          <p:cNvPr id="3" name="Content Placeholder 2"/>
+          <p:cNvSpPr>
+            <a:spLocks noGrp="1"/>
+          </p:cNvSpPr>
+          <p:nvPr>
+            <p:ph idx="1"/>
+          </p:nvPr>
+        </p:nvSpPr>
+        <p:spPr>
+          <a:xfrm>
+            <a:off x="838200" y="1825624"/>
+            <a:ext cx="10515600" cy="4816715"/>
+          </a:xfrm>
+        </p:spPr>
+        <p:txBody>
+          <a:bodyPr>
+            <a:normAutofit fontScale="47500" lnSpcReduction="20000"/>
+          </a:bodyPr>
+          <a:lstStyle/>
+          <a:p>
+            <a:r>
+              <a:rPr lang="en-US" dirty="0"/>
+              <a:t>source /</a:t>
+            </a:r>
+            <a:r>
+              <a:rPr lang="en-US" dirty="0" smtClean="0"/>
+              <a:t>opt/</a:t>
+            </a:r>
+            <a:r>
+              <a:rPr lang="en-US" dirty="0" err="1" smtClean="0"/>
+              <a:t>ros</a:t>
+            </a:r>
+            <a:r>
+              <a:rPr lang="en-US" dirty="0" smtClean="0"/>
+              <a:t>/humble/</a:t>
+            </a:r>
+            <a:r>
+              <a:rPr lang="en-US" dirty="0" err="1" smtClean="0"/>
+              <a:t>setup.bash</a:t>
+            </a:r>
+            <a:endParaRPr lang="en-US" dirty="0" smtClean="0"/>
+          </a:p>
+          <a:p>
+            <a:r>
+              <a:rPr lang="en-US" dirty="0" err="1"/>
+              <a:t>mkdir</a:t>
+            </a:r>
+            <a:r>
+              <a:rPr lang="en-US" dirty="0"/>
+              <a:t> -p ~/</a:t>
+            </a:r>
+            <a:r>
+              <a:rPr lang="en-US" dirty="0" smtClean="0"/>
+              <a:t>ros2_ws/</a:t>
+            </a:r>
+            <a:r>
+              <a:rPr lang="en-US" dirty="0" err="1" smtClean="0"/>
+              <a:t>src</a:t>
+            </a:r>
+            <a:endParaRPr lang="en-US" dirty="0" smtClean="0"/>
+          </a:p>
+          <a:p>
+            <a:r>
+              <a:rPr lang="en-US" dirty="0"/>
+              <a:t>cd ~/</a:t>
+            </a:r>
+            <a:r>
+              <a:rPr lang="en-US" dirty="0" smtClean="0"/>
+              <a:t>ros2_ws/</a:t>
+            </a:r>
+            <a:r>
+              <a:rPr lang="en-US" dirty="0" err="1" smtClean="0"/>
+              <a:t>src</a:t>
+            </a:r>
+            <a:endParaRPr lang="en-US" dirty="0" smtClean="0"/>
+          </a:p>
+          <a:p>
+            <a:r>
+              <a:rPr lang="en-US" dirty="0" smtClean="0"/>
+              <a:t># Clone your repo into </a:t>
+            </a:r>
+            <a:r>
+              <a:rPr lang="en-US" dirty="0" err="1" smtClean="0"/>
+              <a:t>src</a:t>
+            </a:r>
+            <a:r>
+              <a:rPr lang="en-US" dirty="0" smtClean="0"/>
+              <a:t> (this is example that includes the turtle </a:t>
+            </a:r>
+            <a:r>
+              <a:rPr lang="en-US" dirty="0" err="1" smtClean="0"/>
+              <a:t>sim</a:t>
+            </a:r>
+            <a:r>
+              <a:rPr lang="en-US" dirty="0" smtClean="0"/>
+              <a:t>).</a:t>
+            </a:r>
+          </a:p>
+          <a:p>
+            <a:r>
+              <a:rPr lang="en-US" dirty="0" err="1"/>
+              <a:t>git</a:t>
+            </a:r>
+            <a:r>
+              <a:rPr lang="en-US" dirty="0"/>
+              <a:t> clone https://github.com/ros/ros_tutorials.git -b </a:t>
+            </a:r>
+            <a:r>
+              <a:rPr lang="en-US" dirty="0" smtClean="0"/>
+              <a:t>humble</a:t>
+            </a:r>
+          </a:p>
+          <a:p>
+            <a:r>
+              <a:rPr lang="en-US" dirty="0" smtClean="0"/>
+              <a:t># Go back to base directory.</a:t>
+            </a:r>
+          </a:p>
+          <a:p>
+            <a:r>
+              <a:rPr lang="en-US" dirty="0" smtClean="0"/>
+              <a:t>cd ..</a:t>
+            </a:r>
+          </a:p>
+          <a:p>
+            <a:r>
+              <a:rPr lang="en-US" dirty="0" smtClean="0"/>
+              <a:t># Need to initialize (just once).</a:t>
+            </a:r>
+          </a:p>
+          <a:p>
+            <a:r>
+              <a:rPr lang="en-US" dirty="0" err="1" smtClean="0"/>
+              <a:t>sudo</a:t>
+            </a:r>
+            <a:r>
+              <a:rPr lang="en-US" dirty="0" smtClean="0"/>
+              <a:t> </a:t>
+            </a:r>
+            <a:r>
+              <a:rPr lang="en-US" dirty="0" err="1" smtClean="0"/>
+              <a:t>rosdep</a:t>
+            </a:r>
+            <a:r>
+              <a:rPr lang="en-US" dirty="0" smtClean="0"/>
+              <a:t> </a:t>
+            </a:r>
+            <a:r>
+              <a:rPr lang="en-US" dirty="0" err="1" smtClean="0"/>
+              <a:t>init</a:t>
+            </a:r>
+            <a:endParaRPr lang="en-US" dirty="0" smtClean="0"/>
+          </a:p>
+          <a:p>
+            <a:r>
+              <a:rPr lang="en-US" dirty="0" err="1"/>
+              <a:t>r</a:t>
+            </a:r>
+            <a:r>
+              <a:rPr lang="en-US" dirty="0" err="1" smtClean="0"/>
+              <a:t>osdep</a:t>
+            </a:r>
+            <a:r>
+              <a:rPr lang="en-US" dirty="0" smtClean="0"/>
+              <a:t> update</a:t>
+            </a:r>
+          </a:p>
+          <a:p>
+            <a:r>
+              <a:rPr lang="en-US" dirty="0" err="1"/>
+              <a:t>rosdep</a:t>
+            </a:r>
+            <a:r>
+              <a:rPr lang="en-US" dirty="0"/>
+              <a:t> install -</a:t>
+            </a:r>
+            <a:r>
+              <a:rPr lang="en-US" dirty="0" err="1"/>
+              <a:t>i</a:t>
+            </a:r>
+            <a:r>
+              <a:rPr lang="en-US" dirty="0"/>
+              <a:t> --from-path </a:t>
+            </a:r>
+            <a:r>
+              <a:rPr lang="en-US" dirty="0" err="1"/>
+              <a:t>src</a:t>
+            </a:r>
+            <a:r>
+              <a:rPr lang="en-US" dirty="0"/>
+              <a:t> --</a:t>
+            </a:r>
+            <a:r>
+              <a:rPr lang="en-US" dirty="0" err="1"/>
+              <a:t>rosdistro</a:t>
+            </a:r>
+            <a:r>
+              <a:rPr lang="en-US" dirty="0"/>
+              <a:t> </a:t>
+            </a:r>
+            <a:r>
+              <a:rPr lang="en-US" dirty="0" smtClean="0"/>
+              <a:t>humble</a:t>
+            </a:r>
+          </a:p>
+          <a:p>
+            <a:r>
+              <a:rPr lang="en-US" dirty="0" err="1" smtClean="0"/>
+              <a:t>colcon</a:t>
+            </a:r>
+            <a:r>
+              <a:rPr lang="en-US" dirty="0" smtClean="0"/>
+              <a:t> build</a:t>
+            </a:r>
+          </a:p>
+          <a:p>
+            <a:r>
+              <a:rPr lang="en-US" dirty="0" smtClean="0"/>
+              <a:t># In a NEW terminal source the original and the new build:</a:t>
+            </a:r>
+          </a:p>
+          <a:p>
+            <a:r>
+              <a:rPr lang="en-US" dirty="0"/>
+              <a:t>source /</a:t>
+            </a:r>
+            <a:r>
+              <a:rPr lang="en-US" dirty="0" smtClean="0"/>
+              <a:t>opt/</a:t>
+            </a:r>
+            <a:r>
+              <a:rPr lang="en-US" dirty="0" err="1" smtClean="0"/>
+              <a:t>ros</a:t>
+            </a:r>
+            <a:r>
+              <a:rPr lang="en-US" dirty="0" smtClean="0"/>
+              <a:t>/humble/</a:t>
+            </a:r>
+            <a:r>
+              <a:rPr lang="en-US" dirty="0" err="1" smtClean="0"/>
+              <a:t>setup.bash</a:t>
+            </a:r>
+            <a:endParaRPr lang="en-US" dirty="0" smtClean="0"/>
+          </a:p>
+          <a:p>
+            <a:r>
+              <a:rPr lang="en-US" dirty="0" smtClean="0"/>
+              <a:t>cd ~/ros2_ws</a:t>
+            </a:r>
+          </a:p>
+          <a:p>
+            <a:r>
+              <a:rPr lang="en-US" dirty="0"/>
+              <a:t>source </a:t>
+            </a:r>
+            <a:r>
+              <a:rPr lang="en-US" dirty="0" smtClean="0"/>
+              <a:t>install/</a:t>
+            </a:r>
+            <a:r>
+              <a:rPr lang="en-US" dirty="0" err="1" smtClean="0"/>
+              <a:t>local_setup.bash</a:t>
+            </a:r>
+            <a:endParaRPr lang="en-US" dirty="0" smtClean="0"/>
+          </a:p>
+          <a:p>
+            <a:r>
+              <a:rPr lang="en-US" dirty="0"/>
+              <a:t>ros2 run </a:t>
+            </a:r>
+            <a:r>
+              <a:rPr lang="en-US" dirty="0" err="1"/>
+              <a:t>turtlesim</a:t>
+            </a:r>
+            <a:r>
+              <a:rPr lang="en-US" dirty="0"/>
+              <a:t> </a:t>
+            </a:r>
+            <a:r>
+              <a:rPr lang="en-US" dirty="0" err="1"/>
+              <a:t>turtlesim_node</a:t>
+            </a:r>
+            <a:endParaRPr lang="en-US" dirty="0" smtClean="0"/>
+          </a:p>
+          <a:p>
+            <a:r>
+              <a:rPr lang="en-US" dirty="0" smtClean="0"/>
+              <a:t># If you change the source, need to do the </a:t>
+            </a:r>
+            <a:r>
+              <a:rPr lang="en-US" dirty="0" err="1" smtClean="0"/>
+              <a:t>colcon</a:t>
+            </a:r>
+            <a:r>
+              <a:rPr lang="en-US" dirty="0" smtClean="0"/>
+              <a:t> build again and source it again!</a:t>
+            </a:r>
+          </a:p>
+          <a:p>
+            <a:endParaRPr lang="en-US" dirty="0" smtClean="0"/>
+          </a:p>
+          <a:p>
+            <a:endParaRPr lang="en-US" dirty="0"/>
+          </a:p>
+        </p:txBody>
+      </p:sp>
+    </p:spTree>
+    <p:extLst>
+      <p:ext uri="{BB962C8B-B14F-4D97-AF65-F5344CB8AC3E}">
+        <p14:creationId xmlns:p14="http://schemas.microsoft.com/office/powerpoint/2010/main" val="4194587478"/>
+      </p:ext>
+    </p:extLst>
+  </p:cSld>
+  <p:clrMapOvr>
+    <a:masterClrMapping/>
+  </p:clrMapOvr>
+</p:sld>
+</file>
+
+<file path=ppt/slides/slide11.xml><?xml version="1.0" encoding="utf-8"?>
+<p:sld xmlns:a="http://schemas.openxmlformats.org/drawingml/2006/main" xmlns:r="http://schemas.openxmlformats.org/officeDocument/2006/relationships" xmlns:p="http://schemas.openxmlformats.org/presentationml/2006/main">
+  <p:cSld>
+    <p:spTree>
+      <p:nvGrpSpPr>
+        <p:cNvPr id="1" name=""/>
+        <p:cNvGrpSpPr/>
+        <p:nvPr/>
+      </p:nvGrpSpPr>
+      <p:grpSpPr>
+        <a:xfrm>
+          <a:off x="0" y="0"/>
+          <a:ext cx="0" cy="0"/>
+          <a:chOff x="0" y="0"/>
+          <a:chExt cx="0" cy="0"/>
+        </a:xfrm>
+      </p:grpSpPr>
+      <p:sp>
+        <p:nvSpPr>
+          <p:cNvPr id="2" name="Title 1"/>
+          <p:cNvSpPr>
+            <a:spLocks noGrp="1"/>
+          </p:cNvSpPr>
+          <p:nvPr>
+            <p:ph type="title"/>
+          </p:nvPr>
+        </p:nvSpPr>
+        <p:spPr/>
+        <p:txBody>
+          <a:bodyPr/>
+          <a:lstStyle/>
+          <a:p>
+            <a:r>
+              <a:rPr lang="en-US" dirty="0" smtClean="0"/>
+              <a:t>Change tutorial </a:t>
+            </a:r>
+            <a:r>
+              <a:rPr lang="en-US" dirty="0" err="1" smtClean="0"/>
+              <a:t>turtlesim</a:t>
+            </a:r>
+            <a:r>
+              <a:rPr lang="en-US" dirty="0" smtClean="0"/>
+              <a:t> to do what you want?</a:t>
+            </a:r>
+            <a:endParaRPr lang="en-US" dirty="0"/>
+          </a:p>
+        </p:txBody>
+      </p:sp>
+      <p:sp>
+        <p:nvSpPr>
+          <p:cNvPr id="3" name="Content Placeholder 2"/>
+          <p:cNvSpPr>
+            <a:spLocks noGrp="1"/>
+          </p:cNvSpPr>
+          <p:nvPr>
+            <p:ph idx="1"/>
+          </p:nvPr>
+        </p:nvSpPr>
+        <p:spPr/>
+        <p:txBody>
+          <a:bodyPr/>
+          <a:lstStyle/>
+          <a:p>
+            <a:r>
+              <a:rPr lang="en-US" dirty="0" smtClean="0"/>
+              <a:t>Example modify: change ~/ros2_ws/</a:t>
+            </a:r>
+            <a:r>
+              <a:rPr lang="en-US" dirty="0" err="1" smtClean="0"/>
+              <a:t>src</a:t>
+            </a:r>
+            <a:r>
+              <a:rPr lang="en-US" dirty="0" smtClean="0"/>
+              <a:t>/</a:t>
+            </a:r>
+            <a:r>
+              <a:rPr lang="en-US" dirty="0" err="1" smtClean="0"/>
+              <a:t>ros_tutorials</a:t>
+            </a:r>
+            <a:r>
+              <a:rPr lang="en-US" dirty="0" smtClean="0"/>
+              <a:t>/</a:t>
+            </a:r>
+            <a:r>
+              <a:rPr lang="en-US" dirty="0" err="1" smtClean="0"/>
+              <a:t>turtlesim</a:t>
+            </a:r>
+            <a:r>
+              <a:rPr lang="en-US" dirty="0" smtClean="0"/>
+              <a:t>/</a:t>
+            </a:r>
+            <a:r>
+              <a:rPr lang="en-US" dirty="0" err="1" smtClean="0"/>
+              <a:t>src</a:t>
+            </a:r>
+            <a:r>
+              <a:rPr lang="en-US" dirty="0" smtClean="0"/>
+              <a:t>/turtle_frame.cpp</a:t>
+            </a:r>
+          </a:p>
+          <a:p>
+            <a:pPr lvl="1"/>
+            <a:r>
+              <a:rPr lang="en-US" dirty="0" smtClean="0"/>
+              <a:t>Change </a:t>
+            </a:r>
+            <a:r>
+              <a:rPr lang="en-US" dirty="0" err="1" smtClean="0"/>
+              <a:t>setWindowTitle</a:t>
+            </a:r>
+            <a:r>
+              <a:rPr lang="en-US" dirty="0" smtClean="0"/>
+              <a:t> to “</a:t>
+            </a:r>
+            <a:r>
+              <a:rPr lang="en-US" dirty="0" err="1" smtClean="0"/>
+              <a:t>JoesTurtleSim</a:t>
+            </a:r>
+            <a:r>
+              <a:rPr lang="en-US" dirty="0" smtClean="0"/>
+              <a:t>”</a:t>
+            </a:r>
+          </a:p>
+          <a:p>
+            <a:pPr lvl="1"/>
+            <a:r>
+              <a:rPr lang="en-US" dirty="0" smtClean="0"/>
+              <a:t>cd ~/ros2_ws</a:t>
+            </a:r>
+          </a:p>
+          <a:p>
+            <a:pPr lvl="1"/>
+            <a:r>
+              <a:rPr lang="en-US" dirty="0" err="1" smtClean="0"/>
+              <a:t>colcon</a:t>
+            </a:r>
+            <a:r>
+              <a:rPr lang="en-US" dirty="0" smtClean="0"/>
+              <a:t> build</a:t>
+            </a:r>
+          </a:p>
+          <a:p>
+            <a:pPr lvl="1"/>
+            <a:r>
+              <a:rPr lang="en-US" dirty="0" smtClean="0"/>
+              <a:t>source &amp; run again (see previous)</a:t>
+            </a:r>
+          </a:p>
+          <a:p>
+            <a:pPr lvl="1"/>
+            <a:endParaRPr lang="en-US" dirty="0"/>
+          </a:p>
+        </p:txBody>
+      </p:sp>
+    </p:spTree>
+    <p:extLst>
+      <p:ext uri="{BB962C8B-B14F-4D97-AF65-F5344CB8AC3E}">
+        <p14:creationId xmlns:p14="http://schemas.microsoft.com/office/powerpoint/2010/main" val="580269737"/>
+      </p:ext>
+    </p:extLst>
+  </p:cSld>
+  <p:clrMapOvr>
+    <a:masterClrMapping/>
+  </p:clrMapOvr>
+</p:sld>
+</file>
+
+<file path=ppt/slides/slide12.xml><?xml version="1.0" encoding="utf-8"?>
+<p:sld xmlns:a="http://schemas.openxmlformats.org/drawingml/2006/main" xmlns:r="http://schemas.openxmlformats.org/officeDocument/2006/relationships" xmlns:p="http://schemas.openxmlformats.org/presentationml/2006/main">
+  <p:cSld>
+    <p:spTree>
+      <p:nvGrpSpPr>
+        <p:cNvPr id="1" name=""/>
+        <p:cNvGrpSpPr/>
+        <p:nvPr/>
+      </p:nvGrpSpPr>
+      <p:grpSpPr>
+        <a:xfrm>
+          <a:off x="0" y="0"/>
+          <a:ext cx="0" cy="0"/>
+          <a:chOff x="0" y="0"/>
+          <a:chExt cx="0" cy="0"/>
+        </a:xfrm>
+      </p:grpSpPr>
+      <p:sp>
+        <p:nvSpPr>
+          <p:cNvPr id="2" name="Title 1"/>
+          <p:cNvSpPr>
+            <a:spLocks noGrp="1"/>
+          </p:cNvSpPr>
+          <p:nvPr>
+            <p:ph type="title"/>
+          </p:nvPr>
+        </p:nvSpPr>
+        <p:spPr/>
+        <p:txBody>
+          <a:bodyPr/>
+          <a:lstStyle/>
+          <a:p>
+            <a:r>
+              <a:rPr lang="en-US" dirty="0" smtClean="0"/>
+              <a:t>Running with the real </a:t>
+            </a:r>
+            <a:r>
+              <a:rPr lang="en-US" dirty="0" err="1" smtClean="0"/>
+              <a:t>RosMaster</a:t>
+            </a:r>
+            <a:r>
+              <a:rPr lang="en-US" dirty="0" smtClean="0"/>
+              <a:t> board</a:t>
+            </a:r>
+            <a:br>
+              <a:rPr lang="en-US" dirty="0" smtClean="0"/>
+            </a:br>
+            <a:r>
+              <a:rPr lang="en-US" dirty="0" smtClean="0"/>
+              <a:t>taken from downloaded VM ~/workspace</a:t>
+            </a:r>
+            <a:endParaRPr lang="en-US" dirty="0"/>
+          </a:p>
+        </p:txBody>
+      </p:sp>
+      <p:sp>
+        <p:nvSpPr>
+          <p:cNvPr id="3" name="Content Placeholder 2"/>
+          <p:cNvSpPr>
+            <a:spLocks noGrp="1"/>
+          </p:cNvSpPr>
+          <p:nvPr>
+            <p:ph idx="1"/>
+          </p:nvPr>
+        </p:nvSpPr>
+        <p:spPr/>
+        <p:txBody>
+          <a:bodyPr>
+            <a:normAutofit fontScale="55000" lnSpcReduction="20000"/>
+          </a:bodyPr>
+          <a:lstStyle/>
+          <a:p>
+            <a:pPr lvl="1"/>
+            <a:endParaRPr lang="en-US" dirty="0"/>
+          </a:p>
+          <a:p>
+            <a:r>
+              <a:rPr lang="en-US" dirty="0" smtClean="0"/>
+              <a:t>Make sure USB connected: </a:t>
+            </a:r>
+            <a:r>
+              <a:rPr lang="en-US" dirty="0" err="1" smtClean="0"/>
+              <a:t>ls</a:t>
+            </a:r>
+            <a:r>
+              <a:rPr lang="en-US" dirty="0" smtClean="0"/>
+              <a:t> -l /</a:t>
+            </a:r>
+            <a:r>
+              <a:rPr lang="en-US" dirty="0" err="1" smtClean="0"/>
+              <a:t>dev</a:t>
+            </a:r>
+            <a:r>
+              <a:rPr lang="en-US" dirty="0" smtClean="0"/>
+              <a:t>/</a:t>
+            </a:r>
+            <a:r>
+              <a:rPr lang="en-US" dirty="0" err="1" smtClean="0"/>
+              <a:t>myserial</a:t>
+            </a:r>
+            <a:endParaRPr lang="en-US" dirty="0" smtClean="0"/>
+          </a:p>
+          <a:p>
+            <a:r>
+              <a:rPr lang="en-US" dirty="0" smtClean="0"/>
+              <a:t># Setup basic ros2 humble environment:</a:t>
+            </a:r>
+          </a:p>
+          <a:p>
+            <a:r>
+              <a:rPr lang="en-US" dirty="0"/>
+              <a:t>source /opt/</a:t>
+            </a:r>
+            <a:r>
+              <a:rPr lang="en-US" dirty="0" err="1"/>
+              <a:t>ros</a:t>
+            </a:r>
+            <a:r>
+              <a:rPr lang="en-US" dirty="0"/>
+              <a:t>/humble/</a:t>
+            </a:r>
+            <a:r>
+              <a:rPr lang="en-US" dirty="0" err="1"/>
+              <a:t>setup.bash</a:t>
+            </a:r>
+            <a:endParaRPr lang="en-US" dirty="0"/>
+          </a:p>
+          <a:p>
+            <a:r>
+              <a:rPr lang="en-US" dirty="0" smtClean="0"/>
+              <a:t># Run the </a:t>
+            </a:r>
+            <a:r>
+              <a:rPr lang="en-US" dirty="0" err="1" smtClean="0"/>
+              <a:t>Rosmaster</a:t>
+            </a:r>
+            <a:r>
+              <a:rPr lang="en-US" dirty="0" smtClean="0"/>
+              <a:t> board driver (in another terminal):</a:t>
+            </a:r>
+          </a:p>
+          <a:p>
+            <a:r>
+              <a:rPr lang="en-US" dirty="0" smtClean="0"/>
+              <a:t>python3 /home/guy/py_install/Rosmaster_Lib/Rosmaster_Lib.py</a:t>
+            </a:r>
+          </a:p>
+          <a:p>
+            <a:r>
+              <a:rPr lang="en-US" dirty="0" smtClean="0"/>
+              <a:t># Source the local workspace’s environment setup:</a:t>
+            </a:r>
+          </a:p>
+          <a:p>
+            <a:r>
+              <a:rPr lang="en-US" dirty="0" smtClean="0"/>
+              <a:t>source ~/workspace/</a:t>
+            </a:r>
+            <a:r>
+              <a:rPr lang="en-US" dirty="0" err="1" smtClean="0"/>
+              <a:t>src</a:t>
+            </a:r>
+            <a:r>
+              <a:rPr lang="en-US" dirty="0" smtClean="0"/>
+              <a:t>/install/</a:t>
+            </a:r>
+            <a:r>
+              <a:rPr lang="en-US" dirty="0" err="1" smtClean="0"/>
+              <a:t>local_setup.bash</a:t>
+            </a:r>
+            <a:endParaRPr lang="en-US" dirty="0" smtClean="0"/>
+          </a:p>
+          <a:p>
+            <a:r>
+              <a:rPr lang="en-US" dirty="0" smtClean="0"/>
+              <a:t># Bring up ros2:</a:t>
+            </a:r>
+          </a:p>
+          <a:p>
+            <a:r>
+              <a:rPr lang="en-US" dirty="0"/>
+              <a:t>ros2 launch </a:t>
+            </a:r>
+            <a:r>
+              <a:rPr lang="en-US" dirty="0" err="1"/>
+              <a:t>yahboomcar_description</a:t>
+            </a:r>
+            <a:r>
+              <a:rPr lang="en-US" dirty="0"/>
+              <a:t> </a:t>
+            </a:r>
+            <a:r>
+              <a:rPr lang="en-US" dirty="0" smtClean="0"/>
+              <a:t>display.launch.py</a:t>
+            </a:r>
+          </a:p>
+          <a:p>
+            <a:pPr lvl="1"/>
+            <a:r>
+              <a:rPr lang="en-US" dirty="0" smtClean="0"/>
+              <a:t>This exits out with error: </a:t>
+            </a:r>
+          </a:p>
+          <a:p>
+            <a:pPr lvl="1"/>
+            <a:r>
+              <a:rPr lang="en-US" dirty="0"/>
+              <a:t>[ERROR] [rviz2-3]: process has died [</a:t>
+            </a:r>
+            <a:r>
+              <a:rPr lang="en-US" dirty="0" err="1"/>
+              <a:t>pid</a:t>
+            </a:r>
+            <a:r>
+              <a:rPr lang="en-US" dirty="0"/>
+              <a:t> 13919, exit code -11, </a:t>
+            </a:r>
+            <a:r>
+              <a:rPr lang="en-US" dirty="0" err="1"/>
+              <a:t>cmd</a:t>
+            </a:r>
+            <a:r>
+              <a:rPr lang="en-US" dirty="0"/>
+              <a:t> '/opt/</a:t>
+            </a:r>
+            <a:r>
+              <a:rPr lang="en-US" dirty="0" err="1"/>
+              <a:t>ros</a:t>
+            </a:r>
+            <a:r>
+              <a:rPr lang="en-US" dirty="0"/>
+              <a:t>/humble/lib/rviz2/rviz2 -d /home/guy/workspace/</a:t>
+            </a:r>
+            <a:r>
+              <a:rPr lang="en-US" dirty="0" err="1"/>
+              <a:t>src</a:t>
+            </a:r>
+            <a:r>
+              <a:rPr lang="en-US" dirty="0"/>
+              <a:t>/install/</a:t>
+            </a:r>
+            <a:r>
+              <a:rPr lang="en-US" dirty="0" err="1"/>
+              <a:t>yahboomcar_description</a:t>
+            </a:r>
+            <a:r>
+              <a:rPr lang="en-US" dirty="0"/>
+              <a:t>/share/</a:t>
+            </a:r>
+            <a:r>
+              <a:rPr lang="en-US" dirty="0" err="1"/>
+              <a:t>yahboomcar_description</a:t>
+            </a:r>
+            <a:r>
+              <a:rPr lang="en-US" dirty="0"/>
+              <a:t>/</a:t>
+            </a:r>
+            <a:r>
+              <a:rPr lang="en-US" dirty="0" err="1"/>
+              <a:t>rviz</a:t>
+            </a:r>
+            <a:r>
+              <a:rPr lang="en-US" dirty="0"/>
+              <a:t>/</a:t>
+            </a:r>
+            <a:r>
+              <a:rPr lang="en-US" dirty="0" err="1"/>
+              <a:t>yahboomcar.rviz</a:t>
+            </a:r>
+            <a:r>
+              <a:rPr lang="en-US" dirty="0"/>
+              <a:t> --</a:t>
+            </a:r>
+            <a:r>
+              <a:rPr lang="en-US" dirty="0" err="1"/>
+              <a:t>ros-args</a:t>
+            </a:r>
+            <a:r>
+              <a:rPr lang="en-US" dirty="0"/>
+              <a:t> -r __node:=rviz2</a:t>
+            </a:r>
+            <a:r>
+              <a:rPr lang="en-US" dirty="0" smtClean="0"/>
+              <a:t>'].</a:t>
+            </a:r>
+          </a:p>
+          <a:p>
+            <a:r>
+              <a:rPr lang="en-US" dirty="0" smtClean="0"/>
+              <a:t># Other examples show something like this:</a:t>
+            </a:r>
+          </a:p>
+          <a:p>
+            <a:r>
+              <a:rPr lang="en-US" dirty="0" smtClean="0"/>
+              <a:t>ros2 </a:t>
+            </a:r>
+            <a:r>
+              <a:rPr lang="en-US" dirty="0"/>
+              <a:t>launch </a:t>
+            </a:r>
+            <a:r>
+              <a:rPr lang="en-US" dirty="0" err="1"/>
+              <a:t>yahboomcar_bringup</a:t>
+            </a:r>
+            <a:r>
+              <a:rPr lang="en-US" dirty="0"/>
+              <a:t> bringup.launch.py</a:t>
+            </a:r>
+          </a:p>
+          <a:p>
+            <a:pPr lvl="1"/>
+            <a:r>
+              <a:rPr lang="en-US" dirty="0"/>
+              <a:t>*there is no </a:t>
+            </a:r>
+            <a:r>
+              <a:rPr lang="en-US" dirty="0" err="1"/>
+              <a:t>yahboomcar_bringup</a:t>
+            </a:r>
+            <a:r>
+              <a:rPr lang="en-US" dirty="0"/>
+              <a:t> or </a:t>
+            </a:r>
+            <a:r>
+              <a:rPr lang="en-US" dirty="0" smtClean="0"/>
+              <a:t>bringup.launch.py</a:t>
+            </a:r>
+          </a:p>
+          <a:p>
+            <a:pPr lvl="1"/>
+            <a:r>
+              <a:rPr lang="en-US" dirty="0" smtClean="0"/>
+              <a:t>**Where to get this?!?</a:t>
+            </a:r>
+          </a:p>
+          <a:p>
+            <a:endParaRPr lang="en-US" dirty="0" smtClean="0"/>
+          </a:p>
+          <a:p>
+            <a:endParaRPr lang="en-US" dirty="0"/>
+          </a:p>
+        </p:txBody>
+      </p:sp>
+    </p:spTree>
+    <p:extLst>
+      <p:ext uri="{BB962C8B-B14F-4D97-AF65-F5344CB8AC3E}">
+        <p14:creationId xmlns:p14="http://schemas.microsoft.com/office/powerpoint/2010/main" val="3987976372"/>
+      </p:ext>
+    </p:extLst>
+  </p:cSld>
+  <p:clrMapOvr>
+    <a:masterClrMapping/>
+  </p:clrMapOvr>
+</p:sld>
+</file>
+
 <file path=ppt/slides/slide2.xml><?xml version="1.0" encoding="utf-8"?>
 <p:sld xmlns:a="http://schemas.openxmlformats.org/drawingml/2006/main" xmlns:r="http://schemas.openxmlformats.org/officeDocument/2006/relationships" xmlns:p="http://schemas.openxmlformats.org/presentationml/2006/main">
   <p:cSld>
@@ -3294,7 +4198,7 @@
         </p:blipFill>
         <p:spPr bwMode="auto">
           <a:xfrm>
-            <a:off x="2549769" y="115153"/>
+            <a:off x="3182229" y="125313"/>
             <a:ext cx="6664128" cy="6659687"/>
           </a:xfrm>
           <a:prstGeom prst="rect">
@@ -3312,6 +4216,66 @@
           </a:extLst>
         </p:spPr>
       </p:pic>
+      <p:sp>
+        <p:nvSpPr>
+          <p:cNvPr id="3" name="TextBox 2"/>
+          <p:cNvSpPr txBox="1"/>
+          <p:nvPr/>
+        </p:nvSpPr>
+        <p:spPr>
+          <a:xfrm>
+            <a:off x="0" y="1666755"/>
+            <a:ext cx="3077830" cy="369332"/>
+          </a:xfrm>
+          <a:prstGeom prst="rect">
+            <a:avLst/>
+          </a:prstGeom>
+          <a:noFill/>
+        </p:spPr>
+        <p:txBody>
+          <a:bodyPr wrap="none" rtlCol="0">
+            <a:spAutoFit/>
+          </a:bodyPr>
+          <a:lstStyle/>
+          <a:p>
+            <a:r>
+              <a:rPr lang="en-US" dirty="0" smtClean="0"/>
+              <a:t>Supports 4 motors w/encoders</a:t>
+            </a:r>
+            <a:endParaRPr lang="en-US" dirty="0"/>
+          </a:p>
+        </p:txBody>
+      </p:sp>
+      <p:sp>
+        <p:nvSpPr>
+          <p:cNvPr id="4" name="TextBox 3"/>
+          <p:cNvSpPr txBox="1"/>
+          <p:nvPr/>
+        </p:nvSpPr>
+        <p:spPr>
+          <a:xfrm>
+            <a:off x="486137" y="4757194"/>
+            <a:ext cx="3252486" cy="1200329"/>
+          </a:xfrm>
+          <a:prstGeom prst="rect">
+            <a:avLst/>
+          </a:prstGeom>
+          <a:noFill/>
+        </p:spPr>
+        <p:txBody>
+          <a:bodyPr wrap="square" rtlCol="0">
+            <a:spAutoFit/>
+          </a:bodyPr>
+          <a:lstStyle/>
+          <a:p>
+            <a:r>
+              <a:rPr lang="en-US" dirty="0" smtClean="0"/>
+              <a:t>Appears to support up to 5 servos. One 3-pin white connector is slightly non-standard.</a:t>
+            </a:r>
+            <a:endParaRPr lang="en-US" dirty="0"/>
+          </a:p>
+        </p:txBody>
+      </p:sp>
     </p:spTree>
     <p:extLst>
       <p:ext uri="{BB962C8B-B14F-4D97-AF65-F5344CB8AC3E}">
@@ -3359,7 +4323,15 @@
           <a:p>
             <a:r>
               <a:rPr lang="en-US" dirty="0" smtClean="0"/>
-              <a:t>Connecting from Linux / Pi</a:t>
+              <a:t>Connecting from Linux / Pi using straight Python (the </a:t>
+            </a:r>
+            <a:r>
+              <a:rPr lang="en-US" dirty="0" err="1" smtClean="0"/>
+              <a:t>Rosmaster_Lib</a:t>
+            </a:r>
+            <a:r>
+              <a:rPr lang="en-US" dirty="0" smtClean="0"/>
+              <a:t>)</a:t>
             </a:r>
             <a:endParaRPr lang="en-US" dirty="0"/>
           </a:p>
@@ -3378,7 +4350,7 @@
         <p:spPr/>
         <p:txBody>
           <a:bodyPr>
-            <a:normAutofit fontScale="55000" lnSpcReduction="20000"/>
+            <a:normAutofit fontScale="47500" lnSpcReduction="20000"/>
           </a:bodyPr>
           <a:lstStyle/>
           <a:p>
@@ -3742,7 +4714,48 @@
               <a:rPr lang="en-US" dirty="0" smtClean="0">
                 <a:sym typeface="Wingdings" panose="05000000000000000000" pitchFamily="2" charset="2"/>
               </a:rPr>
-              <a:t>(100)</a:t>
+              <a:t>(100</a:t>
+            </a:r>
+            <a:r>
+              <a:rPr lang="en-US" dirty="0" smtClean="0">
+                <a:sym typeface="Wingdings" panose="05000000000000000000" pitchFamily="2" charset="2"/>
+              </a:rPr>
+              <a:t>)</a:t>
+            </a:r>
+          </a:p>
+          <a:p>
+            <a:r>
+              <a:rPr lang="en-US" dirty="0" smtClean="0">
+                <a:sym typeface="Wingdings" panose="05000000000000000000" pitchFamily="2" charset="2"/>
+              </a:rPr>
+              <a:t>You can also call the </a:t>
+            </a:r>
+            <a:r>
+              <a:rPr lang="en-US" dirty="0" err="1" smtClean="0">
+                <a:sym typeface="Wingdings" panose="05000000000000000000" pitchFamily="2" charset="2"/>
+              </a:rPr>
+              <a:t>Rosmaster_Lib</a:t>
+            </a:r>
+            <a:r>
+              <a:rPr lang="en-US" dirty="0" smtClean="0">
+                <a:sym typeface="Wingdings" panose="05000000000000000000" pitchFamily="2" charset="2"/>
+              </a:rPr>
+              <a:t> directly, which makes it output status lines over and over:</a:t>
+            </a:r>
+          </a:p>
+          <a:p>
+            <a:pPr lvl="1"/>
+            <a:r>
+              <a:rPr lang="en-US" dirty="0" smtClean="0">
+                <a:sym typeface="Wingdings" panose="05000000000000000000" pitchFamily="2" charset="2"/>
+              </a:rPr>
+              <a:t>python3 </a:t>
+            </a:r>
+            <a:r>
+              <a:rPr lang="en-US" smtClean="0">
+                <a:sym typeface="Wingdings" panose="05000000000000000000" pitchFamily="2" charset="2"/>
+              </a:rPr>
+              <a:t>/home/guy/py_install/Rosmaster_Lib/Rosmaster_Lib.py</a:t>
             </a:r>
             <a:endParaRPr lang="en-US" dirty="0" smtClean="0">
               <a:sym typeface="Wingdings" panose="05000000000000000000" pitchFamily="2" charset="2"/>
@@ -3751,7 +4764,15 @@
           <a:p>
             <a:r>
               <a:rPr lang="en-US" dirty="0" smtClean="0"/>
-              <a:t>*Works on Pi 5, but not on Jetson Orin Nano</a:t>
+              <a:t>*Works on Pi </a:t>
+            </a:r>
+            <a:r>
+              <a:rPr lang="en-US" dirty="0" smtClean="0"/>
+              <a:t>5 and Windows WSL (after binding USB), </a:t>
+            </a:r>
+            <a:r>
+              <a:rPr lang="en-US" dirty="0" smtClean="0"/>
+              <a:t>but not on Jetson Orin Nano</a:t>
             </a:r>
             <a:endParaRPr lang="en-US" dirty="0"/>
           </a:p>
@@ -3761,6 +4782,556 @@
     <p:extLst>
       <p:ext uri="{BB962C8B-B14F-4D97-AF65-F5344CB8AC3E}">
         <p14:creationId xmlns:p14="http://schemas.microsoft.com/office/powerpoint/2010/main" val="179385849"/>
+      </p:ext>
+    </p:extLst>
+  </p:cSld>
+  <p:clrMapOvr>
+    <a:masterClrMapping/>
+  </p:clrMapOvr>
+</p:sld>
+</file>
+
+<file path=ppt/slides/slide7.xml><?xml version="1.0" encoding="utf-8"?>
+<p:sld xmlns:a="http://schemas.openxmlformats.org/drawingml/2006/main" xmlns:r="http://schemas.openxmlformats.org/officeDocument/2006/relationships" xmlns:p="http://schemas.openxmlformats.org/presentationml/2006/main">
+  <p:cSld>
+    <p:spTree>
+      <p:nvGrpSpPr>
+        <p:cNvPr id="1" name=""/>
+        <p:cNvGrpSpPr/>
+        <p:nvPr/>
+      </p:nvGrpSpPr>
+      <p:grpSpPr>
+        <a:xfrm>
+          <a:off x="0" y="0"/>
+          <a:ext cx="0" cy="0"/>
+          <a:chOff x="0" y="0"/>
+          <a:chExt cx="0" cy="0"/>
+        </a:xfrm>
+      </p:grpSpPr>
+      <p:sp>
+        <p:nvSpPr>
+          <p:cNvPr id="2" name="Title 1"/>
+          <p:cNvSpPr>
+            <a:spLocks noGrp="1"/>
+          </p:cNvSpPr>
+          <p:nvPr>
+            <p:ph type="title"/>
+          </p:nvPr>
+        </p:nvSpPr>
+        <p:spPr/>
+        <p:txBody>
+          <a:bodyPr>
+            <a:normAutofit/>
+          </a:bodyPr>
+          <a:lstStyle/>
+          <a:p>
+            <a:r>
+              <a:rPr lang="en-US" sz="4000" dirty="0" smtClean="0"/>
+              <a:t>Connecting from Windows Subsystem for Linux</a:t>
+            </a:r>
+            <a:endParaRPr lang="en-US" sz="4000" dirty="0"/>
+          </a:p>
+        </p:txBody>
+      </p:sp>
+      <p:sp>
+        <p:nvSpPr>
+          <p:cNvPr id="3" name="Content Placeholder 2"/>
+          <p:cNvSpPr>
+            <a:spLocks noGrp="1"/>
+          </p:cNvSpPr>
+          <p:nvPr>
+            <p:ph idx="1"/>
+          </p:nvPr>
+        </p:nvSpPr>
+        <p:spPr/>
+        <p:txBody>
+          <a:bodyPr>
+            <a:normAutofit fontScale="92500" lnSpcReduction="20000"/>
+          </a:bodyPr>
+          <a:lstStyle/>
+          <a:p>
+            <a:r>
+              <a:rPr lang="en-US" dirty="0" smtClean="0"/>
+              <a:t>Need to install a windows-side driver:</a:t>
+            </a:r>
+          </a:p>
+          <a:p>
+            <a:pPr lvl="1"/>
+            <a:r>
+              <a:rPr lang="en-US" dirty="0" err="1"/>
+              <a:t>winget</a:t>
+            </a:r>
+            <a:r>
+              <a:rPr lang="en-US" dirty="0"/>
+              <a:t> install </a:t>
+            </a:r>
+            <a:r>
+              <a:rPr lang="en-US" dirty="0" err="1" smtClean="0"/>
+              <a:t>usbipd</a:t>
+            </a:r>
+            <a:endParaRPr lang="en-US" dirty="0" smtClean="0"/>
+          </a:p>
+          <a:p>
+            <a:r>
+              <a:rPr lang="en-US" dirty="0" smtClean="0"/>
+              <a:t>Each time you (re-)connect the USB:</a:t>
+            </a:r>
+          </a:p>
+          <a:p>
+            <a:pPr lvl="1"/>
+            <a:r>
+              <a:rPr lang="en-US" dirty="0" err="1"/>
+              <a:t>usbipd</a:t>
+            </a:r>
+            <a:r>
+              <a:rPr lang="en-US" dirty="0"/>
+              <a:t> </a:t>
+            </a:r>
+            <a:r>
+              <a:rPr lang="en-US" dirty="0" smtClean="0"/>
+              <a:t>list</a:t>
+            </a:r>
+          </a:p>
+          <a:p>
+            <a:pPr lvl="2"/>
+            <a:r>
+              <a:rPr lang="en-US" dirty="0" smtClean="0"/>
+              <a:t>*From the list put in the correct bus-ID for the device you want to use in WSL:</a:t>
+            </a:r>
+          </a:p>
+          <a:p>
+            <a:pPr lvl="1"/>
+            <a:r>
+              <a:rPr lang="en-US" dirty="0" err="1"/>
+              <a:t>usbipd</a:t>
+            </a:r>
+            <a:r>
+              <a:rPr lang="en-US" dirty="0"/>
+              <a:t> bind </a:t>
+            </a:r>
+            <a:r>
+              <a:rPr lang="en-US" dirty="0" smtClean="0"/>
+              <a:t>--</a:t>
+            </a:r>
+            <a:r>
+              <a:rPr lang="en-US" dirty="0" err="1" smtClean="0"/>
+              <a:t>busid</a:t>
+            </a:r>
+            <a:r>
+              <a:rPr lang="en-US" dirty="0" smtClean="0"/>
+              <a:t> 1-3</a:t>
+            </a:r>
+          </a:p>
+          <a:p>
+            <a:pPr lvl="2"/>
+            <a:r>
+              <a:rPr lang="en-US" dirty="0" smtClean="0"/>
+              <a:t>*maybe give error, but no harm in running this twice</a:t>
+            </a:r>
+          </a:p>
+          <a:p>
+            <a:pPr lvl="1"/>
+            <a:r>
+              <a:rPr lang="en-US" dirty="0" err="1" smtClean="0"/>
+              <a:t>usbipd</a:t>
+            </a:r>
+            <a:r>
+              <a:rPr lang="en-US" dirty="0" smtClean="0"/>
+              <a:t> attach --</a:t>
+            </a:r>
+            <a:r>
+              <a:rPr lang="en-US" dirty="0" err="1" smtClean="0"/>
+              <a:t>wsl</a:t>
+            </a:r>
+            <a:r>
+              <a:rPr lang="en-US" dirty="0" smtClean="0"/>
+              <a:t> --</a:t>
+            </a:r>
+            <a:r>
+              <a:rPr lang="en-US" dirty="0" err="1" smtClean="0"/>
+              <a:t>busid</a:t>
+            </a:r>
+            <a:r>
+              <a:rPr lang="en-US" dirty="0"/>
+              <a:t> </a:t>
+            </a:r>
+            <a:r>
+              <a:rPr lang="en-US" dirty="0" smtClean="0"/>
+              <a:t>1-3</a:t>
+            </a:r>
+          </a:p>
+          <a:p>
+            <a:r>
+              <a:rPr lang="en-US" dirty="0"/>
+              <a:t>Stuff may need to be installed on the Linux side, as well</a:t>
+            </a:r>
+          </a:p>
+          <a:p>
+            <a:r>
+              <a:rPr lang="en-US" dirty="0" smtClean="0"/>
+              <a:t>In WSL to </a:t>
+            </a:r>
+            <a:r>
+              <a:rPr lang="en-US" dirty="0"/>
+              <a:t>see if it’s really connected from </a:t>
+            </a:r>
+            <a:r>
+              <a:rPr lang="en-US" dirty="0" smtClean="0"/>
+              <a:t>Windows:</a:t>
+            </a:r>
+          </a:p>
+          <a:p>
+            <a:pPr lvl="1"/>
+            <a:r>
+              <a:rPr lang="en-US" dirty="0" err="1" smtClean="0"/>
+              <a:t>lsusb</a:t>
+            </a:r>
+            <a:endParaRPr lang="en-US" dirty="0" smtClean="0"/>
+          </a:p>
+          <a:p>
+            <a:pPr lvl="1"/>
+            <a:r>
+              <a:rPr lang="en-US" dirty="0" err="1" smtClean="0"/>
+              <a:t>ls</a:t>
+            </a:r>
+            <a:r>
+              <a:rPr lang="en-US" dirty="0" smtClean="0"/>
+              <a:t> -l /</a:t>
+            </a:r>
+            <a:r>
+              <a:rPr lang="en-US" dirty="0" err="1" smtClean="0"/>
+              <a:t>dev</a:t>
+            </a:r>
+            <a:r>
+              <a:rPr lang="en-US" dirty="0" smtClean="0"/>
+              <a:t>/</a:t>
+            </a:r>
+            <a:r>
+              <a:rPr lang="en-US" dirty="0" err="1" smtClean="0"/>
+              <a:t>myserial</a:t>
+            </a:r>
+            <a:endParaRPr lang="en-US" dirty="0" smtClean="0"/>
+          </a:p>
+          <a:p>
+            <a:pPr lvl="2"/>
+            <a:r>
+              <a:rPr lang="en-US" dirty="0" smtClean="0"/>
+              <a:t>*should show /</a:t>
+            </a:r>
+            <a:r>
+              <a:rPr lang="en-US" dirty="0" err="1" smtClean="0"/>
+              <a:t>dev</a:t>
+            </a:r>
+            <a:r>
+              <a:rPr lang="en-US" dirty="0" smtClean="0"/>
+              <a:t>/</a:t>
+            </a:r>
+            <a:r>
+              <a:rPr lang="en-US" dirty="0" err="1" smtClean="0"/>
+              <a:t>myserial</a:t>
+            </a:r>
+            <a:r>
+              <a:rPr lang="en-US" dirty="0" smtClean="0"/>
+              <a:t> </a:t>
+            </a:r>
+            <a:r>
+              <a:rPr lang="en-US" dirty="0" smtClean="0">
+                <a:sym typeface="Wingdings" panose="05000000000000000000" pitchFamily="2" charset="2"/>
+              </a:rPr>
+              <a:t> ttyUSB0  symbolic link</a:t>
+            </a:r>
+            <a:endParaRPr lang="en-US" dirty="0" smtClean="0"/>
+          </a:p>
+          <a:p>
+            <a:endParaRPr lang="en-US" dirty="0"/>
+          </a:p>
+          <a:p>
+            <a:endParaRPr lang="en-US" dirty="0" smtClean="0"/>
+          </a:p>
+          <a:p>
+            <a:pPr lvl="1"/>
+            <a:endParaRPr lang="en-US" dirty="0"/>
+          </a:p>
+        </p:txBody>
+      </p:sp>
+    </p:spTree>
+    <p:extLst>
+      <p:ext uri="{BB962C8B-B14F-4D97-AF65-F5344CB8AC3E}">
+        <p14:creationId xmlns:p14="http://schemas.microsoft.com/office/powerpoint/2010/main" val="1648913703"/>
+      </p:ext>
+    </p:extLst>
+  </p:cSld>
+  <p:clrMapOvr>
+    <a:masterClrMapping/>
+  </p:clrMapOvr>
+</p:sld>
+</file>
+
+<file path=ppt/slides/slide8.xml><?xml version="1.0" encoding="utf-8"?>
+<p:sld xmlns:a="http://schemas.openxmlformats.org/drawingml/2006/main" xmlns:r="http://schemas.openxmlformats.org/officeDocument/2006/relationships" xmlns:p="http://schemas.openxmlformats.org/presentationml/2006/main">
+  <p:cSld>
+    <p:spTree>
+      <p:nvGrpSpPr>
+        <p:cNvPr id="1" name=""/>
+        <p:cNvGrpSpPr/>
+        <p:nvPr/>
+      </p:nvGrpSpPr>
+      <p:grpSpPr>
+        <a:xfrm>
+          <a:off x="0" y="0"/>
+          <a:ext cx="0" cy="0"/>
+          <a:chOff x="0" y="0"/>
+          <a:chExt cx="0" cy="0"/>
+        </a:xfrm>
+      </p:grpSpPr>
+      <p:sp>
+        <p:nvSpPr>
+          <p:cNvPr id="2" name="Title 1"/>
+          <p:cNvSpPr>
+            <a:spLocks noGrp="1"/>
+          </p:cNvSpPr>
+          <p:nvPr>
+            <p:ph type="title"/>
+          </p:nvPr>
+        </p:nvSpPr>
+        <p:spPr/>
+        <p:txBody>
+          <a:bodyPr/>
+          <a:lstStyle/>
+          <a:p>
+            <a:r>
+              <a:rPr lang="en-US" dirty="0" smtClean="0"/>
+              <a:t>Installing ROS2 in Linux</a:t>
+            </a:r>
+            <a:endParaRPr lang="en-US" dirty="0"/>
+          </a:p>
+        </p:txBody>
+      </p:sp>
+      <p:sp>
+        <p:nvSpPr>
+          <p:cNvPr id="3" name="Content Placeholder 2"/>
+          <p:cNvSpPr>
+            <a:spLocks noGrp="1"/>
+          </p:cNvSpPr>
+          <p:nvPr>
+            <p:ph idx="1"/>
+          </p:nvPr>
+        </p:nvSpPr>
+        <p:spPr/>
+        <p:txBody>
+          <a:bodyPr/>
+          <a:lstStyle/>
+          <a:p>
+            <a:r>
+              <a:rPr lang="en-US" dirty="0">
+                <a:hlinkClick r:id="rId2"/>
+              </a:rPr>
+              <a:t>https://</a:t>
+            </a:r>
+            <a:r>
+              <a:rPr lang="en-US" dirty="0" smtClean="0">
+                <a:hlinkClick r:id="rId2"/>
+              </a:rPr>
+              <a:t>www.yahboom.net/study/ROS-Driver-Board</a:t>
+            </a:r>
+            <a:endParaRPr lang="en-US" dirty="0" smtClean="0"/>
+          </a:p>
+          <a:p>
+            <a:pPr lvl="1"/>
+            <a:r>
+              <a:rPr lang="en-US" dirty="0" smtClean="0"/>
+              <a:t>Under ‘ROS2 Basic Course’ – ‘ROS2 install Humble’</a:t>
+            </a:r>
+          </a:p>
+        </p:txBody>
+      </p:sp>
+    </p:spTree>
+    <p:extLst>
+      <p:ext uri="{BB962C8B-B14F-4D97-AF65-F5344CB8AC3E}">
+        <p14:creationId xmlns:p14="http://schemas.microsoft.com/office/powerpoint/2010/main" val="1024456953"/>
+      </p:ext>
+    </p:extLst>
+  </p:cSld>
+  <p:clrMapOvr>
+    <a:masterClrMapping/>
+  </p:clrMapOvr>
+</p:sld>
+</file>
+
+<file path=ppt/slides/slide9.xml><?xml version="1.0" encoding="utf-8"?>
+<p:sld xmlns:a="http://schemas.openxmlformats.org/drawingml/2006/main" xmlns:r="http://schemas.openxmlformats.org/officeDocument/2006/relationships" xmlns:p="http://schemas.openxmlformats.org/presentationml/2006/main">
+  <p:cSld>
+    <p:spTree>
+      <p:nvGrpSpPr>
+        <p:cNvPr id="1" name=""/>
+        <p:cNvGrpSpPr/>
+        <p:nvPr/>
+      </p:nvGrpSpPr>
+      <p:grpSpPr>
+        <a:xfrm>
+          <a:off x="0" y="0"/>
+          <a:ext cx="0" cy="0"/>
+          <a:chOff x="0" y="0"/>
+          <a:chExt cx="0" cy="0"/>
+        </a:xfrm>
+      </p:grpSpPr>
+      <p:sp>
+        <p:nvSpPr>
+          <p:cNvPr id="2" name="Title 1"/>
+          <p:cNvSpPr>
+            <a:spLocks noGrp="1"/>
+          </p:cNvSpPr>
+          <p:nvPr>
+            <p:ph type="title"/>
+          </p:nvPr>
+        </p:nvSpPr>
+        <p:spPr/>
+        <p:txBody>
+          <a:bodyPr/>
+          <a:lstStyle/>
+          <a:p>
+            <a:r>
+              <a:rPr lang="en-US" sz="4000" dirty="0" smtClean="0"/>
+              <a:t>Testing the ROS2 install with the Turtle simulator</a:t>
+            </a:r>
+            <a:endParaRPr lang="en-US" dirty="0"/>
+          </a:p>
+        </p:txBody>
+      </p:sp>
+      <p:sp>
+        <p:nvSpPr>
+          <p:cNvPr id="3" name="Content Placeholder 2"/>
+          <p:cNvSpPr>
+            <a:spLocks noGrp="1"/>
+          </p:cNvSpPr>
+          <p:nvPr>
+            <p:ph idx="1"/>
+          </p:nvPr>
+        </p:nvSpPr>
+        <p:spPr/>
+        <p:txBody>
+          <a:bodyPr/>
+          <a:lstStyle/>
+          <a:p>
+            <a:r>
+              <a:rPr lang="en-US" dirty="0" smtClean="0"/>
+              <a:t>Run in separate terminals:</a:t>
+            </a:r>
+          </a:p>
+          <a:p>
+            <a:pPr lvl="1"/>
+            <a:r>
+              <a:rPr lang="en-US" dirty="0" smtClean="0"/>
+              <a:t># Always source first:</a:t>
+            </a:r>
+          </a:p>
+          <a:p>
+            <a:pPr lvl="1"/>
+            <a:r>
+              <a:rPr lang="en-US" dirty="0"/>
+              <a:t>source /opt/</a:t>
+            </a:r>
+            <a:r>
+              <a:rPr lang="en-US" dirty="0" err="1"/>
+              <a:t>ros</a:t>
+            </a:r>
+            <a:r>
+              <a:rPr lang="en-US" dirty="0"/>
+              <a:t>/humble/</a:t>
+            </a:r>
+            <a:r>
+              <a:rPr lang="en-US" dirty="0" err="1"/>
+              <a:t>setup.bash</a:t>
+            </a:r>
+            <a:endParaRPr lang="en-US" dirty="0"/>
+          </a:p>
+          <a:p>
+            <a:pPr lvl="1"/>
+            <a:r>
+              <a:rPr lang="en-US" dirty="0" smtClean="0"/>
+              <a:t># Run ros2 w/turtle simulator</a:t>
+            </a:r>
+          </a:p>
+          <a:p>
+            <a:pPr lvl="1"/>
+            <a:r>
+              <a:rPr lang="en-US" dirty="0" smtClean="0"/>
+              <a:t>ros2 </a:t>
+            </a:r>
+            <a:r>
+              <a:rPr lang="en-US" dirty="0"/>
+              <a:t>run </a:t>
+            </a:r>
+            <a:r>
+              <a:rPr lang="en-US" dirty="0" err="1"/>
+              <a:t>turtlesim</a:t>
+            </a:r>
+            <a:r>
+              <a:rPr lang="en-US" dirty="0"/>
+              <a:t> </a:t>
+            </a:r>
+            <a:r>
+              <a:rPr lang="en-US" dirty="0" err="1" smtClean="0"/>
+              <a:t>turtlesim_node</a:t>
+            </a:r>
+            <a:endParaRPr lang="en-US" dirty="0" smtClean="0"/>
+          </a:p>
+          <a:p>
+            <a:pPr lvl="1"/>
+            <a:r>
+              <a:rPr lang="en-US" dirty="0" smtClean="0"/>
+              <a:t># Control the turtle with the keyboard:</a:t>
+            </a:r>
+          </a:p>
+          <a:p>
+            <a:pPr lvl="1"/>
+            <a:r>
+              <a:rPr lang="en-US" dirty="0" smtClean="0"/>
+              <a:t>ros2 </a:t>
+            </a:r>
+            <a:r>
+              <a:rPr lang="en-US" dirty="0"/>
+              <a:t>run </a:t>
+            </a:r>
+            <a:r>
+              <a:rPr lang="en-US" dirty="0" err="1"/>
+              <a:t>turtlesim</a:t>
+            </a:r>
+            <a:r>
+              <a:rPr lang="en-US" dirty="0"/>
+              <a:t> </a:t>
+            </a:r>
+            <a:r>
+              <a:rPr lang="en-US" dirty="0" err="1" smtClean="0"/>
+              <a:t>turtle_teleop_key</a:t>
+            </a:r>
+            <a:endParaRPr lang="en-US" dirty="0" smtClean="0"/>
+          </a:p>
+          <a:p>
+            <a:pPr lvl="1"/>
+            <a:r>
+              <a:rPr lang="en-US" dirty="0" smtClean="0"/>
+              <a:t># Get telemetry info:</a:t>
+            </a:r>
+          </a:p>
+          <a:p>
+            <a:pPr lvl="1"/>
+            <a:r>
+              <a:rPr lang="en-US" dirty="0"/>
+              <a:t>ros2 topic echo /turtle1/</a:t>
+            </a:r>
+            <a:r>
+              <a:rPr lang="en-US" dirty="0" err="1"/>
+              <a:t>cmd_vel</a:t>
+            </a:r>
+            <a:endParaRPr lang="en-US" dirty="0"/>
+          </a:p>
+        </p:txBody>
+      </p:sp>
+    </p:spTree>
+    <p:extLst>
+      <p:ext uri="{BB962C8B-B14F-4D97-AF65-F5344CB8AC3E}">
+        <p14:creationId xmlns:p14="http://schemas.microsoft.com/office/powerpoint/2010/main" val="49954300"/>
       </p:ext>
     </p:extLst>
   </p:cSld>

</xml_diff>

<commit_message>
Updated for serial servo control
</commit_message>
<xml_diff>
--- a/embedded/RobotOperatingSystem/Yahboom_ROS2_board.pptx
+++ b/embedded/RobotOperatingSystem/Yahboom_ROS2_board.pptx
@@ -10,13 +10,17 @@
     <p:sldId id="258" r:id="rId4"/>
     <p:sldId id="259" r:id="rId5"/>
     <p:sldId id="260" r:id="rId6"/>
-    <p:sldId id="261" r:id="rId7"/>
-    <p:sldId id="262" r:id="rId8"/>
-    <p:sldId id="263" r:id="rId9"/>
-    <p:sldId id="264" r:id="rId10"/>
-    <p:sldId id="266" r:id="rId11"/>
-    <p:sldId id="267" r:id="rId12"/>
-    <p:sldId id="265" r:id="rId13"/>
+    <p:sldId id="270" r:id="rId7"/>
+    <p:sldId id="261" r:id="rId8"/>
+    <p:sldId id="262" r:id="rId9"/>
+    <p:sldId id="268" r:id="rId10"/>
+    <p:sldId id="271" r:id="rId11"/>
+    <p:sldId id="269" r:id="rId12"/>
+    <p:sldId id="263" r:id="rId13"/>
+    <p:sldId id="264" r:id="rId14"/>
+    <p:sldId id="266" r:id="rId15"/>
+    <p:sldId id="267" r:id="rId16"/>
+    <p:sldId id="265" r:id="rId17"/>
   </p:sldIdLst>
   <p:sldSz cx="12192000" cy="6858000"/>
   <p:notesSz cx="6858000" cy="9144000"/>
@@ -254,7 +258,7 @@
           <a:p>
             <a:fld id="{44754554-1BE5-4E82-B131-2EEEA354167B}" type="datetimeFigureOut">
               <a:rPr lang="en-US" smtClean="0"/>
-              <a:t>3/16/2026</a:t>
+              <a:t>4/28/2026</a:t>
             </a:fld>
             <a:endParaRPr lang="en-US"/>
           </a:p>
@@ -424,7 +428,7 @@
           <a:p>
             <a:fld id="{44754554-1BE5-4E82-B131-2EEEA354167B}" type="datetimeFigureOut">
               <a:rPr lang="en-US" smtClean="0"/>
-              <a:t>3/16/2026</a:t>
+              <a:t>4/28/2026</a:t>
             </a:fld>
             <a:endParaRPr lang="en-US"/>
           </a:p>
@@ -604,7 +608,7 @@
           <a:p>
             <a:fld id="{44754554-1BE5-4E82-B131-2EEEA354167B}" type="datetimeFigureOut">
               <a:rPr lang="en-US" smtClean="0"/>
-              <a:t>3/16/2026</a:t>
+              <a:t>4/28/2026</a:t>
             </a:fld>
             <a:endParaRPr lang="en-US"/>
           </a:p>
@@ -774,7 +778,7 @@
           <a:p>
             <a:fld id="{44754554-1BE5-4E82-B131-2EEEA354167B}" type="datetimeFigureOut">
               <a:rPr lang="en-US" smtClean="0"/>
-              <a:t>3/16/2026</a:t>
+              <a:t>4/28/2026</a:t>
             </a:fld>
             <a:endParaRPr lang="en-US"/>
           </a:p>
@@ -1020,7 +1024,7 @@
           <a:p>
             <a:fld id="{44754554-1BE5-4E82-B131-2EEEA354167B}" type="datetimeFigureOut">
               <a:rPr lang="en-US" smtClean="0"/>
-              <a:t>3/16/2026</a:t>
+              <a:t>4/28/2026</a:t>
             </a:fld>
             <a:endParaRPr lang="en-US"/>
           </a:p>
@@ -1252,7 +1256,7 @@
           <a:p>
             <a:fld id="{44754554-1BE5-4E82-B131-2EEEA354167B}" type="datetimeFigureOut">
               <a:rPr lang="en-US" smtClean="0"/>
-              <a:t>3/16/2026</a:t>
+              <a:t>4/28/2026</a:t>
             </a:fld>
             <a:endParaRPr lang="en-US"/>
           </a:p>
@@ -1619,7 +1623,7 @@
           <a:p>
             <a:fld id="{44754554-1BE5-4E82-B131-2EEEA354167B}" type="datetimeFigureOut">
               <a:rPr lang="en-US" smtClean="0"/>
-              <a:t>3/16/2026</a:t>
+              <a:t>4/28/2026</a:t>
             </a:fld>
             <a:endParaRPr lang="en-US"/>
           </a:p>
@@ -1737,7 +1741,7 @@
           <a:p>
             <a:fld id="{44754554-1BE5-4E82-B131-2EEEA354167B}" type="datetimeFigureOut">
               <a:rPr lang="en-US" smtClean="0"/>
-              <a:t>3/16/2026</a:t>
+              <a:t>4/28/2026</a:t>
             </a:fld>
             <a:endParaRPr lang="en-US"/>
           </a:p>
@@ -1832,7 +1836,7 @@
           <a:p>
             <a:fld id="{44754554-1BE5-4E82-B131-2EEEA354167B}" type="datetimeFigureOut">
               <a:rPr lang="en-US" smtClean="0"/>
-              <a:t>3/16/2026</a:t>
+              <a:t>4/28/2026</a:t>
             </a:fld>
             <a:endParaRPr lang="en-US"/>
           </a:p>
@@ -2109,7 +2113,7 @@
           <a:p>
             <a:fld id="{44754554-1BE5-4E82-B131-2EEEA354167B}" type="datetimeFigureOut">
               <a:rPr lang="en-US" smtClean="0"/>
-              <a:t>3/16/2026</a:t>
+              <a:t>4/28/2026</a:t>
             </a:fld>
             <a:endParaRPr lang="en-US"/>
           </a:p>
@@ -2362,7 +2366,7 @@
           <a:p>
             <a:fld id="{44754554-1BE5-4E82-B131-2EEEA354167B}" type="datetimeFigureOut">
               <a:rPr lang="en-US" smtClean="0"/>
-              <a:t>3/16/2026</a:t>
+              <a:t>4/28/2026</a:t>
             </a:fld>
             <a:endParaRPr lang="en-US"/>
           </a:p>
@@ -2575,7 +2579,7 @@
           <a:p>
             <a:fld id="{44754554-1BE5-4E82-B131-2EEEA354167B}" type="datetimeFigureOut">
               <a:rPr lang="en-US" smtClean="0"/>
-              <a:t>3/16/2026</a:t>
+              <a:t>4/28/2026</a:t>
             </a:fld>
             <a:endParaRPr lang="en-US"/>
           </a:p>
@@ -3068,25 +3072,12 @@
         </p:nvSpPr>
         <p:spPr/>
         <p:txBody>
-          <a:bodyPr>
-            <a:normAutofit/>
-          </a:bodyPr>
-          <a:lstStyle/>
-          <a:p>
-            <a:r>
-              <a:rPr lang="en-US" dirty="0" smtClean="0"/>
-              <a:t>Creating new ROS2 </a:t>
-            </a:r>
-            <a:r>
-              <a:rPr lang="en-US" dirty="0"/>
-              <a:t>workspace</a:t>
-            </a:r>
-            <a:br>
-              <a:rPr lang="en-US" dirty="0"/>
-            </a:br>
-            <a:r>
-              <a:rPr lang="en-US" sz="1400" dirty="0"/>
-              <a:t>https://docs.ros.org/en/humble/Tutorials/Beginner-Client-Libraries/Creating-A-Workspace/Creating-A-Workspace.html</a:t>
+          <a:bodyPr/>
+          <a:lstStyle/>
+          <a:p>
+            <a:r>
+              <a:rPr lang="en-US" dirty="0" smtClean="0"/>
+              <a:t>Controlling PWM servos</a:t>
             </a:r>
             <a:endParaRPr lang="en-US" dirty="0"/>
           </a:p>
@@ -3102,300 +3093,93 @@
             <p:ph idx="1"/>
           </p:nvPr>
         </p:nvSpPr>
-        <p:spPr>
-          <a:xfrm>
-            <a:off x="838200" y="1825624"/>
-            <a:ext cx="10515600" cy="4816715"/>
-          </a:xfrm>
-        </p:spPr>
-        <p:txBody>
-          <a:bodyPr>
-            <a:normAutofit fontScale="47500" lnSpcReduction="20000"/>
-          </a:bodyPr>
-          <a:lstStyle/>
-          <a:p>
-            <a:r>
-              <a:rPr lang="en-US" dirty="0"/>
-              <a:t>source /</a:t>
-            </a:r>
-            <a:r>
-              <a:rPr lang="en-US" dirty="0" smtClean="0"/>
-              <a:t>opt/</a:t>
-            </a:r>
+        <p:spPr/>
+        <p:txBody>
+          <a:bodyPr/>
+          <a:lstStyle/>
+          <a:p>
+            <a:r>
+              <a:rPr lang="en-US" dirty="0">
+                <a:sym typeface="Wingdings" panose="05000000000000000000" pitchFamily="2" charset="2"/>
+              </a:rPr>
+              <a:t>from </a:t>
+            </a:r>
+            <a:r>
+              <a:rPr lang="en-US" dirty="0" err="1">
+                <a:sym typeface="Wingdings" panose="05000000000000000000" pitchFamily="2" charset="2"/>
+              </a:rPr>
+              <a:t>Rosmaster_Lib</a:t>
+            </a:r>
+            <a:r>
+              <a:rPr lang="en-US" dirty="0">
+                <a:sym typeface="Wingdings" panose="05000000000000000000" pitchFamily="2" charset="2"/>
+              </a:rPr>
+              <a:t> import </a:t>
+            </a:r>
+            <a:r>
+              <a:rPr lang="en-US" dirty="0" err="1">
+                <a:sym typeface="Wingdings" panose="05000000000000000000" pitchFamily="2" charset="2"/>
+              </a:rPr>
+              <a:t>Rosmaster</a:t>
+            </a:r>
+            <a:endParaRPr lang="en-US" dirty="0">
+              <a:sym typeface="Wingdings" panose="05000000000000000000" pitchFamily="2" charset="2"/>
+            </a:endParaRPr>
+          </a:p>
+          <a:p>
+            <a:r>
+              <a:rPr lang="en-US" dirty="0">
+                <a:sym typeface="Wingdings" panose="05000000000000000000" pitchFamily="2" charset="2"/>
+              </a:rPr>
+              <a:t>bot = </a:t>
+            </a:r>
+            <a:r>
+              <a:rPr lang="en-US" dirty="0" err="1">
+                <a:sym typeface="Wingdings" panose="05000000000000000000" pitchFamily="2" charset="2"/>
+              </a:rPr>
+              <a:t>Rosmaster</a:t>
+            </a:r>
+            <a:r>
+              <a:rPr lang="en-US" dirty="0" smtClean="0">
+                <a:sym typeface="Wingdings" panose="05000000000000000000" pitchFamily="2" charset="2"/>
+              </a:rPr>
+              <a:t>()</a:t>
+            </a:r>
+          </a:p>
+          <a:p>
+            <a:pPr lvl="1"/>
+            <a:r>
+              <a:rPr lang="en-US" dirty="0" smtClean="0">
+                <a:sym typeface="Wingdings" panose="05000000000000000000" pitchFamily="2" charset="2"/>
+              </a:rPr>
+              <a:t>This works!</a:t>
+            </a:r>
+            <a:endParaRPr lang="en-US" dirty="0">
+              <a:sym typeface="Wingdings" panose="05000000000000000000" pitchFamily="2" charset="2"/>
+            </a:endParaRPr>
+          </a:p>
+          <a:p>
             <a:r>
               <a:rPr lang="en-US" dirty="0" err="1" smtClean="0"/>
-              <a:t>ros</a:t>
-            </a:r>
-            <a:r>
-              <a:rPr lang="en-US" dirty="0" smtClean="0"/>
-              <a:t>/humble/</a:t>
-            </a:r>
-            <a:r>
-              <a:rPr lang="en-US" dirty="0" err="1" smtClean="0"/>
-              <a:t>setup.bash</a:t>
-            </a:r>
-            <a:endParaRPr lang="en-US" dirty="0" smtClean="0"/>
-          </a:p>
-          <a:p>
-            <a:r>
-              <a:rPr lang="en-US" dirty="0" err="1"/>
-              <a:t>mkdir</a:t>
-            </a:r>
-            <a:r>
-              <a:rPr lang="en-US" dirty="0"/>
-              <a:t> -p ~/</a:t>
-            </a:r>
-            <a:r>
-              <a:rPr lang="en-US" dirty="0" smtClean="0"/>
-              <a:t>ros2_ws/</a:t>
-            </a:r>
-            <a:r>
-              <a:rPr lang="en-US" dirty="0" err="1" smtClean="0"/>
-              <a:t>src</a:t>
-            </a:r>
-            <a:endParaRPr lang="en-US" dirty="0" smtClean="0"/>
-          </a:p>
-          <a:p>
-            <a:r>
-              <a:rPr lang="en-US" dirty="0"/>
-              <a:t>cd ~/</a:t>
-            </a:r>
-            <a:r>
-              <a:rPr lang="en-US" dirty="0" smtClean="0"/>
-              <a:t>ros2_ws/</a:t>
-            </a:r>
-            <a:r>
-              <a:rPr lang="en-US" dirty="0" err="1" smtClean="0"/>
-              <a:t>src</a:t>
-            </a:r>
-            <a:endParaRPr lang="en-US" dirty="0" smtClean="0"/>
-          </a:p>
-          <a:p>
-            <a:r>
-              <a:rPr lang="en-US" dirty="0" smtClean="0"/>
-              <a:t># Clone your repo into </a:t>
-            </a:r>
-            <a:r>
-              <a:rPr lang="en-US" dirty="0" err="1" smtClean="0"/>
-              <a:t>src</a:t>
-            </a:r>
-            <a:r>
-              <a:rPr lang="en-US" dirty="0" smtClean="0"/>
-              <a:t> (this is example that includes the turtle </a:t>
-            </a:r>
-            <a:r>
-              <a:rPr lang="en-US" dirty="0" err="1" smtClean="0"/>
-              <a:t>sim</a:t>
-            </a:r>
-            <a:r>
-              <a:rPr lang="en-US" dirty="0" smtClean="0"/>
-              <a:t>).</a:t>
-            </a:r>
-          </a:p>
-          <a:p>
-            <a:r>
-              <a:rPr lang="en-US" dirty="0" err="1"/>
-              <a:t>git</a:t>
-            </a:r>
-            <a:r>
-              <a:rPr lang="en-US" dirty="0"/>
-              <a:t> clone https://github.com/ros/ros_tutorials.git -b </a:t>
-            </a:r>
-            <a:r>
-              <a:rPr lang="en-US" dirty="0" smtClean="0"/>
-              <a:t>humble</a:t>
-            </a:r>
-          </a:p>
-          <a:p>
-            <a:r>
-              <a:rPr lang="en-US" dirty="0" smtClean="0"/>
-              <a:t># Go back to base directory.</a:t>
-            </a:r>
-          </a:p>
-          <a:p>
-            <a:r>
-              <a:rPr lang="en-US" dirty="0" smtClean="0"/>
-              <a:t>cd ..</a:t>
-            </a:r>
-          </a:p>
-          <a:p>
-            <a:r>
-              <a:rPr lang="en-US" dirty="0" smtClean="0"/>
-              <a:t># Need to initialize (just once).</a:t>
-            </a:r>
-          </a:p>
-          <a:p>
-            <a:r>
-              <a:rPr lang="en-US" dirty="0" err="1" smtClean="0"/>
-              <a:t>sudo</a:t>
-            </a:r>
-            <a:r>
-              <a:rPr lang="en-US" dirty="0" smtClean="0"/>
-              <a:t> </a:t>
-            </a:r>
-            <a:r>
-              <a:rPr lang="en-US" dirty="0" err="1" smtClean="0"/>
-              <a:t>rosdep</a:t>
-            </a:r>
-            <a:r>
-              <a:rPr lang="en-US" dirty="0" smtClean="0"/>
-              <a:t> </a:t>
-            </a:r>
-            <a:r>
-              <a:rPr lang="en-US" dirty="0" err="1" smtClean="0"/>
-              <a:t>init</a:t>
-            </a:r>
-            <a:endParaRPr lang="en-US" dirty="0" smtClean="0"/>
-          </a:p>
-          <a:p>
-            <a:r>
-              <a:rPr lang="en-US" dirty="0" err="1"/>
-              <a:t>r</a:t>
-            </a:r>
-            <a:r>
-              <a:rPr lang="en-US" dirty="0" err="1" smtClean="0"/>
-              <a:t>osdep</a:t>
-            </a:r>
-            <a:r>
-              <a:rPr lang="en-US" dirty="0" smtClean="0"/>
-              <a:t> update</a:t>
-            </a:r>
-          </a:p>
-          <a:p>
-            <a:r>
-              <a:rPr lang="en-US" dirty="0" err="1"/>
-              <a:t>rosdep</a:t>
-            </a:r>
-            <a:r>
-              <a:rPr lang="en-US" dirty="0"/>
-              <a:t> install -</a:t>
-            </a:r>
-            <a:r>
-              <a:rPr lang="en-US" dirty="0" err="1"/>
-              <a:t>i</a:t>
-            </a:r>
-            <a:r>
-              <a:rPr lang="en-US" dirty="0"/>
-              <a:t> --from-path </a:t>
-            </a:r>
-            <a:r>
-              <a:rPr lang="en-US" dirty="0" err="1"/>
-              <a:t>src</a:t>
-            </a:r>
-            <a:r>
-              <a:rPr lang="en-US" dirty="0"/>
-              <a:t> --</a:t>
-            </a:r>
-            <a:r>
-              <a:rPr lang="en-US" dirty="0" err="1"/>
-              <a:t>rosdistro</a:t>
-            </a:r>
-            <a:r>
-              <a:rPr lang="en-US" dirty="0"/>
-              <a:t> </a:t>
-            </a:r>
-            <a:r>
-              <a:rPr lang="en-US" dirty="0" smtClean="0"/>
-              <a:t>humble</a:t>
-            </a:r>
-          </a:p>
-          <a:p>
-            <a:r>
-              <a:rPr lang="en-US" dirty="0" err="1" smtClean="0"/>
-              <a:t>colcon</a:t>
-            </a:r>
-            <a:r>
-              <a:rPr lang="en-US" dirty="0" smtClean="0"/>
-              <a:t> build</a:t>
-            </a:r>
-          </a:p>
-          <a:p>
-            <a:r>
-              <a:rPr lang="en-US" dirty="0" smtClean="0"/>
-              <a:t># In a NEW terminal source the original and the new build:</a:t>
-            </a:r>
-          </a:p>
-          <a:p>
-            <a:r>
-              <a:rPr lang="en-US" dirty="0"/>
-              <a:t>source /</a:t>
-            </a:r>
-            <a:r>
-              <a:rPr lang="en-US" dirty="0" smtClean="0"/>
-              <a:t>opt/</a:t>
-            </a:r>
-            <a:r>
-              <a:rPr lang="en-US" dirty="0" err="1" smtClean="0"/>
-              <a:t>ros</a:t>
-            </a:r>
-            <a:r>
-              <a:rPr lang="en-US" dirty="0" smtClean="0"/>
-              <a:t>/humble/</a:t>
-            </a:r>
-            <a:r>
-              <a:rPr lang="en-US" dirty="0" err="1" smtClean="0"/>
-              <a:t>setup.bash</a:t>
-            </a:r>
-            <a:endParaRPr lang="en-US" dirty="0" smtClean="0"/>
-          </a:p>
-          <a:p>
-            <a:r>
-              <a:rPr lang="en-US" dirty="0" smtClean="0"/>
-              <a:t>cd ~/ros2_ws</a:t>
-            </a:r>
-          </a:p>
-          <a:p>
-            <a:r>
-              <a:rPr lang="en-US" dirty="0"/>
-              <a:t>source </a:t>
-            </a:r>
-            <a:r>
-              <a:rPr lang="en-US" dirty="0" smtClean="0"/>
-              <a:t>install/</a:t>
-            </a:r>
-            <a:r>
-              <a:rPr lang="en-US" dirty="0" err="1" smtClean="0"/>
-              <a:t>local_setup.bash</a:t>
-            </a:r>
-            <a:endParaRPr lang="en-US" dirty="0" smtClean="0"/>
-          </a:p>
-          <a:p>
-            <a:r>
-              <a:rPr lang="en-US" dirty="0"/>
-              <a:t>ros2 run </a:t>
-            </a:r>
-            <a:r>
-              <a:rPr lang="en-US" dirty="0" err="1"/>
-              <a:t>turtlesim</a:t>
-            </a:r>
-            <a:r>
-              <a:rPr lang="en-US" dirty="0"/>
-              <a:t> </a:t>
-            </a:r>
-            <a:r>
-              <a:rPr lang="en-US" dirty="0" err="1"/>
-              <a:t>turtlesim_node</a:t>
-            </a:r>
-            <a:endParaRPr lang="en-US" dirty="0" smtClean="0"/>
-          </a:p>
-          <a:p>
-            <a:r>
-              <a:rPr lang="en-US" dirty="0" smtClean="0"/>
-              <a:t># If you change the source, need to do the </a:t>
-            </a:r>
-            <a:r>
-              <a:rPr lang="en-US" dirty="0" err="1" smtClean="0"/>
-              <a:t>colcon</a:t>
-            </a:r>
-            <a:r>
-              <a:rPr lang="en-US" dirty="0" smtClean="0"/>
-              <a:t> build again and source it again!</a:t>
-            </a:r>
-          </a:p>
-          <a:p>
-            <a:endParaRPr lang="en-US" dirty="0" smtClean="0"/>
-          </a:p>
-          <a:p>
+              <a:t>bot.set_pwm_servo</a:t>
+            </a:r>
+            <a:r>
+              <a:rPr lang="en-US" dirty="0" smtClean="0"/>
+              <a:t>(1, 90)</a:t>
+            </a:r>
+          </a:p>
+          <a:p>
+            <a:endParaRPr lang="en-US" dirty="0"/>
+          </a:p>
+          <a:p>
+            <a:r>
+              <a:rPr lang="en-US" dirty="0" smtClean="0"/>
+              <a:t>But limited to only 4 PWM servo control lines. Serial controller can do up to 6 and give positional verification feedback – need to get </a:t>
+            </a:r>
+            <a:r>
+              <a:rPr lang="en-US" smtClean="0"/>
+              <a:t>that working!</a:t>
+            </a:r>
             <a:endParaRPr lang="en-US" dirty="0"/>
           </a:p>
         </p:txBody>
@@ -3403,7 +3187,7 @@
     </p:spTree>
     <p:extLst>
       <p:ext uri="{BB962C8B-B14F-4D97-AF65-F5344CB8AC3E}">
-        <p14:creationId xmlns:p14="http://schemas.microsoft.com/office/powerpoint/2010/main" val="4194587478"/>
+        <p14:creationId xmlns:p14="http://schemas.microsoft.com/office/powerpoint/2010/main" val="443737428"/>
       </p:ext>
     </p:extLst>
   </p:cSld>
@@ -3447,6 +3231,840 @@
           <a:p>
             <a:r>
               <a:rPr lang="en-US" dirty="0" smtClean="0"/>
+              <a:t>Control serial servos</a:t>
+            </a:r>
+            <a:endParaRPr lang="en-US" dirty="0"/>
+          </a:p>
+        </p:txBody>
+      </p:sp>
+      <p:sp>
+        <p:nvSpPr>
+          <p:cNvPr id="3" name="Content Placeholder 2"/>
+          <p:cNvSpPr>
+            <a:spLocks noGrp="1"/>
+          </p:cNvSpPr>
+          <p:nvPr>
+            <p:ph idx="1"/>
+          </p:nvPr>
+        </p:nvSpPr>
+        <p:spPr/>
+        <p:txBody>
+          <a:bodyPr/>
+          <a:lstStyle/>
+          <a:p>
+            <a:r>
+              <a:rPr lang="en-US" dirty="0">
+                <a:hlinkClick r:id="rId2"/>
+              </a:rPr>
+              <a:t>9. Control serial servos</a:t>
+            </a:r>
+            <a:endParaRPr lang="en-US" dirty="0" smtClean="0">
+              <a:sym typeface="Wingdings" panose="05000000000000000000" pitchFamily="2" charset="2"/>
+            </a:endParaRPr>
+          </a:p>
+          <a:p>
+            <a:r>
+              <a:rPr lang="en-US" dirty="0" smtClean="0">
+                <a:sym typeface="Wingdings" panose="05000000000000000000" pitchFamily="2" charset="2"/>
+              </a:rPr>
+              <a:t>from </a:t>
+            </a:r>
+            <a:r>
+              <a:rPr lang="en-US" dirty="0" err="1">
+                <a:sym typeface="Wingdings" panose="05000000000000000000" pitchFamily="2" charset="2"/>
+              </a:rPr>
+              <a:t>Rosmaster_Lib</a:t>
+            </a:r>
+            <a:r>
+              <a:rPr lang="en-US" dirty="0">
+                <a:sym typeface="Wingdings" panose="05000000000000000000" pitchFamily="2" charset="2"/>
+              </a:rPr>
+              <a:t> import </a:t>
+            </a:r>
+            <a:r>
+              <a:rPr lang="en-US" dirty="0" err="1">
+                <a:sym typeface="Wingdings" panose="05000000000000000000" pitchFamily="2" charset="2"/>
+              </a:rPr>
+              <a:t>Rosmaster</a:t>
+            </a:r>
+            <a:endParaRPr lang="en-US" dirty="0">
+              <a:sym typeface="Wingdings" panose="05000000000000000000" pitchFamily="2" charset="2"/>
+            </a:endParaRPr>
+          </a:p>
+          <a:p>
+            <a:r>
+              <a:rPr lang="en-US" dirty="0">
+                <a:sym typeface="Wingdings" panose="05000000000000000000" pitchFamily="2" charset="2"/>
+              </a:rPr>
+              <a:t>bot = </a:t>
+            </a:r>
+            <a:r>
+              <a:rPr lang="en-US" dirty="0" err="1">
+                <a:sym typeface="Wingdings" panose="05000000000000000000" pitchFamily="2" charset="2"/>
+              </a:rPr>
+              <a:t>Rosmaster</a:t>
+            </a:r>
+            <a:r>
+              <a:rPr lang="en-US" dirty="0">
+                <a:sym typeface="Wingdings" panose="05000000000000000000" pitchFamily="2" charset="2"/>
+              </a:rPr>
+              <a:t>()</a:t>
+            </a:r>
+          </a:p>
+          <a:p>
+            <a:r>
+              <a:rPr lang="en-US" dirty="0" err="1" smtClean="0"/>
+              <a:t>bot.set_uart_servo_torque</a:t>
+            </a:r>
+            <a:r>
+              <a:rPr lang="en-US" dirty="0" smtClean="0"/>
+              <a:t>(1)</a:t>
+            </a:r>
+          </a:p>
+          <a:p>
+            <a:pPr lvl="1"/>
+            <a:r>
+              <a:rPr lang="en-US" dirty="0" smtClean="0"/>
+              <a:t>*This doesn’t do anything…crap</a:t>
+            </a:r>
+            <a:r>
+              <a:rPr lang="en-US" dirty="0" smtClean="0"/>
+              <a:t>…</a:t>
+            </a:r>
+          </a:p>
+          <a:p>
+            <a:pPr lvl="1"/>
+            <a:r>
+              <a:rPr lang="en-US" dirty="0" smtClean="0"/>
+              <a:t>*Also, serial servo lights up but flashes pattern – something wrong.</a:t>
+            </a:r>
+            <a:endParaRPr lang="en-US" dirty="0" smtClean="0"/>
+          </a:p>
+          <a:p>
+            <a:r>
+              <a:rPr lang="en-US" dirty="0" err="1" smtClean="0"/>
+              <a:t>bot.set_uart_servo_angle</a:t>
+            </a:r>
+            <a:r>
+              <a:rPr lang="en-US" dirty="0" smtClean="0"/>
+              <a:t>(1, 180, 1000)</a:t>
+            </a:r>
+          </a:p>
+          <a:p>
+            <a:pPr lvl="1"/>
+            <a:r>
+              <a:rPr lang="en-US" dirty="0" smtClean="0"/>
+              <a:t>*No matter the parameter ID it always returns -1, crap.</a:t>
+            </a:r>
+          </a:p>
+          <a:p>
+            <a:r>
+              <a:rPr lang="en-US" dirty="0" err="1" smtClean="0"/>
+              <a:t>bot.get_uart_servo_angle</a:t>
+            </a:r>
+            <a:r>
+              <a:rPr lang="en-US" dirty="0" smtClean="0"/>
+              <a:t>(1)</a:t>
+            </a:r>
+            <a:endParaRPr lang="en-US" dirty="0"/>
+          </a:p>
+        </p:txBody>
+      </p:sp>
+    </p:spTree>
+    <p:extLst>
+      <p:ext uri="{BB962C8B-B14F-4D97-AF65-F5344CB8AC3E}">
+        <p14:creationId xmlns:p14="http://schemas.microsoft.com/office/powerpoint/2010/main" val="4044427439"/>
+      </p:ext>
+    </p:extLst>
+  </p:cSld>
+  <p:clrMapOvr>
+    <a:masterClrMapping/>
+  </p:clrMapOvr>
+</p:sld>
+</file>
+
+<file path=ppt/slides/slide12.xml><?xml version="1.0" encoding="utf-8"?>
+<p:sld xmlns:a="http://schemas.openxmlformats.org/drawingml/2006/main" xmlns:r="http://schemas.openxmlformats.org/officeDocument/2006/relationships" xmlns:p="http://schemas.openxmlformats.org/presentationml/2006/main">
+  <p:cSld>
+    <p:spTree>
+      <p:nvGrpSpPr>
+        <p:cNvPr id="1" name=""/>
+        <p:cNvGrpSpPr/>
+        <p:nvPr/>
+      </p:nvGrpSpPr>
+      <p:grpSpPr>
+        <a:xfrm>
+          <a:off x="0" y="0"/>
+          <a:ext cx="0" cy="0"/>
+          <a:chOff x="0" y="0"/>
+          <a:chExt cx="0" cy="0"/>
+        </a:xfrm>
+      </p:grpSpPr>
+      <p:sp>
+        <p:nvSpPr>
+          <p:cNvPr id="2" name="Title 1"/>
+          <p:cNvSpPr>
+            <a:spLocks noGrp="1"/>
+          </p:cNvSpPr>
+          <p:nvPr>
+            <p:ph type="title"/>
+          </p:nvPr>
+        </p:nvSpPr>
+        <p:spPr/>
+        <p:txBody>
+          <a:bodyPr/>
+          <a:lstStyle/>
+          <a:p>
+            <a:r>
+              <a:rPr lang="en-US" dirty="0" smtClean="0"/>
+              <a:t>Installing ROS2 in Linux</a:t>
+            </a:r>
+            <a:endParaRPr lang="en-US" dirty="0"/>
+          </a:p>
+        </p:txBody>
+      </p:sp>
+      <p:sp>
+        <p:nvSpPr>
+          <p:cNvPr id="3" name="Content Placeholder 2"/>
+          <p:cNvSpPr>
+            <a:spLocks noGrp="1"/>
+          </p:cNvSpPr>
+          <p:nvPr>
+            <p:ph idx="1"/>
+          </p:nvPr>
+        </p:nvSpPr>
+        <p:spPr/>
+        <p:txBody>
+          <a:bodyPr/>
+          <a:lstStyle/>
+          <a:p>
+            <a:r>
+              <a:rPr lang="en-US" dirty="0">
+                <a:hlinkClick r:id="rId2"/>
+              </a:rPr>
+              <a:t>https://</a:t>
+            </a:r>
+            <a:r>
+              <a:rPr lang="en-US" dirty="0" smtClean="0">
+                <a:hlinkClick r:id="rId2"/>
+              </a:rPr>
+              <a:t>www.yahboom.net/study/ROS-Driver-Board</a:t>
+            </a:r>
+            <a:endParaRPr lang="en-US" dirty="0" smtClean="0"/>
+          </a:p>
+          <a:p>
+            <a:pPr lvl="1"/>
+            <a:r>
+              <a:rPr lang="en-US" dirty="0" smtClean="0"/>
+              <a:t>Under ‘ROS2 Basic Course’ – ‘ROS2 install Humble’</a:t>
+            </a:r>
+          </a:p>
+        </p:txBody>
+      </p:sp>
+    </p:spTree>
+    <p:extLst>
+      <p:ext uri="{BB962C8B-B14F-4D97-AF65-F5344CB8AC3E}">
+        <p14:creationId xmlns:p14="http://schemas.microsoft.com/office/powerpoint/2010/main" val="1024456953"/>
+      </p:ext>
+    </p:extLst>
+  </p:cSld>
+  <p:clrMapOvr>
+    <a:masterClrMapping/>
+  </p:clrMapOvr>
+</p:sld>
+</file>
+
+<file path=ppt/slides/slide13.xml><?xml version="1.0" encoding="utf-8"?>
+<p:sld xmlns:a="http://schemas.openxmlformats.org/drawingml/2006/main" xmlns:r="http://schemas.openxmlformats.org/officeDocument/2006/relationships" xmlns:p="http://schemas.openxmlformats.org/presentationml/2006/main">
+  <p:cSld>
+    <p:spTree>
+      <p:nvGrpSpPr>
+        <p:cNvPr id="1" name=""/>
+        <p:cNvGrpSpPr/>
+        <p:nvPr/>
+      </p:nvGrpSpPr>
+      <p:grpSpPr>
+        <a:xfrm>
+          <a:off x="0" y="0"/>
+          <a:ext cx="0" cy="0"/>
+          <a:chOff x="0" y="0"/>
+          <a:chExt cx="0" cy="0"/>
+        </a:xfrm>
+      </p:grpSpPr>
+      <p:sp>
+        <p:nvSpPr>
+          <p:cNvPr id="2" name="Title 1"/>
+          <p:cNvSpPr>
+            <a:spLocks noGrp="1"/>
+          </p:cNvSpPr>
+          <p:nvPr>
+            <p:ph type="title"/>
+          </p:nvPr>
+        </p:nvSpPr>
+        <p:spPr/>
+        <p:txBody>
+          <a:bodyPr/>
+          <a:lstStyle/>
+          <a:p>
+            <a:r>
+              <a:rPr lang="en-US" sz="4000" dirty="0" smtClean="0"/>
+              <a:t>Testing the ROS2 install with the Turtle simulator</a:t>
+            </a:r>
+            <a:endParaRPr lang="en-US" dirty="0"/>
+          </a:p>
+        </p:txBody>
+      </p:sp>
+      <p:sp>
+        <p:nvSpPr>
+          <p:cNvPr id="3" name="Content Placeholder 2"/>
+          <p:cNvSpPr>
+            <a:spLocks noGrp="1"/>
+          </p:cNvSpPr>
+          <p:nvPr>
+            <p:ph idx="1"/>
+          </p:nvPr>
+        </p:nvSpPr>
+        <p:spPr/>
+        <p:txBody>
+          <a:bodyPr/>
+          <a:lstStyle/>
+          <a:p>
+            <a:r>
+              <a:rPr lang="en-US" dirty="0" smtClean="0"/>
+              <a:t>Run in separate terminals:</a:t>
+            </a:r>
+          </a:p>
+          <a:p>
+            <a:pPr lvl="1"/>
+            <a:r>
+              <a:rPr lang="en-US" dirty="0" smtClean="0"/>
+              <a:t># Always source first:</a:t>
+            </a:r>
+          </a:p>
+          <a:p>
+            <a:pPr lvl="1"/>
+            <a:r>
+              <a:rPr lang="en-US" dirty="0"/>
+              <a:t>source /opt/</a:t>
+            </a:r>
+            <a:r>
+              <a:rPr lang="en-US" dirty="0" err="1"/>
+              <a:t>ros</a:t>
+            </a:r>
+            <a:r>
+              <a:rPr lang="en-US" dirty="0"/>
+              <a:t>/humble/</a:t>
+            </a:r>
+            <a:r>
+              <a:rPr lang="en-US" dirty="0" err="1"/>
+              <a:t>setup.bash</a:t>
+            </a:r>
+            <a:endParaRPr lang="en-US" dirty="0"/>
+          </a:p>
+          <a:p>
+            <a:pPr lvl="1"/>
+            <a:r>
+              <a:rPr lang="en-US" dirty="0" smtClean="0"/>
+              <a:t># Run ros2 w/turtle simulator</a:t>
+            </a:r>
+          </a:p>
+          <a:p>
+            <a:pPr lvl="1"/>
+            <a:r>
+              <a:rPr lang="en-US" dirty="0" smtClean="0"/>
+              <a:t>ros2 </a:t>
+            </a:r>
+            <a:r>
+              <a:rPr lang="en-US" dirty="0"/>
+              <a:t>run </a:t>
+            </a:r>
+            <a:r>
+              <a:rPr lang="en-US" dirty="0" err="1"/>
+              <a:t>turtlesim</a:t>
+            </a:r>
+            <a:r>
+              <a:rPr lang="en-US" dirty="0"/>
+              <a:t> </a:t>
+            </a:r>
+            <a:r>
+              <a:rPr lang="en-US" dirty="0" err="1" smtClean="0"/>
+              <a:t>turtlesim_node</a:t>
+            </a:r>
+            <a:endParaRPr lang="en-US" dirty="0" smtClean="0"/>
+          </a:p>
+          <a:p>
+            <a:pPr lvl="1"/>
+            <a:r>
+              <a:rPr lang="en-US" dirty="0" smtClean="0"/>
+              <a:t># Control the turtle with the keyboard:</a:t>
+            </a:r>
+          </a:p>
+          <a:p>
+            <a:pPr lvl="1"/>
+            <a:r>
+              <a:rPr lang="en-US" dirty="0" smtClean="0"/>
+              <a:t>ros2 </a:t>
+            </a:r>
+            <a:r>
+              <a:rPr lang="en-US" dirty="0"/>
+              <a:t>run </a:t>
+            </a:r>
+            <a:r>
+              <a:rPr lang="en-US" dirty="0" err="1"/>
+              <a:t>turtlesim</a:t>
+            </a:r>
+            <a:r>
+              <a:rPr lang="en-US" dirty="0"/>
+              <a:t> </a:t>
+            </a:r>
+            <a:r>
+              <a:rPr lang="en-US" dirty="0" err="1" smtClean="0"/>
+              <a:t>turtle_teleop_key</a:t>
+            </a:r>
+            <a:endParaRPr lang="en-US" dirty="0" smtClean="0"/>
+          </a:p>
+          <a:p>
+            <a:pPr lvl="1"/>
+            <a:r>
+              <a:rPr lang="en-US" dirty="0" smtClean="0"/>
+              <a:t># Get telemetry info:</a:t>
+            </a:r>
+          </a:p>
+          <a:p>
+            <a:pPr lvl="1"/>
+            <a:r>
+              <a:rPr lang="en-US" dirty="0"/>
+              <a:t>ros2 topic echo /turtle1/</a:t>
+            </a:r>
+            <a:r>
+              <a:rPr lang="en-US" dirty="0" err="1"/>
+              <a:t>cmd_vel</a:t>
+            </a:r>
+            <a:endParaRPr lang="en-US" dirty="0"/>
+          </a:p>
+        </p:txBody>
+      </p:sp>
+    </p:spTree>
+    <p:extLst>
+      <p:ext uri="{BB962C8B-B14F-4D97-AF65-F5344CB8AC3E}">
+        <p14:creationId xmlns:p14="http://schemas.microsoft.com/office/powerpoint/2010/main" val="49954300"/>
+      </p:ext>
+    </p:extLst>
+  </p:cSld>
+  <p:clrMapOvr>
+    <a:masterClrMapping/>
+  </p:clrMapOvr>
+</p:sld>
+</file>
+
+<file path=ppt/slides/slide14.xml><?xml version="1.0" encoding="utf-8"?>
+<p:sld xmlns:a="http://schemas.openxmlformats.org/drawingml/2006/main" xmlns:r="http://schemas.openxmlformats.org/officeDocument/2006/relationships" xmlns:p="http://schemas.openxmlformats.org/presentationml/2006/main">
+  <p:cSld>
+    <p:spTree>
+      <p:nvGrpSpPr>
+        <p:cNvPr id="1" name=""/>
+        <p:cNvGrpSpPr/>
+        <p:nvPr/>
+      </p:nvGrpSpPr>
+      <p:grpSpPr>
+        <a:xfrm>
+          <a:off x="0" y="0"/>
+          <a:ext cx="0" cy="0"/>
+          <a:chOff x="0" y="0"/>
+          <a:chExt cx="0" cy="0"/>
+        </a:xfrm>
+      </p:grpSpPr>
+      <p:sp>
+        <p:nvSpPr>
+          <p:cNvPr id="2" name="Title 1"/>
+          <p:cNvSpPr>
+            <a:spLocks noGrp="1"/>
+          </p:cNvSpPr>
+          <p:nvPr>
+            <p:ph type="title"/>
+          </p:nvPr>
+        </p:nvSpPr>
+        <p:spPr/>
+        <p:txBody>
+          <a:bodyPr>
+            <a:normAutofit/>
+          </a:bodyPr>
+          <a:lstStyle/>
+          <a:p>
+            <a:r>
+              <a:rPr lang="en-US" dirty="0" smtClean="0"/>
+              <a:t>Creating new ROS2 </a:t>
+            </a:r>
+            <a:r>
+              <a:rPr lang="en-US" dirty="0"/>
+              <a:t>workspace</a:t>
+            </a:r>
+            <a:br>
+              <a:rPr lang="en-US" dirty="0"/>
+            </a:br>
+            <a:r>
+              <a:rPr lang="en-US" sz="1400" dirty="0"/>
+              <a:t>https://docs.ros.org/en/humble/Tutorials/Beginner-Client-Libraries/Creating-A-Workspace/Creating-A-Workspace.html</a:t>
+            </a:r>
+            <a:endParaRPr lang="en-US" dirty="0"/>
+          </a:p>
+        </p:txBody>
+      </p:sp>
+      <p:sp>
+        <p:nvSpPr>
+          <p:cNvPr id="3" name="Content Placeholder 2"/>
+          <p:cNvSpPr>
+            <a:spLocks noGrp="1"/>
+          </p:cNvSpPr>
+          <p:nvPr>
+            <p:ph idx="1"/>
+          </p:nvPr>
+        </p:nvSpPr>
+        <p:spPr>
+          <a:xfrm>
+            <a:off x="838200" y="1825624"/>
+            <a:ext cx="10515600" cy="4816715"/>
+          </a:xfrm>
+        </p:spPr>
+        <p:txBody>
+          <a:bodyPr>
+            <a:normAutofit fontScale="47500" lnSpcReduction="20000"/>
+          </a:bodyPr>
+          <a:lstStyle/>
+          <a:p>
+            <a:r>
+              <a:rPr lang="en-US" dirty="0"/>
+              <a:t>source /</a:t>
+            </a:r>
+            <a:r>
+              <a:rPr lang="en-US" dirty="0" smtClean="0"/>
+              <a:t>opt/</a:t>
+            </a:r>
+            <a:r>
+              <a:rPr lang="en-US" dirty="0" err="1" smtClean="0"/>
+              <a:t>ros</a:t>
+            </a:r>
+            <a:r>
+              <a:rPr lang="en-US" dirty="0" smtClean="0"/>
+              <a:t>/humble/</a:t>
+            </a:r>
+            <a:r>
+              <a:rPr lang="en-US" dirty="0" err="1" smtClean="0"/>
+              <a:t>setup.bash</a:t>
+            </a:r>
+            <a:endParaRPr lang="en-US" dirty="0" smtClean="0"/>
+          </a:p>
+          <a:p>
+            <a:r>
+              <a:rPr lang="en-US" dirty="0" err="1"/>
+              <a:t>mkdir</a:t>
+            </a:r>
+            <a:r>
+              <a:rPr lang="en-US" dirty="0"/>
+              <a:t> -p ~/</a:t>
+            </a:r>
+            <a:r>
+              <a:rPr lang="en-US" dirty="0" smtClean="0"/>
+              <a:t>ros2_ws/</a:t>
+            </a:r>
+            <a:r>
+              <a:rPr lang="en-US" dirty="0" err="1" smtClean="0"/>
+              <a:t>src</a:t>
+            </a:r>
+            <a:endParaRPr lang="en-US" dirty="0" smtClean="0"/>
+          </a:p>
+          <a:p>
+            <a:r>
+              <a:rPr lang="en-US" dirty="0"/>
+              <a:t>cd ~/</a:t>
+            </a:r>
+            <a:r>
+              <a:rPr lang="en-US" dirty="0" smtClean="0"/>
+              <a:t>ros2_ws/</a:t>
+            </a:r>
+            <a:r>
+              <a:rPr lang="en-US" dirty="0" err="1" smtClean="0"/>
+              <a:t>src</a:t>
+            </a:r>
+            <a:endParaRPr lang="en-US" dirty="0" smtClean="0"/>
+          </a:p>
+          <a:p>
+            <a:r>
+              <a:rPr lang="en-US" dirty="0" smtClean="0"/>
+              <a:t># Clone your repo into </a:t>
+            </a:r>
+            <a:r>
+              <a:rPr lang="en-US" dirty="0" err="1" smtClean="0"/>
+              <a:t>src</a:t>
+            </a:r>
+            <a:r>
+              <a:rPr lang="en-US" dirty="0" smtClean="0"/>
+              <a:t> (this is example that includes the turtle </a:t>
+            </a:r>
+            <a:r>
+              <a:rPr lang="en-US" dirty="0" err="1" smtClean="0"/>
+              <a:t>sim</a:t>
+            </a:r>
+            <a:r>
+              <a:rPr lang="en-US" dirty="0" smtClean="0"/>
+              <a:t>).</a:t>
+            </a:r>
+          </a:p>
+          <a:p>
+            <a:r>
+              <a:rPr lang="en-US" dirty="0" err="1"/>
+              <a:t>git</a:t>
+            </a:r>
+            <a:r>
+              <a:rPr lang="en-US" dirty="0"/>
+              <a:t> clone https://github.com/ros/ros_tutorials.git -b </a:t>
+            </a:r>
+            <a:r>
+              <a:rPr lang="en-US" dirty="0" smtClean="0"/>
+              <a:t>humble</a:t>
+            </a:r>
+          </a:p>
+          <a:p>
+            <a:r>
+              <a:rPr lang="en-US" dirty="0" smtClean="0"/>
+              <a:t># Go back to base directory.</a:t>
+            </a:r>
+          </a:p>
+          <a:p>
+            <a:r>
+              <a:rPr lang="en-US" dirty="0" smtClean="0"/>
+              <a:t>cd ..</a:t>
+            </a:r>
+          </a:p>
+          <a:p>
+            <a:r>
+              <a:rPr lang="en-US" dirty="0" smtClean="0"/>
+              <a:t># Need to initialize (just once).</a:t>
+            </a:r>
+          </a:p>
+          <a:p>
+            <a:r>
+              <a:rPr lang="en-US" dirty="0" err="1" smtClean="0"/>
+              <a:t>sudo</a:t>
+            </a:r>
+            <a:r>
+              <a:rPr lang="en-US" dirty="0" smtClean="0"/>
+              <a:t> </a:t>
+            </a:r>
+            <a:r>
+              <a:rPr lang="en-US" dirty="0" err="1" smtClean="0"/>
+              <a:t>rosdep</a:t>
+            </a:r>
+            <a:r>
+              <a:rPr lang="en-US" dirty="0" smtClean="0"/>
+              <a:t> </a:t>
+            </a:r>
+            <a:r>
+              <a:rPr lang="en-US" dirty="0" err="1" smtClean="0"/>
+              <a:t>init</a:t>
+            </a:r>
+            <a:endParaRPr lang="en-US" dirty="0" smtClean="0"/>
+          </a:p>
+          <a:p>
+            <a:r>
+              <a:rPr lang="en-US" dirty="0" err="1"/>
+              <a:t>r</a:t>
+            </a:r>
+            <a:r>
+              <a:rPr lang="en-US" dirty="0" err="1" smtClean="0"/>
+              <a:t>osdep</a:t>
+            </a:r>
+            <a:r>
+              <a:rPr lang="en-US" dirty="0" smtClean="0"/>
+              <a:t> update</a:t>
+            </a:r>
+          </a:p>
+          <a:p>
+            <a:r>
+              <a:rPr lang="en-US" dirty="0" err="1"/>
+              <a:t>rosdep</a:t>
+            </a:r>
+            <a:r>
+              <a:rPr lang="en-US" dirty="0"/>
+              <a:t> install -</a:t>
+            </a:r>
+            <a:r>
+              <a:rPr lang="en-US" dirty="0" err="1"/>
+              <a:t>i</a:t>
+            </a:r>
+            <a:r>
+              <a:rPr lang="en-US" dirty="0"/>
+              <a:t> --from-path </a:t>
+            </a:r>
+            <a:r>
+              <a:rPr lang="en-US" dirty="0" err="1"/>
+              <a:t>src</a:t>
+            </a:r>
+            <a:r>
+              <a:rPr lang="en-US" dirty="0"/>
+              <a:t> --</a:t>
+            </a:r>
+            <a:r>
+              <a:rPr lang="en-US" dirty="0" err="1"/>
+              <a:t>rosdistro</a:t>
+            </a:r>
+            <a:r>
+              <a:rPr lang="en-US" dirty="0"/>
+              <a:t> </a:t>
+            </a:r>
+            <a:r>
+              <a:rPr lang="en-US" dirty="0" smtClean="0"/>
+              <a:t>humble</a:t>
+            </a:r>
+          </a:p>
+          <a:p>
+            <a:r>
+              <a:rPr lang="en-US" dirty="0" err="1" smtClean="0"/>
+              <a:t>colcon</a:t>
+            </a:r>
+            <a:r>
+              <a:rPr lang="en-US" dirty="0" smtClean="0"/>
+              <a:t> build</a:t>
+            </a:r>
+          </a:p>
+          <a:p>
+            <a:r>
+              <a:rPr lang="en-US" dirty="0" smtClean="0"/>
+              <a:t># In a NEW terminal source the original and the new build:</a:t>
+            </a:r>
+          </a:p>
+          <a:p>
+            <a:r>
+              <a:rPr lang="en-US" dirty="0"/>
+              <a:t>source /</a:t>
+            </a:r>
+            <a:r>
+              <a:rPr lang="en-US" dirty="0" smtClean="0"/>
+              <a:t>opt/</a:t>
+            </a:r>
+            <a:r>
+              <a:rPr lang="en-US" dirty="0" err="1" smtClean="0"/>
+              <a:t>ros</a:t>
+            </a:r>
+            <a:r>
+              <a:rPr lang="en-US" dirty="0" smtClean="0"/>
+              <a:t>/humble/</a:t>
+            </a:r>
+            <a:r>
+              <a:rPr lang="en-US" dirty="0" err="1" smtClean="0"/>
+              <a:t>setup.bash</a:t>
+            </a:r>
+            <a:endParaRPr lang="en-US" dirty="0" smtClean="0"/>
+          </a:p>
+          <a:p>
+            <a:r>
+              <a:rPr lang="en-US" dirty="0" smtClean="0"/>
+              <a:t>cd ~/ros2_ws</a:t>
+            </a:r>
+          </a:p>
+          <a:p>
+            <a:r>
+              <a:rPr lang="en-US" dirty="0"/>
+              <a:t>source </a:t>
+            </a:r>
+            <a:r>
+              <a:rPr lang="en-US" dirty="0" smtClean="0"/>
+              <a:t>install/</a:t>
+            </a:r>
+            <a:r>
+              <a:rPr lang="en-US" dirty="0" err="1" smtClean="0"/>
+              <a:t>local_setup.bash</a:t>
+            </a:r>
+            <a:endParaRPr lang="en-US" dirty="0" smtClean="0"/>
+          </a:p>
+          <a:p>
+            <a:r>
+              <a:rPr lang="en-US" dirty="0"/>
+              <a:t>ros2 run </a:t>
+            </a:r>
+            <a:r>
+              <a:rPr lang="en-US" dirty="0" err="1"/>
+              <a:t>turtlesim</a:t>
+            </a:r>
+            <a:r>
+              <a:rPr lang="en-US" dirty="0"/>
+              <a:t> </a:t>
+            </a:r>
+            <a:r>
+              <a:rPr lang="en-US" dirty="0" err="1"/>
+              <a:t>turtlesim_node</a:t>
+            </a:r>
+            <a:endParaRPr lang="en-US" dirty="0" smtClean="0"/>
+          </a:p>
+          <a:p>
+            <a:r>
+              <a:rPr lang="en-US" dirty="0" smtClean="0"/>
+              <a:t># If you change the source, need to do the </a:t>
+            </a:r>
+            <a:r>
+              <a:rPr lang="en-US" dirty="0" err="1" smtClean="0"/>
+              <a:t>colcon</a:t>
+            </a:r>
+            <a:r>
+              <a:rPr lang="en-US" dirty="0" smtClean="0"/>
+              <a:t> build again and source it again!</a:t>
+            </a:r>
+          </a:p>
+          <a:p>
+            <a:endParaRPr lang="en-US" dirty="0" smtClean="0"/>
+          </a:p>
+          <a:p>
+            <a:endParaRPr lang="en-US" dirty="0"/>
+          </a:p>
+        </p:txBody>
+      </p:sp>
+    </p:spTree>
+    <p:extLst>
+      <p:ext uri="{BB962C8B-B14F-4D97-AF65-F5344CB8AC3E}">
+        <p14:creationId xmlns:p14="http://schemas.microsoft.com/office/powerpoint/2010/main" val="4194587478"/>
+      </p:ext>
+    </p:extLst>
+  </p:cSld>
+  <p:clrMapOvr>
+    <a:masterClrMapping/>
+  </p:clrMapOvr>
+</p:sld>
+</file>
+
+<file path=ppt/slides/slide15.xml><?xml version="1.0" encoding="utf-8"?>
+<p:sld xmlns:a="http://schemas.openxmlformats.org/drawingml/2006/main" xmlns:r="http://schemas.openxmlformats.org/officeDocument/2006/relationships" xmlns:p="http://schemas.openxmlformats.org/presentationml/2006/main">
+  <p:cSld>
+    <p:spTree>
+      <p:nvGrpSpPr>
+        <p:cNvPr id="1" name=""/>
+        <p:cNvGrpSpPr/>
+        <p:nvPr/>
+      </p:nvGrpSpPr>
+      <p:grpSpPr>
+        <a:xfrm>
+          <a:off x="0" y="0"/>
+          <a:ext cx="0" cy="0"/>
+          <a:chOff x="0" y="0"/>
+          <a:chExt cx="0" cy="0"/>
+        </a:xfrm>
+      </p:grpSpPr>
+      <p:sp>
+        <p:nvSpPr>
+          <p:cNvPr id="2" name="Title 1"/>
+          <p:cNvSpPr>
+            <a:spLocks noGrp="1"/>
+          </p:cNvSpPr>
+          <p:nvPr>
+            <p:ph type="title"/>
+          </p:nvPr>
+        </p:nvSpPr>
+        <p:spPr/>
+        <p:txBody>
+          <a:bodyPr/>
+          <a:lstStyle/>
+          <a:p>
+            <a:r>
+              <a:rPr lang="en-US" dirty="0" smtClean="0"/>
               <a:t>Change tutorial </a:t>
             </a:r>
             <a:r>
@@ -3580,7 +4198,7 @@
 </p:sld>
 </file>
 
-<file path=ppt/slides/slide12.xml><?xml version="1.0" encoding="utf-8"?>
+<file path=ppt/slides/slide16.xml><?xml version="1.0" encoding="utf-8"?>
 <p:sld xmlns:a="http://schemas.openxmlformats.org/drawingml/2006/main" xmlns:r="http://schemas.openxmlformats.org/officeDocument/2006/relationships" xmlns:p="http://schemas.openxmlformats.org/presentationml/2006/main">
   <p:cSld>
     <p:spTree>
@@ -4270,7 +4888,13 @@
           <a:p>
             <a:r>
               <a:rPr lang="en-US" dirty="0" smtClean="0"/>
-              <a:t>Appears to support up to 5 servos. One 3-pin white connector is slightly non-standard.</a:t>
+              <a:t>Appears to support up to 5 regular servos.</a:t>
+            </a:r>
+          </a:p>
+          <a:p>
+            <a:r>
+              <a:rPr lang="en-US" dirty="0" smtClean="0"/>
+              <a:t>3-pin white connector is for serial bus servos (up to 6)!!</a:t>
             </a:r>
             <a:endParaRPr lang="en-US" dirty="0"/>
           </a:p>
@@ -4323,15 +4947,7 @@
           <a:p>
             <a:r>
               <a:rPr lang="en-US" dirty="0" smtClean="0"/>
-              <a:t>Connecting from Linux / Pi using straight Python (the </a:t>
-            </a:r>
-            <a:r>
-              <a:rPr lang="en-US" dirty="0" err="1" smtClean="0"/>
-              <a:t>Rosmaster_Lib</a:t>
-            </a:r>
-            <a:r>
-              <a:rPr lang="en-US" dirty="0" smtClean="0"/>
-              <a:t>)</a:t>
+              <a:t>Links</a:t>
             </a:r>
             <a:endParaRPr lang="en-US" dirty="0"/>
           </a:p>
@@ -4349,430 +4965,14 @@
         </p:nvSpPr>
         <p:spPr/>
         <p:txBody>
-          <a:bodyPr>
-            <a:normAutofit fontScale="47500" lnSpcReduction="20000"/>
-          </a:bodyPr>
-          <a:lstStyle/>
-          <a:p>
-            <a:r>
-              <a:rPr lang="en-US" dirty="0" err="1" smtClean="0"/>
-              <a:t>lsusb</a:t>
-            </a:r>
-            <a:r>
-              <a:rPr lang="en-US" dirty="0" smtClean="0"/>
-              <a:t> to verify it sees the ‘</a:t>
-            </a:r>
-            <a:r>
-              <a:rPr lang="en-US" dirty="0" err="1" smtClean="0"/>
-              <a:t>QinHeng</a:t>
-            </a:r>
-            <a:r>
-              <a:rPr lang="en-US" dirty="0" smtClean="0"/>
-              <a:t>’ device</a:t>
-            </a:r>
-          </a:p>
-          <a:p>
-            <a:r>
-              <a:rPr lang="en-US" dirty="0" smtClean="0"/>
-              <a:t>Make /</a:t>
-            </a:r>
-            <a:r>
-              <a:rPr lang="en-US" dirty="0" err="1" smtClean="0"/>
-              <a:t>etc</a:t>
-            </a:r>
-            <a:r>
-              <a:rPr lang="en-US" dirty="0" smtClean="0"/>
-              <a:t>/</a:t>
-            </a:r>
-            <a:r>
-              <a:rPr lang="en-US" dirty="0" err="1" smtClean="0"/>
-              <a:t>udev</a:t>
-            </a:r>
-            <a:r>
-              <a:rPr lang="en-US" dirty="0" smtClean="0"/>
-              <a:t>/</a:t>
-            </a:r>
-            <a:r>
-              <a:rPr lang="en-US" dirty="0" err="1" smtClean="0"/>
-              <a:t>rules.d</a:t>
-            </a:r>
-            <a:r>
-              <a:rPr lang="en-US" dirty="0" smtClean="0"/>
-              <a:t>/</a:t>
-            </a:r>
-            <a:r>
-              <a:rPr lang="en-US" dirty="0" err="1" smtClean="0"/>
-              <a:t>myserial.rules</a:t>
-            </a:r>
-            <a:r>
-              <a:rPr lang="en-US" dirty="0" smtClean="0"/>
-              <a:t> file with:</a:t>
-            </a:r>
-          </a:p>
-          <a:p>
-            <a:pPr lvl="1"/>
-            <a:r>
-              <a:rPr lang="en-US" sz="1400" dirty="0"/>
-              <a:t>KERNEL=="</a:t>
-            </a:r>
-            <a:r>
-              <a:rPr lang="en-US" sz="1400" dirty="0" err="1"/>
-              <a:t>ttyUSB</a:t>
-            </a:r>
-            <a:r>
-              <a:rPr lang="en-US" sz="1400" dirty="0"/>
-              <a:t>*", ATTRS{</a:t>
-            </a:r>
-            <a:r>
-              <a:rPr lang="en-US" sz="1400" dirty="0" err="1"/>
-              <a:t>idVendor</a:t>
-            </a:r>
-            <a:r>
-              <a:rPr lang="en-US" sz="1400" dirty="0"/>
-              <a:t>}=="1a86", ATTRS{</a:t>
-            </a:r>
-            <a:r>
-              <a:rPr lang="en-US" sz="1400" dirty="0" err="1"/>
-              <a:t>idProduct</a:t>
-            </a:r>
-            <a:r>
-              <a:rPr lang="en-US" sz="1400" dirty="0"/>
-              <a:t>}=="7523", MODE:="0777", SYMLINK+="</a:t>
-            </a:r>
-            <a:r>
-              <a:rPr lang="en-US" sz="1400" dirty="0" err="1" smtClean="0"/>
-              <a:t>myserial</a:t>
-            </a:r>
-            <a:r>
-              <a:rPr lang="en-US" sz="1400" dirty="0" smtClean="0"/>
-              <a:t>“</a:t>
-            </a:r>
-          </a:p>
-          <a:p>
-            <a:pPr lvl="1"/>
-            <a:r>
-              <a:rPr lang="en-US" dirty="0" smtClean="0"/>
-              <a:t>'/dev/</a:t>
-            </a:r>
-            <a:r>
-              <a:rPr lang="en-US" dirty="0" err="1" smtClean="0"/>
-              <a:t>myserial</a:t>
-            </a:r>
-            <a:r>
-              <a:rPr lang="en-US" dirty="0" smtClean="0"/>
-              <a:t>' is what the </a:t>
-            </a:r>
-            <a:r>
-              <a:rPr lang="en-US" dirty="0" err="1" smtClean="0"/>
-              <a:t>Rosmaster</a:t>
-            </a:r>
-            <a:r>
-              <a:rPr lang="en-US" dirty="0" smtClean="0"/>
-              <a:t> bot constructer uses to connect</a:t>
-            </a:r>
-          </a:p>
-          <a:p>
-            <a:r>
-              <a:rPr lang="en-US" dirty="0" smtClean="0"/>
-              <a:t>It should have these permissions: -</a:t>
-            </a:r>
-            <a:r>
-              <a:rPr lang="en-US" dirty="0" err="1" smtClean="0"/>
-              <a:t>rwxr</a:t>
-            </a:r>
-            <a:r>
-              <a:rPr lang="en-US" dirty="0" smtClean="0"/>
-              <a:t>-</a:t>
-            </a:r>
-            <a:r>
-              <a:rPr lang="en-US" dirty="0" err="1" smtClean="0"/>
-              <a:t>xr</a:t>
-            </a:r>
-            <a:r>
-              <a:rPr lang="en-US" dirty="0" smtClean="0"/>
-              <a:t>-x</a:t>
-            </a:r>
-          </a:p>
-          <a:p>
-            <a:r>
-              <a:rPr lang="en-US" dirty="0" smtClean="0"/>
-              <a:t>ls -l /dev/</a:t>
-            </a:r>
-            <a:r>
-              <a:rPr lang="en-US" dirty="0" err="1" smtClean="0"/>
-              <a:t>myserial</a:t>
-            </a:r>
-            <a:r>
-              <a:rPr lang="en-US" dirty="0" smtClean="0"/>
-              <a:t> should show the link: /dev/</a:t>
-            </a:r>
-            <a:r>
-              <a:rPr lang="en-US" dirty="0" err="1" smtClean="0"/>
-              <a:t>myserial</a:t>
-            </a:r>
-            <a:r>
-              <a:rPr lang="en-US" dirty="0" smtClean="0"/>
-              <a:t> </a:t>
-            </a:r>
-            <a:r>
-              <a:rPr lang="en-US" dirty="0" smtClean="0">
-                <a:sym typeface="Wingdings" panose="05000000000000000000" pitchFamily="2" charset="2"/>
-              </a:rPr>
-              <a:t> ttyUSB0</a:t>
-            </a:r>
-          </a:p>
-          <a:p>
-            <a:r>
-              <a:rPr lang="en-US" dirty="0" smtClean="0">
-                <a:sym typeface="Wingdings" panose="05000000000000000000" pitchFamily="2" charset="2"/>
-              </a:rPr>
-              <a:t>Install </a:t>
-            </a:r>
-            <a:r>
-              <a:rPr lang="en-US" dirty="0" err="1" smtClean="0">
-                <a:sym typeface="Wingdings" panose="05000000000000000000" pitchFamily="2" charset="2"/>
-              </a:rPr>
-              <a:t>Rosmaster</a:t>
-            </a:r>
-            <a:r>
-              <a:rPr lang="en-US" dirty="0" smtClean="0">
-                <a:sym typeface="Wingdings" panose="05000000000000000000" pitchFamily="2" charset="2"/>
-              </a:rPr>
-              <a:t> library from code from downloaded py_install.zip:</a:t>
-            </a:r>
-          </a:p>
-          <a:p>
-            <a:pPr lvl="1"/>
-            <a:r>
-              <a:rPr lang="en-US" dirty="0" smtClean="0">
-                <a:sym typeface="Wingdings" panose="05000000000000000000" pitchFamily="2" charset="2"/>
-              </a:rPr>
-              <a:t>cd </a:t>
-            </a:r>
-            <a:r>
-              <a:rPr lang="en-US" dirty="0" err="1" smtClean="0">
-                <a:sym typeface="Wingdings" panose="05000000000000000000" pitchFamily="2" charset="2"/>
-              </a:rPr>
-              <a:t>py_install</a:t>
-            </a:r>
-            <a:endParaRPr lang="en-US" dirty="0" smtClean="0">
-              <a:sym typeface="Wingdings" panose="05000000000000000000" pitchFamily="2" charset="2"/>
-            </a:endParaRPr>
-          </a:p>
-          <a:p>
-            <a:pPr lvl="1"/>
-            <a:r>
-              <a:rPr lang="en-US" dirty="0" err="1" smtClean="0">
-                <a:sym typeface="Wingdings" panose="05000000000000000000" pitchFamily="2" charset="2"/>
-              </a:rPr>
-              <a:t>sudo</a:t>
-            </a:r>
-            <a:r>
-              <a:rPr lang="en-US" dirty="0" smtClean="0">
-                <a:sym typeface="Wingdings" panose="05000000000000000000" pitchFamily="2" charset="2"/>
-              </a:rPr>
-              <a:t> python3 setup.py install</a:t>
-            </a:r>
-          </a:p>
-          <a:p>
-            <a:pPr lvl="1"/>
-            <a:r>
-              <a:rPr lang="en-US" dirty="0" smtClean="0">
-                <a:sym typeface="Wingdings" panose="05000000000000000000" pitchFamily="2" charset="2"/>
-              </a:rPr>
-              <a:t>*Might also have to re-install the serial library</a:t>
-            </a:r>
-          </a:p>
-          <a:p>
-            <a:pPr lvl="2"/>
-            <a:r>
-              <a:rPr lang="en-US" dirty="0" err="1" smtClean="0">
-                <a:sym typeface="Wingdings" panose="05000000000000000000" pitchFamily="2" charset="2"/>
-              </a:rPr>
-              <a:t>sudo</a:t>
-            </a:r>
-            <a:r>
-              <a:rPr lang="en-US" dirty="0" smtClean="0">
-                <a:sym typeface="Wingdings" panose="05000000000000000000" pitchFamily="2" charset="2"/>
-              </a:rPr>
-              <a:t> pip3 uninstall serial</a:t>
-            </a:r>
-          </a:p>
-          <a:p>
-            <a:pPr lvl="2"/>
-            <a:r>
-              <a:rPr lang="en-US" dirty="0" err="1" smtClean="0">
-                <a:sym typeface="Wingdings" panose="05000000000000000000" pitchFamily="2" charset="2"/>
-              </a:rPr>
-              <a:t>sudo</a:t>
-            </a:r>
-            <a:r>
-              <a:rPr lang="en-US" dirty="0" smtClean="0">
-                <a:sym typeface="Wingdings" panose="05000000000000000000" pitchFamily="2" charset="2"/>
-              </a:rPr>
-              <a:t> pip3 install </a:t>
-            </a:r>
-            <a:r>
-              <a:rPr lang="en-US" dirty="0" err="1" smtClean="0">
-                <a:sym typeface="Wingdings" panose="05000000000000000000" pitchFamily="2" charset="2"/>
-              </a:rPr>
-              <a:t>pyserial</a:t>
-            </a:r>
-            <a:endParaRPr lang="en-US" dirty="0" smtClean="0">
-              <a:sym typeface="Wingdings" panose="05000000000000000000" pitchFamily="2" charset="2"/>
-            </a:endParaRPr>
-          </a:p>
-          <a:p>
-            <a:r>
-              <a:rPr lang="en-US" dirty="0" smtClean="0">
-                <a:sym typeface="Wingdings" panose="05000000000000000000" pitchFamily="2" charset="2"/>
-              </a:rPr>
-              <a:t>Then you can execute in python:</a:t>
-            </a:r>
-          </a:p>
-          <a:p>
-            <a:pPr lvl="1"/>
-            <a:r>
-              <a:rPr lang="en-US" dirty="0" smtClean="0">
-                <a:sym typeface="Wingdings" panose="05000000000000000000" pitchFamily="2" charset="2"/>
-              </a:rPr>
-              <a:t>from </a:t>
-            </a:r>
-            <a:r>
-              <a:rPr lang="en-US" dirty="0" err="1" smtClean="0">
-                <a:sym typeface="Wingdings" panose="05000000000000000000" pitchFamily="2" charset="2"/>
-              </a:rPr>
-              <a:t>Rosmaster_Lib</a:t>
-            </a:r>
-            <a:r>
-              <a:rPr lang="en-US" dirty="0" smtClean="0">
-                <a:sym typeface="Wingdings" panose="05000000000000000000" pitchFamily="2" charset="2"/>
-              </a:rPr>
-              <a:t> import </a:t>
-            </a:r>
-            <a:r>
-              <a:rPr lang="en-US" dirty="0" err="1" smtClean="0">
-                <a:sym typeface="Wingdings" panose="05000000000000000000" pitchFamily="2" charset="2"/>
-              </a:rPr>
-              <a:t>Rosmaster</a:t>
-            </a:r>
-            <a:endParaRPr lang="en-US" dirty="0" smtClean="0">
-              <a:sym typeface="Wingdings" panose="05000000000000000000" pitchFamily="2" charset="2"/>
-            </a:endParaRPr>
-          </a:p>
-          <a:p>
-            <a:pPr lvl="1"/>
-            <a:r>
-              <a:rPr lang="en-US" dirty="0" smtClean="0">
-                <a:sym typeface="Wingdings" panose="05000000000000000000" pitchFamily="2" charset="2"/>
-              </a:rPr>
-              <a:t>bot = </a:t>
-            </a:r>
-            <a:r>
-              <a:rPr lang="en-US" dirty="0" err="1" smtClean="0">
-                <a:sym typeface="Wingdings" panose="05000000000000000000" pitchFamily="2" charset="2"/>
-              </a:rPr>
-              <a:t>Rosmaster</a:t>
-            </a:r>
-            <a:r>
-              <a:rPr lang="en-US" dirty="0" smtClean="0">
-                <a:sym typeface="Wingdings" panose="05000000000000000000" pitchFamily="2" charset="2"/>
-              </a:rPr>
-              <a:t>()</a:t>
-            </a:r>
-          </a:p>
-          <a:p>
-            <a:pPr lvl="1"/>
-            <a:r>
-              <a:rPr lang="en-US" dirty="0" err="1" smtClean="0">
-                <a:sym typeface="Wingdings" panose="05000000000000000000" pitchFamily="2" charset="2"/>
-              </a:rPr>
-              <a:t>bot.set_motor</a:t>
-            </a:r>
-            <a:r>
-              <a:rPr lang="en-US" dirty="0" smtClean="0">
-                <a:sym typeface="Wingdings" panose="05000000000000000000" pitchFamily="2" charset="2"/>
-              </a:rPr>
-              <a:t>(50,0,0,0)</a:t>
-            </a:r>
-          </a:p>
-          <a:p>
-            <a:pPr lvl="1"/>
-            <a:r>
-              <a:rPr lang="en-US" dirty="0" err="1">
-                <a:sym typeface="Wingdings" panose="05000000000000000000" pitchFamily="2" charset="2"/>
-              </a:rPr>
-              <a:t>b</a:t>
-            </a:r>
-            <a:r>
-              <a:rPr lang="en-US" dirty="0" err="1" smtClean="0">
-                <a:sym typeface="Wingdings" panose="05000000000000000000" pitchFamily="2" charset="2"/>
-              </a:rPr>
-              <a:t>ot.set_beep</a:t>
-            </a:r>
-            <a:r>
-              <a:rPr lang="en-US" dirty="0" smtClean="0">
-                <a:sym typeface="Wingdings" panose="05000000000000000000" pitchFamily="2" charset="2"/>
-              </a:rPr>
-              <a:t>(100</a:t>
-            </a:r>
-            <a:r>
-              <a:rPr lang="en-US" dirty="0" smtClean="0">
-                <a:sym typeface="Wingdings" panose="05000000000000000000" pitchFamily="2" charset="2"/>
-              </a:rPr>
-              <a:t>)</a:t>
-            </a:r>
-          </a:p>
-          <a:p>
-            <a:r>
-              <a:rPr lang="en-US" dirty="0" smtClean="0">
-                <a:sym typeface="Wingdings" panose="05000000000000000000" pitchFamily="2" charset="2"/>
-              </a:rPr>
-              <a:t>You can also call the </a:t>
-            </a:r>
-            <a:r>
-              <a:rPr lang="en-US" dirty="0" err="1" smtClean="0">
-                <a:sym typeface="Wingdings" panose="05000000000000000000" pitchFamily="2" charset="2"/>
-              </a:rPr>
-              <a:t>Rosmaster_Lib</a:t>
-            </a:r>
-            <a:r>
-              <a:rPr lang="en-US" dirty="0" smtClean="0">
-                <a:sym typeface="Wingdings" panose="05000000000000000000" pitchFamily="2" charset="2"/>
-              </a:rPr>
-              <a:t> directly, which makes it output status lines over and over:</a:t>
-            </a:r>
-          </a:p>
-          <a:p>
-            <a:pPr lvl="1"/>
-            <a:r>
-              <a:rPr lang="en-US" dirty="0" smtClean="0">
-                <a:sym typeface="Wingdings" panose="05000000000000000000" pitchFamily="2" charset="2"/>
-              </a:rPr>
-              <a:t>python3 </a:t>
-            </a:r>
-            <a:r>
-              <a:rPr lang="en-US" smtClean="0">
-                <a:sym typeface="Wingdings" panose="05000000000000000000" pitchFamily="2" charset="2"/>
-              </a:rPr>
-              <a:t>/home/guy/py_install/Rosmaster_Lib/Rosmaster_Lib.py</a:t>
-            </a:r>
-            <a:endParaRPr lang="en-US" dirty="0" smtClean="0">
-              <a:sym typeface="Wingdings" panose="05000000000000000000" pitchFamily="2" charset="2"/>
-            </a:endParaRPr>
-          </a:p>
-          <a:p>
-            <a:r>
-              <a:rPr lang="en-US" dirty="0" smtClean="0"/>
-              <a:t>*Works on Pi </a:t>
-            </a:r>
-            <a:r>
-              <a:rPr lang="en-US" dirty="0" smtClean="0"/>
-              <a:t>5 and Windows WSL (after binding USB), </a:t>
-            </a:r>
-            <a:r>
-              <a:rPr lang="en-US" dirty="0" smtClean="0"/>
-              <a:t>but not on Jetson Orin Nano</a:t>
+          <a:bodyPr/>
+          <a:lstStyle/>
+          <a:p>
+            <a:r>
+              <a:rPr lang="en-US" dirty="0">
+                <a:hlinkClick r:id="rId2"/>
+              </a:rPr>
+              <a:t>ROS Robot Expansion Board</a:t>
             </a:r>
             <a:endParaRPr lang="en-US" dirty="0"/>
           </a:p>
@@ -4781,7 +4981,7 @@
     </p:spTree>
     <p:extLst>
       <p:ext uri="{BB962C8B-B14F-4D97-AF65-F5344CB8AC3E}">
-        <p14:creationId xmlns:p14="http://schemas.microsoft.com/office/powerpoint/2010/main" val="179385849"/>
+        <p14:creationId xmlns:p14="http://schemas.microsoft.com/office/powerpoint/2010/main" val="1348924025"/>
       </p:ext>
     </p:extLst>
   </p:cSld>
@@ -4820,211 +5020,185 @@
         </p:nvSpPr>
         <p:spPr/>
         <p:txBody>
+          <a:bodyPr/>
+          <a:lstStyle/>
+          <a:p>
+            <a:r>
+              <a:rPr lang="en-US" dirty="0" smtClean="0"/>
+              <a:t>Connecting from Linux / Pi using straight Python (the </a:t>
+            </a:r>
+            <a:r>
+              <a:rPr lang="en-US" dirty="0" err="1" smtClean="0"/>
+              <a:t>Rosmaster_Lib</a:t>
+            </a:r>
+            <a:r>
+              <a:rPr lang="en-US" dirty="0" smtClean="0"/>
+              <a:t>)</a:t>
+            </a:r>
+            <a:endParaRPr lang="en-US" dirty="0"/>
+          </a:p>
+        </p:txBody>
+      </p:sp>
+      <p:sp>
+        <p:nvSpPr>
+          <p:cNvPr id="3" name="Content Placeholder 2"/>
+          <p:cNvSpPr>
+            <a:spLocks noGrp="1"/>
+          </p:cNvSpPr>
+          <p:nvPr>
+            <p:ph idx="1"/>
+          </p:nvPr>
+        </p:nvSpPr>
+        <p:spPr/>
+        <p:txBody>
           <a:bodyPr>
-            <a:normAutofit/>
+            <a:normAutofit fontScale="47500" lnSpcReduction="20000"/>
           </a:bodyPr>
           <a:lstStyle/>
           <a:p>
-            <a:r>
-              <a:rPr lang="en-US" sz="4000" dirty="0" smtClean="0"/>
-              <a:t>Connecting from Windows Subsystem for Linux</a:t>
-            </a:r>
-            <a:endParaRPr lang="en-US" sz="4000" dirty="0"/>
-          </a:p>
-        </p:txBody>
-      </p:sp>
-      <p:sp>
-        <p:nvSpPr>
-          <p:cNvPr id="3" name="Content Placeholder 2"/>
-          <p:cNvSpPr>
-            <a:spLocks noGrp="1"/>
-          </p:cNvSpPr>
-          <p:nvPr>
-            <p:ph idx="1"/>
-          </p:nvPr>
-        </p:nvSpPr>
-        <p:spPr/>
-        <p:txBody>
-          <a:bodyPr>
-            <a:normAutofit fontScale="92500" lnSpcReduction="20000"/>
-          </a:bodyPr>
-          <a:lstStyle/>
-          <a:p>
-            <a:r>
-              <a:rPr lang="en-US" dirty="0" smtClean="0"/>
-              <a:t>Need to install a windows-side driver:</a:t>
-            </a:r>
-          </a:p>
-          <a:p>
-            <a:pPr lvl="1"/>
-            <a:r>
-              <a:rPr lang="en-US" dirty="0" err="1"/>
-              <a:t>winget</a:t>
-            </a:r>
-            <a:r>
-              <a:rPr lang="en-US" dirty="0"/>
-              <a:t> install </a:t>
-            </a:r>
-            <a:r>
-              <a:rPr lang="en-US" dirty="0" err="1" smtClean="0"/>
-              <a:t>usbipd</a:t>
-            </a:r>
-            <a:endParaRPr lang="en-US" dirty="0" smtClean="0"/>
-          </a:p>
-          <a:p>
-            <a:r>
-              <a:rPr lang="en-US" dirty="0" smtClean="0"/>
-              <a:t>Each time you (re-)connect the USB:</a:t>
-            </a:r>
-          </a:p>
-          <a:p>
-            <a:pPr lvl="1"/>
-            <a:r>
-              <a:rPr lang="en-US" dirty="0" err="1"/>
-              <a:t>usbipd</a:t>
-            </a:r>
-            <a:r>
-              <a:rPr lang="en-US" dirty="0"/>
-              <a:t> </a:t>
-            </a:r>
-            <a:r>
-              <a:rPr lang="en-US" dirty="0" smtClean="0"/>
-              <a:t>list</a:t>
-            </a:r>
-          </a:p>
-          <a:p>
-            <a:pPr lvl="2"/>
-            <a:r>
-              <a:rPr lang="en-US" dirty="0" smtClean="0"/>
-              <a:t>*From the list put in the correct bus-ID for the device you want to use in WSL:</a:t>
-            </a:r>
-          </a:p>
-          <a:p>
-            <a:pPr lvl="1"/>
-            <a:r>
-              <a:rPr lang="en-US" dirty="0" err="1"/>
-              <a:t>usbipd</a:t>
-            </a:r>
-            <a:r>
-              <a:rPr lang="en-US" dirty="0"/>
-              <a:t> bind </a:t>
-            </a:r>
-            <a:r>
-              <a:rPr lang="en-US" dirty="0" smtClean="0"/>
-              <a:t>--</a:t>
-            </a:r>
-            <a:r>
-              <a:rPr lang="en-US" dirty="0" err="1" smtClean="0"/>
-              <a:t>busid</a:t>
-            </a:r>
-            <a:r>
-              <a:rPr lang="en-US" dirty="0" smtClean="0"/>
-              <a:t> 1-3</a:t>
-            </a:r>
-          </a:p>
-          <a:p>
-            <a:pPr lvl="2"/>
-            <a:r>
-              <a:rPr lang="en-US" dirty="0" smtClean="0"/>
-              <a:t>*maybe give error, but no harm in running this twice</a:t>
-            </a:r>
-          </a:p>
-          <a:p>
-            <a:pPr lvl="1"/>
-            <a:r>
-              <a:rPr lang="en-US" dirty="0" err="1" smtClean="0"/>
-              <a:t>usbipd</a:t>
-            </a:r>
-            <a:r>
-              <a:rPr lang="en-US" dirty="0" smtClean="0"/>
-              <a:t> attach --</a:t>
-            </a:r>
-            <a:r>
-              <a:rPr lang="en-US" dirty="0" err="1" smtClean="0"/>
-              <a:t>wsl</a:t>
-            </a:r>
-            <a:r>
-              <a:rPr lang="en-US" dirty="0" smtClean="0"/>
-              <a:t> --</a:t>
-            </a:r>
-            <a:r>
-              <a:rPr lang="en-US" dirty="0" err="1" smtClean="0"/>
-              <a:t>busid</a:t>
-            </a:r>
-            <a:r>
-              <a:rPr lang="en-US" dirty="0"/>
-              <a:t> </a:t>
-            </a:r>
-            <a:r>
-              <a:rPr lang="en-US" dirty="0" smtClean="0"/>
-              <a:t>1-3</a:t>
-            </a:r>
-          </a:p>
-          <a:p>
-            <a:r>
-              <a:rPr lang="en-US" dirty="0"/>
-              <a:t>Stuff may need to be installed on the Linux side, as well</a:t>
-            </a:r>
-          </a:p>
-          <a:p>
-            <a:r>
-              <a:rPr lang="en-US" dirty="0" smtClean="0"/>
-              <a:t>In WSL to </a:t>
-            </a:r>
-            <a:r>
-              <a:rPr lang="en-US" dirty="0"/>
-              <a:t>see if it’s really connected from </a:t>
-            </a:r>
-            <a:r>
-              <a:rPr lang="en-US" dirty="0" smtClean="0"/>
-              <a:t>Windows:</a:t>
-            </a:r>
-          </a:p>
-          <a:p>
-            <a:pPr lvl="1"/>
             <a:r>
               <a:rPr lang="en-US" dirty="0" err="1" smtClean="0"/>
               <a:t>lsusb</a:t>
             </a:r>
-            <a:endParaRPr lang="en-US" dirty="0" smtClean="0"/>
+            <a:r>
+              <a:rPr lang="en-US" dirty="0" smtClean="0"/>
+              <a:t> to verify it sees the ‘</a:t>
+            </a:r>
+            <a:r>
+              <a:rPr lang="en-US" dirty="0" err="1" smtClean="0"/>
+              <a:t>QinHeng</a:t>
+            </a:r>
+            <a:r>
+              <a:rPr lang="en-US" dirty="0" smtClean="0"/>
+              <a:t>’ device plugged into USB</a:t>
+            </a:r>
+          </a:p>
+          <a:p>
+            <a:r>
+              <a:rPr lang="en-US" dirty="0" smtClean="0"/>
+              <a:t>Make /</a:t>
+            </a:r>
+            <a:r>
+              <a:rPr lang="en-US" dirty="0" err="1" smtClean="0"/>
+              <a:t>etc</a:t>
+            </a:r>
+            <a:r>
+              <a:rPr lang="en-US" dirty="0" smtClean="0"/>
+              <a:t>/</a:t>
+            </a:r>
+            <a:r>
+              <a:rPr lang="en-US" dirty="0" err="1" smtClean="0"/>
+              <a:t>udev</a:t>
+            </a:r>
+            <a:r>
+              <a:rPr lang="en-US" dirty="0" smtClean="0"/>
+              <a:t>/</a:t>
+            </a:r>
+            <a:r>
+              <a:rPr lang="en-US" dirty="0" err="1" smtClean="0"/>
+              <a:t>rules.d</a:t>
+            </a:r>
+            <a:r>
+              <a:rPr lang="en-US" dirty="0" smtClean="0"/>
+              <a:t>/</a:t>
+            </a:r>
+            <a:r>
+              <a:rPr lang="en-US" dirty="0" err="1" smtClean="0"/>
+              <a:t>myserial.rules</a:t>
+            </a:r>
+            <a:r>
+              <a:rPr lang="en-US" dirty="0" smtClean="0"/>
+              <a:t> file with:</a:t>
+            </a:r>
           </a:p>
           <a:p>
             <a:pPr lvl="1"/>
             <a:r>
-              <a:rPr lang="en-US" dirty="0" err="1" smtClean="0"/>
-              <a:t>ls</a:t>
-            </a:r>
-            <a:r>
-              <a:rPr lang="en-US" dirty="0" smtClean="0"/>
-              <a:t> -l /</a:t>
-            </a:r>
-            <a:r>
-              <a:rPr lang="en-US" dirty="0" err="1" smtClean="0"/>
-              <a:t>dev</a:t>
-            </a:r>
-            <a:r>
-              <a:rPr lang="en-US" dirty="0" smtClean="0"/>
-              <a:t>/</a:t>
+              <a:rPr lang="en-US" sz="1400" dirty="0"/>
+              <a:t>KERNEL=="</a:t>
+            </a:r>
+            <a:r>
+              <a:rPr lang="en-US" sz="1400" dirty="0" err="1"/>
+              <a:t>ttyUSB</a:t>
+            </a:r>
+            <a:r>
+              <a:rPr lang="en-US" sz="1400" dirty="0"/>
+              <a:t>*", ATTRS{</a:t>
+            </a:r>
+            <a:r>
+              <a:rPr lang="en-US" sz="1400" dirty="0" err="1"/>
+              <a:t>idVendor</a:t>
+            </a:r>
+            <a:r>
+              <a:rPr lang="en-US" sz="1400" dirty="0"/>
+              <a:t>}=="1a86", ATTRS{</a:t>
+            </a:r>
+            <a:r>
+              <a:rPr lang="en-US" sz="1400" dirty="0" err="1"/>
+              <a:t>idProduct</a:t>
+            </a:r>
+            <a:r>
+              <a:rPr lang="en-US" sz="1400" dirty="0"/>
+              <a:t>}=="7523", MODE:="0777", SYMLINK+="</a:t>
+            </a:r>
+            <a:r>
+              <a:rPr lang="en-US" sz="1400" dirty="0" err="1" smtClean="0"/>
+              <a:t>myserial</a:t>
+            </a:r>
+            <a:r>
+              <a:rPr lang="en-US" sz="1400" dirty="0" smtClean="0"/>
+              <a:t>“</a:t>
+            </a:r>
+          </a:p>
+          <a:p>
+            <a:pPr lvl="1"/>
+            <a:r>
+              <a:rPr lang="en-US" dirty="0" smtClean="0"/>
+              <a:t>'/dev/</a:t>
             </a:r>
             <a:r>
               <a:rPr lang="en-US" dirty="0" err="1" smtClean="0"/>
               <a:t>myserial</a:t>
             </a:r>
-            <a:endParaRPr lang="en-US" dirty="0" smtClean="0"/>
-          </a:p>
-          <a:p>
-            <a:pPr lvl="2"/>
-            <a:r>
-              <a:rPr lang="en-US" dirty="0" smtClean="0"/>
-              <a:t>*should show /</a:t>
+            <a:r>
+              <a:rPr lang="en-US" dirty="0" smtClean="0"/>
+              <a:t>' is what the </a:t>
             </a:r>
             <a:r>
               <a:rPr lang="en-US" dirty="0" err="1" smtClean="0"/>
-              <a:t>dev</a:t>
-            </a:r>
-            <a:r>
-              <a:rPr lang="en-US" dirty="0" smtClean="0"/>
-              <a:t>/</a:t>
+              <a:t>Rosmaster</a:t>
+            </a:r>
+            <a:r>
+              <a:rPr lang="en-US" dirty="0" smtClean="0"/>
+              <a:t> bot constructer uses to connect</a:t>
+            </a:r>
+          </a:p>
+          <a:p>
+            <a:r>
+              <a:rPr lang="en-US" dirty="0" smtClean="0"/>
+              <a:t>It should have these permissions: -</a:t>
+            </a:r>
+            <a:r>
+              <a:rPr lang="en-US" dirty="0" err="1" smtClean="0"/>
+              <a:t>rwxr</a:t>
+            </a:r>
+            <a:r>
+              <a:rPr lang="en-US" dirty="0" smtClean="0"/>
+              <a:t>-</a:t>
+            </a:r>
+            <a:r>
+              <a:rPr lang="en-US" dirty="0" err="1" smtClean="0"/>
+              <a:t>xr</a:t>
+            </a:r>
+            <a:r>
+              <a:rPr lang="en-US" dirty="0" smtClean="0"/>
+              <a:t>-x</a:t>
+            </a:r>
+          </a:p>
+          <a:p>
+            <a:r>
+              <a:rPr lang="en-US" dirty="0" smtClean="0"/>
+              <a:t>ls -l /dev/</a:t>
             </a:r>
             <a:r>
               <a:rPr lang="en-US" dirty="0" err="1" smtClean="0"/>
@@ -5032,24 +5206,253 @@
             </a:r>
             <a:r>
               <a:rPr lang="en-US" dirty="0" smtClean="0"/>
+              <a:t> should show the link: /dev/</a:t>
+            </a:r>
+            <a:r>
+              <a:rPr lang="en-US" dirty="0" err="1" smtClean="0"/>
+              <a:t>myserial</a:t>
+            </a:r>
+            <a:r>
+              <a:rPr lang="en-US" dirty="0" smtClean="0"/>
               <a:t> </a:t>
             </a:r>
             <a:r>
               <a:rPr lang="en-US" dirty="0" smtClean="0">
                 <a:sym typeface="Wingdings" panose="05000000000000000000" pitchFamily="2" charset="2"/>
               </a:rPr>
-              <a:t> ttyUSB0  symbolic link</a:t>
-            </a:r>
-            <a:endParaRPr lang="en-US" dirty="0" smtClean="0"/>
-          </a:p>
-          <a:p>
-            <a:endParaRPr lang="en-US" dirty="0"/>
-          </a:p>
-          <a:p>
-            <a:endParaRPr lang="en-US" dirty="0" smtClean="0"/>
+              <a:t> ttyUSB0</a:t>
+            </a:r>
+          </a:p>
+          <a:p>
+            <a:r>
+              <a:rPr lang="en-US" dirty="0" smtClean="0">
+                <a:sym typeface="Wingdings" panose="05000000000000000000" pitchFamily="2" charset="2"/>
+              </a:rPr>
+              <a:t>Install </a:t>
+            </a:r>
+            <a:r>
+              <a:rPr lang="en-US" dirty="0" err="1" smtClean="0">
+                <a:sym typeface="Wingdings" panose="05000000000000000000" pitchFamily="2" charset="2"/>
+              </a:rPr>
+              <a:t>Rosmaster</a:t>
+            </a:r>
+            <a:r>
+              <a:rPr lang="en-US" dirty="0" smtClean="0">
+                <a:sym typeface="Wingdings" panose="05000000000000000000" pitchFamily="2" charset="2"/>
+              </a:rPr>
+              <a:t> library from code from downloaded py_install.zip:</a:t>
+            </a:r>
           </a:p>
           <a:p>
             <a:pPr lvl="1"/>
+            <a:r>
+              <a:rPr lang="en-US" dirty="0" smtClean="0">
+                <a:sym typeface="Wingdings" panose="05000000000000000000" pitchFamily="2" charset="2"/>
+              </a:rPr>
+              <a:t>cd </a:t>
+            </a:r>
+            <a:r>
+              <a:rPr lang="en-US" dirty="0" err="1" smtClean="0">
+                <a:sym typeface="Wingdings" panose="05000000000000000000" pitchFamily="2" charset="2"/>
+              </a:rPr>
+              <a:t>py_install</a:t>
+            </a:r>
+            <a:endParaRPr lang="en-US" dirty="0" smtClean="0">
+              <a:sym typeface="Wingdings" panose="05000000000000000000" pitchFamily="2" charset="2"/>
+            </a:endParaRPr>
+          </a:p>
+          <a:p>
+            <a:pPr lvl="1"/>
+            <a:r>
+              <a:rPr lang="en-US" dirty="0" err="1" smtClean="0">
+                <a:sym typeface="Wingdings" panose="05000000000000000000" pitchFamily="2" charset="2"/>
+              </a:rPr>
+              <a:t>sudo</a:t>
+            </a:r>
+            <a:r>
+              <a:rPr lang="en-US" dirty="0" smtClean="0">
+                <a:sym typeface="Wingdings" panose="05000000000000000000" pitchFamily="2" charset="2"/>
+              </a:rPr>
+              <a:t> python3 setup.py install</a:t>
+            </a:r>
+          </a:p>
+          <a:p>
+            <a:pPr lvl="1"/>
+            <a:r>
+              <a:rPr lang="en-US" dirty="0" smtClean="0">
+                <a:sym typeface="Wingdings" panose="05000000000000000000" pitchFamily="2" charset="2"/>
+              </a:rPr>
+              <a:t>*Might also have to re-install the serial library</a:t>
+            </a:r>
+          </a:p>
+          <a:p>
+            <a:pPr lvl="2"/>
+            <a:r>
+              <a:rPr lang="en-US" dirty="0" err="1" smtClean="0">
+                <a:sym typeface="Wingdings" panose="05000000000000000000" pitchFamily="2" charset="2"/>
+              </a:rPr>
+              <a:t>sudo</a:t>
+            </a:r>
+            <a:r>
+              <a:rPr lang="en-US" dirty="0" smtClean="0">
+                <a:sym typeface="Wingdings" panose="05000000000000000000" pitchFamily="2" charset="2"/>
+              </a:rPr>
+              <a:t> pip3 uninstall serial</a:t>
+            </a:r>
+          </a:p>
+          <a:p>
+            <a:pPr lvl="2"/>
+            <a:r>
+              <a:rPr lang="en-US" dirty="0" err="1" smtClean="0">
+                <a:sym typeface="Wingdings" panose="05000000000000000000" pitchFamily="2" charset="2"/>
+              </a:rPr>
+              <a:t>sudo</a:t>
+            </a:r>
+            <a:r>
+              <a:rPr lang="en-US" dirty="0" smtClean="0">
+                <a:sym typeface="Wingdings" panose="05000000000000000000" pitchFamily="2" charset="2"/>
+              </a:rPr>
+              <a:t> pip3 install </a:t>
+            </a:r>
+            <a:r>
+              <a:rPr lang="en-US" dirty="0" err="1" smtClean="0">
+                <a:sym typeface="Wingdings" panose="05000000000000000000" pitchFamily="2" charset="2"/>
+              </a:rPr>
+              <a:t>pyserial</a:t>
+            </a:r>
+            <a:endParaRPr lang="en-US" dirty="0" smtClean="0">
+              <a:sym typeface="Wingdings" panose="05000000000000000000" pitchFamily="2" charset="2"/>
+            </a:endParaRPr>
+          </a:p>
+          <a:p>
+            <a:r>
+              <a:rPr lang="en-US" dirty="0" smtClean="0">
+                <a:sym typeface="Wingdings" panose="05000000000000000000" pitchFamily="2" charset="2"/>
+              </a:rPr>
+              <a:t>Then you can execute in python:</a:t>
+            </a:r>
+          </a:p>
+          <a:p>
+            <a:pPr lvl="1"/>
+            <a:r>
+              <a:rPr lang="en-US" dirty="0" smtClean="0">
+                <a:sym typeface="Wingdings" panose="05000000000000000000" pitchFamily="2" charset="2"/>
+              </a:rPr>
+              <a:t>from </a:t>
+            </a:r>
+            <a:r>
+              <a:rPr lang="en-US" dirty="0" err="1" smtClean="0">
+                <a:sym typeface="Wingdings" panose="05000000000000000000" pitchFamily="2" charset="2"/>
+              </a:rPr>
+              <a:t>Rosmaster_Lib</a:t>
+            </a:r>
+            <a:r>
+              <a:rPr lang="en-US" dirty="0" smtClean="0">
+                <a:sym typeface="Wingdings" panose="05000000000000000000" pitchFamily="2" charset="2"/>
+              </a:rPr>
+              <a:t> import </a:t>
+            </a:r>
+            <a:r>
+              <a:rPr lang="en-US" dirty="0" err="1" smtClean="0">
+                <a:sym typeface="Wingdings" panose="05000000000000000000" pitchFamily="2" charset="2"/>
+              </a:rPr>
+              <a:t>Rosmaster</a:t>
+            </a:r>
+            <a:endParaRPr lang="en-US" dirty="0" smtClean="0">
+              <a:sym typeface="Wingdings" panose="05000000000000000000" pitchFamily="2" charset="2"/>
+            </a:endParaRPr>
+          </a:p>
+          <a:p>
+            <a:pPr lvl="1"/>
+            <a:r>
+              <a:rPr lang="en-US" dirty="0" smtClean="0">
+                <a:sym typeface="Wingdings" panose="05000000000000000000" pitchFamily="2" charset="2"/>
+              </a:rPr>
+              <a:t>bot = </a:t>
+            </a:r>
+            <a:r>
+              <a:rPr lang="en-US" dirty="0" err="1" smtClean="0">
+                <a:sym typeface="Wingdings" panose="05000000000000000000" pitchFamily="2" charset="2"/>
+              </a:rPr>
+              <a:t>Rosmaster</a:t>
+            </a:r>
+            <a:r>
+              <a:rPr lang="en-US" dirty="0" smtClean="0">
+                <a:sym typeface="Wingdings" panose="05000000000000000000" pitchFamily="2" charset="2"/>
+              </a:rPr>
+              <a:t>()</a:t>
+            </a:r>
+          </a:p>
+          <a:p>
+            <a:pPr lvl="1"/>
+            <a:r>
+              <a:rPr lang="en-US" dirty="0" err="1" smtClean="0">
+                <a:sym typeface="Wingdings" panose="05000000000000000000" pitchFamily="2" charset="2"/>
+              </a:rPr>
+              <a:t>bot.set_motor</a:t>
+            </a:r>
+            <a:r>
+              <a:rPr lang="en-US" dirty="0" smtClean="0">
+                <a:sym typeface="Wingdings" panose="05000000000000000000" pitchFamily="2" charset="2"/>
+              </a:rPr>
+              <a:t>(50,0,0,0)</a:t>
+            </a:r>
+          </a:p>
+          <a:p>
+            <a:pPr lvl="1"/>
+            <a:r>
+              <a:rPr lang="en-US" dirty="0" err="1">
+                <a:sym typeface="Wingdings" panose="05000000000000000000" pitchFamily="2" charset="2"/>
+              </a:rPr>
+              <a:t>b</a:t>
+            </a:r>
+            <a:r>
+              <a:rPr lang="en-US" dirty="0" err="1" smtClean="0">
+                <a:sym typeface="Wingdings" panose="05000000000000000000" pitchFamily="2" charset="2"/>
+              </a:rPr>
+              <a:t>ot.set_beep</a:t>
+            </a:r>
+            <a:r>
+              <a:rPr lang="en-US" dirty="0" smtClean="0">
+                <a:sym typeface="Wingdings" panose="05000000000000000000" pitchFamily="2" charset="2"/>
+              </a:rPr>
+              <a:t>(100)</a:t>
+            </a:r>
+          </a:p>
+          <a:p>
+            <a:r>
+              <a:rPr lang="en-US" dirty="0" smtClean="0">
+                <a:sym typeface="Wingdings" panose="05000000000000000000" pitchFamily="2" charset="2"/>
+              </a:rPr>
+              <a:t>You can also call the </a:t>
+            </a:r>
+            <a:r>
+              <a:rPr lang="en-US" dirty="0" err="1" smtClean="0">
+                <a:sym typeface="Wingdings" panose="05000000000000000000" pitchFamily="2" charset="2"/>
+              </a:rPr>
+              <a:t>Rosmaster_Lib</a:t>
+            </a:r>
+            <a:r>
+              <a:rPr lang="en-US" dirty="0" smtClean="0">
+                <a:sym typeface="Wingdings" panose="05000000000000000000" pitchFamily="2" charset="2"/>
+              </a:rPr>
+              <a:t> directly, which makes it output status lines over and over:</a:t>
+            </a:r>
+          </a:p>
+          <a:p>
+            <a:pPr lvl="1"/>
+            <a:r>
+              <a:rPr lang="en-US" dirty="0" smtClean="0">
+                <a:sym typeface="Wingdings" panose="05000000000000000000" pitchFamily="2" charset="2"/>
+              </a:rPr>
+              <a:t>python3 /home/guy/py_install/Rosmaster_Lib/Rosmaster_Lib.py</a:t>
+            </a:r>
+          </a:p>
+          <a:p>
+            <a:r>
+              <a:rPr lang="en-US" dirty="0" smtClean="0"/>
+              <a:t>*Works on Pi 5 and Windows WSL (after binding USB), but not on Jetson Orin Nano</a:t>
+            </a:r>
             <a:endParaRPr lang="en-US" dirty="0"/>
           </a:p>
         </p:txBody>
@@ -5057,7 +5460,7 @@
     </p:spTree>
     <p:extLst>
       <p:ext uri="{BB962C8B-B14F-4D97-AF65-F5344CB8AC3E}">
-        <p14:creationId xmlns:p14="http://schemas.microsoft.com/office/powerpoint/2010/main" val="1648913703"/>
+        <p14:creationId xmlns:p14="http://schemas.microsoft.com/office/powerpoint/2010/main" val="179385849"/>
       </p:ext>
     </p:extLst>
   </p:cSld>
@@ -5096,59 +5499,267 @@
         </p:nvSpPr>
         <p:spPr/>
         <p:txBody>
-          <a:bodyPr/>
-          <a:lstStyle/>
-          <a:p>
-            <a:r>
-              <a:rPr lang="en-US" dirty="0" smtClean="0"/>
-              <a:t>Installing ROS2 in Linux</a:t>
-            </a:r>
+          <a:bodyPr>
+            <a:normAutofit/>
+          </a:bodyPr>
+          <a:lstStyle/>
+          <a:p>
+            <a:r>
+              <a:rPr lang="en-US" sz="4000" dirty="0" smtClean="0"/>
+              <a:t>Connecting from Windows Subsystem for Linux</a:t>
+            </a:r>
+            <a:endParaRPr lang="en-US" sz="4000" dirty="0"/>
+          </a:p>
+        </p:txBody>
+      </p:sp>
+      <p:sp>
+        <p:nvSpPr>
+          <p:cNvPr id="3" name="Content Placeholder 2"/>
+          <p:cNvSpPr>
+            <a:spLocks noGrp="1"/>
+          </p:cNvSpPr>
+          <p:nvPr>
+            <p:ph idx="1"/>
+          </p:nvPr>
+        </p:nvSpPr>
+        <p:spPr/>
+        <p:txBody>
+          <a:bodyPr>
+            <a:normAutofit fontScale="77500" lnSpcReduction="20000"/>
+          </a:bodyPr>
+          <a:lstStyle/>
+          <a:p>
+            <a:r>
+              <a:rPr lang="en-US" dirty="0" smtClean="0"/>
+              <a:t>Need to install a windows-side driver (in non-Linux command line):</a:t>
+            </a:r>
+          </a:p>
+          <a:p>
+            <a:pPr lvl="1"/>
+            <a:r>
+              <a:rPr lang="en-US" dirty="0" err="1"/>
+              <a:t>winget</a:t>
+            </a:r>
+            <a:r>
+              <a:rPr lang="en-US" dirty="0"/>
+              <a:t> install </a:t>
+            </a:r>
+            <a:r>
+              <a:rPr lang="en-US" dirty="0" err="1" smtClean="0"/>
+              <a:t>usbipd</a:t>
+            </a:r>
+            <a:endParaRPr lang="en-US" dirty="0" smtClean="0"/>
+          </a:p>
+          <a:p>
+            <a:r>
+              <a:rPr lang="en-US" dirty="0" smtClean="0"/>
+              <a:t>Each time you (re-)connect the USB:</a:t>
+            </a:r>
+          </a:p>
+          <a:p>
+            <a:pPr lvl="1"/>
+            <a:r>
+              <a:rPr lang="en-US" dirty="0" err="1"/>
+              <a:t>usbipd</a:t>
+            </a:r>
+            <a:r>
+              <a:rPr lang="en-US" dirty="0"/>
+              <a:t> </a:t>
+            </a:r>
+            <a:r>
+              <a:rPr lang="en-US" dirty="0" smtClean="0"/>
+              <a:t>list</a:t>
+            </a:r>
+          </a:p>
+          <a:p>
+            <a:pPr lvl="2"/>
+            <a:r>
+              <a:rPr lang="en-US" dirty="0" smtClean="0"/>
+              <a:t>Should show a ‘USB-SERIAL CH340’ for the ROS board</a:t>
+            </a:r>
+          </a:p>
+          <a:p>
+            <a:pPr lvl="2"/>
+            <a:r>
+              <a:rPr lang="en-US" dirty="0" smtClean="0"/>
+              <a:t>*From the list put in the correct bus-ID for the device you want to use in WSL:</a:t>
+            </a:r>
+          </a:p>
+          <a:p>
+            <a:pPr lvl="1"/>
+            <a:r>
+              <a:rPr lang="en-US" dirty="0" err="1"/>
+              <a:t>usbipd</a:t>
+            </a:r>
+            <a:r>
+              <a:rPr lang="en-US" dirty="0"/>
+              <a:t> bind </a:t>
+            </a:r>
+            <a:r>
+              <a:rPr lang="en-US" dirty="0" smtClean="0"/>
+              <a:t>--</a:t>
+            </a:r>
+            <a:r>
+              <a:rPr lang="en-US" dirty="0" err="1" smtClean="0"/>
+              <a:t>busid</a:t>
+            </a:r>
+            <a:r>
+              <a:rPr lang="en-US" dirty="0" smtClean="0"/>
+              <a:t> 1-3</a:t>
+            </a:r>
+          </a:p>
+          <a:p>
+            <a:pPr lvl="2"/>
+            <a:r>
+              <a:rPr lang="en-US" dirty="0" smtClean="0"/>
+              <a:t>*maybe give error, but no harm in running this twice</a:t>
+            </a:r>
+          </a:p>
+          <a:p>
+            <a:pPr lvl="1"/>
+            <a:r>
+              <a:rPr lang="en-US" dirty="0" err="1" smtClean="0"/>
+              <a:t>usbipd</a:t>
+            </a:r>
+            <a:r>
+              <a:rPr lang="en-US" dirty="0" smtClean="0"/>
+              <a:t> attach --</a:t>
+            </a:r>
+            <a:r>
+              <a:rPr lang="en-US" dirty="0" err="1" smtClean="0"/>
+              <a:t>wsl</a:t>
+            </a:r>
+            <a:r>
+              <a:rPr lang="en-US" dirty="0" smtClean="0"/>
+              <a:t> --</a:t>
+            </a:r>
+            <a:r>
+              <a:rPr lang="en-US" dirty="0" err="1" smtClean="0"/>
+              <a:t>busid</a:t>
+            </a:r>
+            <a:r>
+              <a:rPr lang="en-US" dirty="0"/>
+              <a:t> </a:t>
+            </a:r>
+            <a:r>
+              <a:rPr lang="en-US" dirty="0" smtClean="0"/>
+              <a:t>1-3</a:t>
+            </a:r>
+          </a:p>
+          <a:p>
+            <a:r>
+              <a:rPr lang="en-US" dirty="0"/>
+              <a:t>Stuff may need to be installed on the Linux side, as well</a:t>
+            </a:r>
+          </a:p>
+          <a:p>
+            <a:r>
+              <a:rPr lang="en-US" dirty="0" smtClean="0"/>
+              <a:t>In WSL to </a:t>
+            </a:r>
+            <a:r>
+              <a:rPr lang="en-US" dirty="0"/>
+              <a:t>see if it’s really connected from </a:t>
+            </a:r>
+            <a:r>
+              <a:rPr lang="en-US" dirty="0" smtClean="0"/>
+              <a:t>Windows:</a:t>
+            </a:r>
+          </a:p>
+          <a:p>
+            <a:pPr lvl="1"/>
+            <a:r>
+              <a:rPr lang="en-US" dirty="0" err="1" smtClean="0"/>
+              <a:t>lsusb</a:t>
+            </a:r>
+            <a:endParaRPr lang="en-US" dirty="0" smtClean="0"/>
+          </a:p>
+          <a:p>
+            <a:pPr lvl="2"/>
+            <a:r>
+              <a:rPr lang="en-US" dirty="0"/>
+              <a:t>should show: Bus 001 Device 002: ID 1a86:7523 </a:t>
+            </a:r>
+            <a:r>
+              <a:rPr lang="en-US" dirty="0" err="1"/>
+              <a:t>QinHeng</a:t>
+            </a:r>
+            <a:r>
+              <a:rPr lang="en-US" dirty="0"/>
+              <a:t> Electronics CH340 serial converter </a:t>
+            </a:r>
+            <a:endParaRPr lang="en-US" dirty="0" smtClean="0"/>
+          </a:p>
+          <a:p>
+            <a:pPr lvl="1"/>
+            <a:r>
+              <a:rPr lang="en-US" dirty="0" err="1" smtClean="0"/>
+              <a:t>ls</a:t>
+            </a:r>
+            <a:r>
+              <a:rPr lang="en-US" dirty="0" smtClean="0"/>
+              <a:t> -l /</a:t>
+            </a:r>
+            <a:r>
+              <a:rPr lang="en-US" dirty="0" err="1" smtClean="0"/>
+              <a:t>dev</a:t>
+            </a:r>
+            <a:r>
+              <a:rPr lang="en-US" dirty="0" smtClean="0"/>
+              <a:t>/</a:t>
+            </a:r>
+            <a:r>
+              <a:rPr lang="en-US" dirty="0" err="1" smtClean="0"/>
+              <a:t>myserial</a:t>
+            </a:r>
+            <a:endParaRPr lang="en-US" dirty="0" smtClean="0"/>
+          </a:p>
+          <a:p>
+            <a:pPr lvl="2"/>
+            <a:r>
+              <a:rPr lang="en-US" dirty="0" smtClean="0"/>
+              <a:t>*should show /</a:t>
+            </a:r>
+            <a:r>
+              <a:rPr lang="en-US" dirty="0" err="1" smtClean="0"/>
+              <a:t>dev</a:t>
+            </a:r>
+            <a:r>
+              <a:rPr lang="en-US" dirty="0" smtClean="0"/>
+              <a:t>/</a:t>
+            </a:r>
+            <a:r>
+              <a:rPr lang="en-US" dirty="0" err="1" smtClean="0"/>
+              <a:t>myserial</a:t>
+            </a:r>
+            <a:r>
+              <a:rPr lang="en-US" dirty="0" smtClean="0"/>
+              <a:t> </a:t>
+            </a:r>
+            <a:r>
+              <a:rPr lang="en-US" dirty="0" smtClean="0">
+                <a:sym typeface="Wingdings" panose="05000000000000000000" pitchFamily="2" charset="2"/>
+              </a:rPr>
+              <a:t> ttyUSB0  symbolic link</a:t>
+            </a:r>
+            <a:endParaRPr lang="en-US" dirty="0" smtClean="0"/>
+          </a:p>
+          <a:p>
             <a:endParaRPr lang="en-US" dirty="0"/>
           </a:p>
-        </p:txBody>
-      </p:sp>
-      <p:sp>
-        <p:nvSpPr>
-          <p:cNvPr id="3" name="Content Placeholder 2"/>
-          <p:cNvSpPr>
-            <a:spLocks noGrp="1"/>
-          </p:cNvSpPr>
-          <p:nvPr>
-            <p:ph idx="1"/>
-          </p:nvPr>
-        </p:nvSpPr>
-        <p:spPr/>
-        <p:txBody>
-          <a:bodyPr/>
-          <a:lstStyle/>
-          <a:p>
-            <a:r>
-              <a:rPr lang="en-US" dirty="0">
-                <a:hlinkClick r:id="rId2"/>
-              </a:rPr>
-              <a:t>https://</a:t>
-            </a:r>
-            <a:r>
-              <a:rPr lang="en-US" dirty="0" smtClean="0">
-                <a:hlinkClick r:id="rId2"/>
-              </a:rPr>
-              <a:t>www.yahboom.net/study/ROS-Driver-Board</a:t>
-            </a:r>
+          <a:p>
             <a:endParaRPr lang="en-US" dirty="0" smtClean="0"/>
           </a:p>
           <a:p>
             <a:pPr lvl="1"/>
-            <a:r>
-              <a:rPr lang="en-US" dirty="0" smtClean="0"/>
-              <a:t>Under ‘ROS2 Basic Course’ – ‘ROS2 install Humble’</a:t>
-            </a:r>
+            <a:endParaRPr lang="en-US" dirty="0"/>
           </a:p>
         </p:txBody>
       </p:sp>
     </p:spTree>
     <p:extLst>
       <p:ext uri="{BB962C8B-B14F-4D97-AF65-F5344CB8AC3E}">
-        <p14:creationId xmlns:p14="http://schemas.microsoft.com/office/powerpoint/2010/main" val="1024456953"/>
+        <p14:creationId xmlns:p14="http://schemas.microsoft.com/office/powerpoint/2010/main" val="1648913703"/>
       </p:ext>
     </p:extLst>
   </p:cSld>
@@ -5191,8 +5802,8 @@
           <a:lstStyle/>
           <a:p>
             <a:r>
-              <a:rPr lang="en-US" sz="4000" dirty="0" smtClean="0"/>
-              <a:t>Testing the ROS2 install with the Turtle simulator</a:t>
+              <a:rPr lang="en-US" dirty="0" smtClean="0"/>
+              <a:t>Control motors and movement</a:t>
             </a:r>
             <a:endParaRPr lang="en-US" dirty="0"/>
           </a:p>
@@ -5214,124 +5825,110 @@
           <a:lstStyle/>
           <a:p>
             <a:r>
-              <a:rPr lang="en-US" dirty="0" smtClean="0"/>
-              <a:t>Run in separate terminals:</a:t>
+              <a:rPr lang="en-US" dirty="0" smtClean="0">
+                <a:sym typeface="Wingdings" panose="05000000000000000000" pitchFamily="2" charset="2"/>
+              </a:rPr>
+              <a:t>Set motor speed directly:</a:t>
             </a:r>
           </a:p>
           <a:p>
             <a:pPr lvl="1"/>
             <a:r>
-              <a:rPr lang="en-US" dirty="0" smtClean="0"/>
-              <a:t># Always source first:</a:t>
-            </a:r>
+              <a:rPr lang="en-US" dirty="0" smtClean="0">
+                <a:sym typeface="Wingdings" panose="05000000000000000000" pitchFamily="2" charset="2"/>
+              </a:rPr>
+              <a:t>from </a:t>
+            </a:r>
+            <a:r>
+              <a:rPr lang="en-US" dirty="0" err="1">
+                <a:sym typeface="Wingdings" panose="05000000000000000000" pitchFamily="2" charset="2"/>
+              </a:rPr>
+              <a:t>Rosmaster_Lib</a:t>
+            </a:r>
+            <a:r>
+              <a:rPr lang="en-US" dirty="0">
+                <a:sym typeface="Wingdings" panose="05000000000000000000" pitchFamily="2" charset="2"/>
+              </a:rPr>
+              <a:t> import </a:t>
+            </a:r>
+            <a:r>
+              <a:rPr lang="en-US" dirty="0" err="1">
+                <a:sym typeface="Wingdings" panose="05000000000000000000" pitchFamily="2" charset="2"/>
+              </a:rPr>
+              <a:t>Rosmaster</a:t>
+            </a:r>
+            <a:endParaRPr lang="en-US" dirty="0">
+              <a:sym typeface="Wingdings" panose="05000000000000000000" pitchFamily="2" charset="2"/>
+            </a:endParaRPr>
           </a:p>
           <a:p>
             <a:pPr lvl="1"/>
             <a:r>
-              <a:rPr lang="en-US" dirty="0"/>
-              <a:t>source /opt/</a:t>
-            </a:r>
-            <a:r>
-              <a:rPr lang="en-US" dirty="0" err="1"/>
-              <a:t>ros</a:t>
-            </a:r>
-            <a:r>
-              <a:rPr lang="en-US" dirty="0"/>
-              <a:t>/humble/</a:t>
-            </a:r>
-            <a:r>
-              <a:rPr lang="en-US" dirty="0" err="1"/>
-              <a:t>setup.bash</a:t>
-            </a:r>
-            <a:endParaRPr lang="en-US" dirty="0"/>
+              <a:rPr lang="en-US" dirty="0">
+                <a:sym typeface="Wingdings" panose="05000000000000000000" pitchFamily="2" charset="2"/>
+              </a:rPr>
+              <a:t>bot = </a:t>
+            </a:r>
+            <a:r>
+              <a:rPr lang="en-US" dirty="0" err="1">
+                <a:sym typeface="Wingdings" panose="05000000000000000000" pitchFamily="2" charset="2"/>
+              </a:rPr>
+              <a:t>Rosmaster</a:t>
+            </a:r>
+            <a:r>
+              <a:rPr lang="en-US" dirty="0">
+                <a:sym typeface="Wingdings" panose="05000000000000000000" pitchFamily="2" charset="2"/>
+              </a:rPr>
+              <a:t>()</a:t>
+            </a:r>
           </a:p>
           <a:p>
             <a:pPr lvl="1"/>
             <a:r>
-              <a:rPr lang="en-US" dirty="0" smtClean="0"/>
-              <a:t># Run ros2 w/turtle simulator</a:t>
+              <a:rPr lang="en-US" dirty="0" err="1">
+                <a:sym typeface="Wingdings" panose="05000000000000000000" pitchFamily="2" charset="2"/>
+              </a:rPr>
+              <a:t>bot.set_motor</a:t>
+            </a:r>
+            <a:r>
+              <a:rPr lang="en-US" dirty="0">
+                <a:sym typeface="Wingdings" panose="05000000000000000000" pitchFamily="2" charset="2"/>
+              </a:rPr>
+              <a:t>(50,0,0,0)</a:t>
             </a:r>
           </a:p>
           <a:p>
             <a:pPr lvl="1"/>
             <a:r>
-              <a:rPr lang="en-US" dirty="0" smtClean="0"/>
-              <a:t>ros2 </a:t>
-            </a:r>
-            <a:r>
-              <a:rPr lang="en-US" dirty="0"/>
-              <a:t>run </a:t>
-            </a:r>
-            <a:r>
-              <a:rPr lang="en-US" dirty="0" err="1"/>
-              <a:t>turtlesim</a:t>
-            </a:r>
-            <a:r>
-              <a:rPr lang="en-US" dirty="0"/>
-              <a:t> </a:t>
-            </a:r>
-            <a:r>
-              <a:rPr lang="en-US" dirty="0" err="1" smtClean="0"/>
-              <a:t>turtlesim_node</a:t>
-            </a:r>
-            <a:endParaRPr lang="en-US" dirty="0" smtClean="0"/>
-          </a:p>
-          <a:p>
-            <a:pPr lvl="1"/>
-            <a:r>
-              <a:rPr lang="en-US" dirty="0" smtClean="0"/>
-              <a:t># Control the turtle with the keyboard:</a:t>
-            </a:r>
-          </a:p>
-          <a:p>
-            <a:pPr lvl="1"/>
-            <a:r>
-              <a:rPr lang="en-US" dirty="0" smtClean="0"/>
-              <a:t>ros2 </a:t>
-            </a:r>
-            <a:r>
-              <a:rPr lang="en-US" dirty="0"/>
-              <a:t>run </a:t>
-            </a:r>
-            <a:r>
-              <a:rPr lang="en-US" dirty="0" err="1"/>
-              <a:t>turtlesim</a:t>
-            </a:r>
-            <a:r>
-              <a:rPr lang="en-US" dirty="0"/>
-              <a:t> </a:t>
-            </a:r>
-            <a:r>
-              <a:rPr lang="en-US" dirty="0" err="1" smtClean="0"/>
-              <a:t>turtle_teleop_key</a:t>
-            </a:r>
-            <a:endParaRPr lang="en-US" dirty="0" smtClean="0"/>
-          </a:p>
-          <a:p>
-            <a:pPr lvl="1"/>
-            <a:r>
-              <a:rPr lang="en-US" dirty="0" smtClean="0"/>
-              <a:t># Get telemetry info:</a:t>
-            </a:r>
-          </a:p>
-          <a:p>
-            <a:pPr lvl="1"/>
-            <a:r>
-              <a:rPr lang="en-US" dirty="0"/>
-              <a:t>ros2 topic echo /turtle1/</a:t>
-            </a:r>
-            <a:r>
-              <a:rPr lang="en-US" dirty="0" err="1"/>
-              <a:t>cmd_vel</a:t>
-            </a:r>
-            <a:endParaRPr lang="en-US" dirty="0"/>
+              <a:rPr lang="en-US" dirty="0" err="1" smtClean="0">
+                <a:sym typeface="Wingdings" panose="05000000000000000000" pitchFamily="2" charset="2"/>
+              </a:rPr>
+              <a:t>bot.set_beep</a:t>
+            </a:r>
+            <a:r>
+              <a:rPr lang="en-US" dirty="0" smtClean="0">
+                <a:sym typeface="Wingdings" panose="05000000000000000000" pitchFamily="2" charset="2"/>
+              </a:rPr>
+              <a:t>(100)</a:t>
+            </a:r>
+          </a:p>
+          <a:p>
+            <a:r>
+              <a:rPr lang="en-US" dirty="0" smtClean="0">
+                <a:sym typeface="Wingdings" panose="05000000000000000000" pitchFamily="2" charset="2"/>
+              </a:rPr>
+              <a:t>Hmmm…</a:t>
+            </a:r>
+            <a:endParaRPr lang="en-US" dirty="0">
+              <a:sym typeface="Wingdings" panose="05000000000000000000" pitchFamily="2" charset="2"/>
+            </a:endParaRPr>
           </a:p>
         </p:txBody>
       </p:sp>
     </p:spTree>
     <p:extLst>
       <p:ext uri="{BB962C8B-B14F-4D97-AF65-F5344CB8AC3E}">
-        <p14:creationId xmlns:p14="http://schemas.microsoft.com/office/powerpoint/2010/main" val="49954300"/>
+        <p14:creationId xmlns:p14="http://schemas.microsoft.com/office/powerpoint/2010/main" val="3687948443"/>
       </p:ext>
     </p:extLst>
   </p:cSld>

</xml_diff>